<commit_message>
Align competition deck with locked title
</commit_message>
<xml_diff>
--- a/docs/MEACompass_Competition_Deck_WORKING.pptx
+++ b/docs/MEACompass_Competition_Deck_WORKING.pptx
@@ -2,24 +2,24 @@
 <file path=ppt/presentation.xml><?xml version="1.0" encoding="utf-8"?>
 <p:presentation xmlns:p="http://schemas.openxmlformats.org/presentationml/2006/main">
   <p:sldMasterIdLst>
-    <p:sldMasterId xmlns:r="http://schemas.openxmlformats.org/officeDocument/2006/relationships" id="2147483648" r:id="R4aab4e12c1194689"/>
+    <p:sldMasterId xmlns:r="http://schemas.openxmlformats.org/officeDocument/2006/relationships" id="2147483648" r:id="Ra7c56639b18f4f3e"/>
   </p:sldMasterIdLst>
   <p:notesMasterIdLst>
-    <p:notesMasterId xmlns:r="http://schemas.openxmlformats.org/officeDocument/2006/relationships" r:id="R8ea4a0a244424164"/>
+    <p:notesMasterId xmlns:r="http://schemas.openxmlformats.org/officeDocument/2006/relationships" r:id="Rccf6a55e61914aed"/>
   </p:notesMasterIdLst>
   <p:sldIdLst>
-    <p:sldId xmlns:r="http://schemas.openxmlformats.org/officeDocument/2006/relationships" id="256" r:id="R936c9fbbde67486b"/>
-    <p:sldId xmlns:r="http://schemas.openxmlformats.org/officeDocument/2006/relationships" id="257" r:id="R6ae3736c40b14923"/>
-    <p:sldId xmlns:r="http://schemas.openxmlformats.org/officeDocument/2006/relationships" id="258" r:id="Rb1cf95cd4d0f458d"/>
-    <p:sldId xmlns:r="http://schemas.openxmlformats.org/officeDocument/2006/relationships" id="259" r:id="R06b3d9a977ef4941"/>
-    <p:sldId xmlns:r="http://schemas.openxmlformats.org/officeDocument/2006/relationships" id="260" r:id="R026ab24894eb4b30"/>
-    <p:sldId xmlns:r="http://schemas.openxmlformats.org/officeDocument/2006/relationships" id="261" r:id="Rea624b1ccf164324"/>
-    <p:sldId xmlns:r="http://schemas.openxmlformats.org/officeDocument/2006/relationships" id="262" r:id="R40a5a20b1cc146c8"/>
-    <p:sldId xmlns:r="http://schemas.openxmlformats.org/officeDocument/2006/relationships" id="263" r:id="R51cb59e6d4bc4d80"/>
-    <p:sldId xmlns:r="http://schemas.openxmlformats.org/officeDocument/2006/relationships" id="264" r:id="Rd1a45bb0159d4594"/>
-    <p:sldId xmlns:r="http://schemas.openxmlformats.org/officeDocument/2006/relationships" id="265" r:id="R3c52376e02d048ce"/>
-    <p:sldId xmlns:r="http://schemas.openxmlformats.org/officeDocument/2006/relationships" id="266" r:id="Racac10aabfd041e4"/>
-    <p:sldId xmlns:r="http://schemas.openxmlformats.org/officeDocument/2006/relationships" id="267" r:id="Rfcc31c62731b4808"/>
+    <p:sldId xmlns:r="http://schemas.openxmlformats.org/officeDocument/2006/relationships" id="256" r:id="R0b69fb44b725426f"/>
+    <p:sldId xmlns:r="http://schemas.openxmlformats.org/officeDocument/2006/relationships" id="257" r:id="R580c6355d2304e0d"/>
+    <p:sldId xmlns:r="http://schemas.openxmlformats.org/officeDocument/2006/relationships" id="258" r:id="Re29aa1ce60cd4b9e"/>
+    <p:sldId xmlns:r="http://schemas.openxmlformats.org/officeDocument/2006/relationships" id="259" r:id="Ra0d9b05d9c484c83"/>
+    <p:sldId xmlns:r="http://schemas.openxmlformats.org/officeDocument/2006/relationships" id="260" r:id="R022d530202aa4bb2"/>
+    <p:sldId xmlns:r="http://schemas.openxmlformats.org/officeDocument/2006/relationships" id="261" r:id="Rc12b877ffc214c6f"/>
+    <p:sldId xmlns:r="http://schemas.openxmlformats.org/officeDocument/2006/relationships" id="262" r:id="R021beab6f2054e2c"/>
+    <p:sldId xmlns:r="http://schemas.openxmlformats.org/officeDocument/2006/relationships" id="263" r:id="Rf013b8e00cb54ae7"/>
+    <p:sldId xmlns:r="http://schemas.openxmlformats.org/officeDocument/2006/relationships" id="264" r:id="R70bf5f2687e94591"/>
+    <p:sldId xmlns:r="http://schemas.openxmlformats.org/officeDocument/2006/relationships" id="265" r:id="Rc2d53566aa5e4ea0"/>
+    <p:sldId xmlns:r="http://schemas.openxmlformats.org/officeDocument/2006/relationships" id="266" r:id="Rbb4dc3df67c349bd"/>
+    <p:sldId xmlns:r="http://schemas.openxmlformats.org/officeDocument/2006/relationships" id="267" r:id="Radfa495f8b4d4f60"/>
   </p:sldIdLst>
   <p:sldSz cx="12192000" cy="6858000"/>
   <p:notesSz cx="6858000" cy="9144000"/>
@@ -1292,7 +1292,7 @@
   </p:cSld>
   <p:clrMap bg1="lt1" tx1="dk1" bg2="lt2" tx2="dk2" accent1="accent1" accent2="accent2" accent3="accent3" accent4="accent4" accent5="accent5" accent6="accent6" hlink="hlink" folHlink="folHlink"/>
   <p:sldLayoutIdLst>
-    <p:sldLayoutId xmlns:r="http://schemas.openxmlformats.org/officeDocument/2006/relationships" id="2147483649" r:id="R125f20743a644e2a"/>
+    <p:sldLayoutId xmlns:r="http://schemas.openxmlformats.org/officeDocument/2006/relationships" id="2147483649" r:id="Rbb5dfde6686d414d"/>
   </p:sldLayoutIdLst>
   <p:txStyles>
     <p:titleStyle>
@@ -1598,7 +1598,7 @@
           <p:cNvPr id="1" name="kicker-marker">
             <a:extLst xmlns:a="http://schemas.openxmlformats.org/drawingml/2006/main">
               <a:ext uri="{FF2B5EF4-FFF2-40B4-BE49-F238E27FC236}">
-                <a16:creationId xmlns:a16="http://schemas.microsoft.com/office/drawing/2014/main" id="{1E7703A3-4E05-49AE-BED0-4BEC23D8F2FC}"/>
+                <a16:creationId xmlns:a16="http://schemas.microsoft.com/office/drawing/2014/main" id="{784025B0-2406-4436-948C-07A044BAC816}"/>
               </a:ext>
             </a:extLst>
           </p:cNvPr>
@@ -1633,7 +1633,7 @@
           <p:cNvPr id="2" name="kicker-label">
             <a:extLst xmlns:a="http://schemas.openxmlformats.org/drawingml/2006/main">
               <a:ext uri="{FF2B5EF4-FFF2-40B4-BE49-F238E27FC236}">
-                <a16:creationId xmlns:a16="http://schemas.microsoft.com/office/drawing/2014/main" id="{1DEF3A72-B586-41E0-8890-D3A10C2E4068}"/>
+                <a16:creationId xmlns:a16="http://schemas.microsoft.com/office/drawing/2014/main" id="{0F58A607-2200-4E59-BC87-572C04026817}"/>
               </a:ext>
             </a:extLst>
           </p:cNvPr>
@@ -1680,7 +1680,7 @@
                 <a:ea typeface="Aptos"/>
                 <a:cs typeface="Aptos"/>
               </a:rPr>
-              <a:t>THE DELAY</a:t>
+              <a:t>MEACOMPASS</a:t>
             </a:r>
           </a:p>
         </p:txBody>
@@ -1690,7 +1690,7 @@
           <p:cNvPr id="3" name="">
             <a:extLst xmlns:a="http://schemas.openxmlformats.org/drawingml/2006/main">
               <a:ext uri="{FF2B5EF4-FFF2-40B4-BE49-F238E27FC236}">
-                <a16:creationId xmlns:a16="http://schemas.microsoft.com/office/drawing/2014/main" id="{16EFCCE1-5D39-4A81-ACBE-3CC53E6CC92C}"/>
+                <a16:creationId xmlns:a16="http://schemas.microsoft.com/office/drawing/2014/main" id="{1172ED2F-AE50-47C7-A9B9-4DAD0D596A95}"/>
               </a:ext>
             </a:extLst>
           </p:cNvPr>
@@ -1737,7 +1737,7 @@
                 <a:ea typeface="Georgia"/>
                 <a:cs typeface="Georgia"/>
               </a:rPr>
-              <a:t>The useful endpoint arrives at DIV12. Triage should not wait blindly.</a:t>
+              <a:t>Reliability-Aware Early Prediction of Neural Network Development from Microelectrode-Array Assays</a:t>
             </a:r>
           </a:p>
         </p:txBody>
@@ -1747,7 +1747,64 @@
           <p:cNvPr id="4" name="">
             <a:extLst xmlns:a="http://schemas.openxmlformats.org/drawingml/2006/main">
               <a:ext uri="{FF2B5EF4-FFF2-40B4-BE49-F238E27FC236}">
-                <a16:creationId xmlns:a16="http://schemas.microsoft.com/office/drawing/2014/main" id="{E5344ED5-0F96-41A9-AFB6-2D1FA3575311}"/>
+                <a16:creationId xmlns:a16="http://schemas.microsoft.com/office/drawing/2014/main" id="{EF44CA94-BE09-4983-A45C-050641541CF8}"/>
+              </a:ext>
+            </a:extLst>
+          </p:cNvPr>
+          <p:cNvSpPr>
+            <a:spLocks xmlns:a="http://schemas.openxmlformats.org/drawingml/2006/main" noGrp="1"/>
+          </p:cNvSpPr>
+          <p:nvPr/>
+        </p:nvSpPr>
+        <p:spPr>
+          <a:xfrm xmlns:a="http://schemas.openxmlformats.org/drawingml/2006/main">
+            <a:off x="590550" y="1457325"/>
+            <a:ext cx="10668000" cy="333375"/>
+          </a:xfrm>
+          <a:prstGeom xmlns:a="http://schemas.openxmlformats.org/drawingml/2006/main" prst="rect">
+            <a:avLst/>
+          </a:prstGeom>
+        </p:spPr>
+        <p:txBody>
+          <a:bodyPr xmlns:a="http://schemas.openxmlformats.org/drawingml/2006/main" wrap="square" lIns="0" tIns="0" rIns="0" bIns="0" anchor="t">
+            <a:normAutofit fontScale="100000"/>
+          </a:bodyPr>
+          <a:lstStyle xmlns:a="http://schemas.openxmlformats.org/drawingml/2006/main"/>
+          <a:p xmlns:a="http://schemas.openxmlformats.org/drawingml/2006/main">
+            <a:pPr algn="l">
+              <a:lnSpc>
+                <a:spcPct val="100000"/>
+              </a:lnSpc>
+              <a:buNone/>
+              <a:defRPr sz="975" b="0">
+                <a:solidFill>
+                  <a:srgbClr val="B8C3C9"/>
+                </a:solidFill>
+                <a:latin typeface="Aptos"/>
+                <a:ea typeface="Aptos"/>
+                <a:cs typeface="Aptos"/>
+              </a:defRPr>
+            </a:pPr>
+            <a:r>
+              <a:rPr sz="975" b="0">
+                <a:solidFill>
+                  <a:srgbClr val="B8C3C9"/>
+                </a:solidFill>
+                <a:latin typeface="Aptos"/>
+                <a:ea typeface="Aptos"/>
+                <a:cs typeface="Aptos"/>
+              </a:rPr>
+              <a:t>Toward Functional Digital Twins for Neural Organ-on-Chip Screening</a:t>
+            </a:r>
+          </a:p>
+        </p:txBody>
+      </p:sp>
+      <p:sp>
+        <p:nvSpPr>
+          <p:cNvPr id="5" name="">
+            <a:extLst xmlns:a="http://schemas.openxmlformats.org/drawingml/2006/main">
+              <a:ext uri="{FF2B5EF4-FFF2-40B4-BE49-F238E27FC236}">
+                <a16:creationId xmlns:a16="http://schemas.microsoft.com/office/drawing/2014/main" id="{878F2B70-1CDB-4F00-8538-6C491F181170}"/>
               </a:ext>
             </a:extLst>
           </p:cNvPr>
@@ -1779,10 +1836,10 @@
       </p:sp>
       <p:sp>
         <p:nvSpPr>
-          <p:cNvPr id="5" name="">
-            <a:extLst xmlns:a="http://schemas.openxmlformats.org/drawingml/2006/main">
-              <a:ext uri="{FF2B5EF4-FFF2-40B4-BE49-F238E27FC236}">
-                <a16:creationId xmlns:a16="http://schemas.microsoft.com/office/drawing/2014/main" id="{F6383930-011E-4BB3-BB21-382722C7F543}"/>
+          <p:cNvPr id="6" name="">
+            <a:extLst xmlns:a="http://schemas.openxmlformats.org/drawingml/2006/main">
+              <a:ext uri="{FF2B5EF4-FFF2-40B4-BE49-F238E27FC236}">
+                <a16:creationId xmlns:a16="http://schemas.microsoft.com/office/drawing/2014/main" id="{7AB87D2E-E444-4006-AD34-DA1330714413}"/>
               </a:ext>
             </a:extLst>
           </p:cNvPr>
@@ -1836,10 +1893,10 @@
       </p:sp>
       <p:sp>
         <p:nvSpPr>
-          <p:cNvPr id="6" name="">
-            <a:extLst xmlns:a="http://schemas.openxmlformats.org/drawingml/2006/main">
-              <a:ext uri="{FF2B5EF4-FFF2-40B4-BE49-F238E27FC236}">
-                <a16:creationId xmlns:a16="http://schemas.microsoft.com/office/drawing/2014/main" id="{6D720282-38D7-41AF-8977-61D0B0B51914}"/>
+          <p:cNvPr id="7" name="">
+            <a:extLst xmlns:a="http://schemas.openxmlformats.org/drawingml/2006/main">
+              <a:ext uri="{FF2B5EF4-FFF2-40B4-BE49-F238E27FC236}">
+                <a16:creationId xmlns:a16="http://schemas.microsoft.com/office/drawing/2014/main" id="{1D0D93D1-E0EE-42B1-A535-766179C88161}"/>
               </a:ext>
             </a:extLst>
           </p:cNvPr>
@@ -1893,22 +1950,22 @@
       </p:sp>
       <p:sp>
         <p:nvSpPr>
-          <p:cNvPr id="7" name="">
-            <a:extLst xmlns:a="http://schemas.openxmlformats.org/drawingml/2006/main">
-              <a:ext uri="{FF2B5EF4-FFF2-40B4-BE49-F238E27FC236}">
-                <a16:creationId xmlns:a16="http://schemas.microsoft.com/office/drawing/2014/main" id="{8AB06B98-3C9A-409E-8C53-5450B8F12183}"/>
-              </a:ext>
-            </a:extLst>
-          </p:cNvPr>
-          <p:cNvSpPr>
-            <a:spLocks xmlns:a="http://schemas.openxmlformats.org/drawingml/2006/main" noGrp="1"/>
-          </p:cNvSpPr>
-          <p:nvPr/>
-        </p:nvSpPr>
-        <p:spPr>
-          <a:xfrm xmlns:a="http://schemas.openxmlformats.org/drawingml/2006/main">
-            <a:off x="590550" y="1562100"/>
-            <a:ext cx="8763000" cy="333375"/>
+          <p:cNvPr id="8" name="">
+            <a:extLst xmlns:a="http://schemas.openxmlformats.org/drawingml/2006/main">
+              <a:ext uri="{FF2B5EF4-FFF2-40B4-BE49-F238E27FC236}">
+                <a16:creationId xmlns:a16="http://schemas.microsoft.com/office/drawing/2014/main" id="{4EAA02A1-B82B-4080-9CAF-8802FE507786}"/>
+              </a:ext>
+            </a:extLst>
+          </p:cNvPr>
+          <p:cNvSpPr>
+            <a:spLocks xmlns:a="http://schemas.openxmlformats.org/drawingml/2006/main" noGrp="1"/>
+          </p:cNvSpPr>
+          <p:nvPr/>
+        </p:nvSpPr>
+        <p:spPr>
+          <a:xfrm xmlns:a="http://schemas.openxmlformats.org/drawingml/2006/main">
+            <a:off x="590550" y="1857375"/>
+            <a:ext cx="8763000" cy="323850"/>
           </a:xfrm>
           <a:prstGeom xmlns:a="http://schemas.openxmlformats.org/drawingml/2006/main" prst="rect">
             <a:avLst/>
@@ -1925,35 +1982,35 @@
                 <a:spcPct val="100000"/>
               </a:lnSpc>
               <a:buNone/>
-              <a:defRPr sz="1050" b="0">
-                <a:solidFill>
-                  <a:srgbClr val="B8C3C9"/>
-                </a:solidFill>
-                <a:latin typeface="Aptos"/>
-                <a:ea typeface="Aptos"/>
-                <a:cs typeface="Aptos"/>
-              </a:defRPr>
-            </a:pPr>
-            <a:r>
-              <a:rPr sz="1050" b="0">
-                <a:solidFill>
-                  <a:srgbClr val="B8C3C9"/>
-                </a:solidFill>
-                <a:latin typeface="Aptos"/>
-                <a:ea typeface="Aptos"/>
-                <a:cs typeface="Aptos"/>
-              </a:rPr>
-              <a:t>Rat cortical neural network formation is measured over days—not in a single snapshot.</a:t>
-            </a:r>
-          </a:p>
-        </p:txBody>
-      </p:sp>
-      <p:sp>
-        <p:nvSpPr>
-          <p:cNvPr id="8" name="">
-            <a:extLst xmlns:a="http://schemas.openxmlformats.org/drawingml/2006/main">
-              <a:ext uri="{FF2B5EF4-FFF2-40B4-BE49-F238E27FC236}">
-                <a16:creationId xmlns:a16="http://schemas.microsoft.com/office/drawing/2014/main" id="{BD9991EB-4EDF-431A-9F12-4B02937C3859}"/>
+              <a:defRPr sz="1275" b="1">
+                <a:solidFill>
+                  <a:srgbClr val="FFFFFF"/>
+                </a:solidFill>
+                <a:latin typeface="Georgia"/>
+                <a:ea typeface="Georgia"/>
+                <a:cs typeface="Georgia"/>
+              </a:defRPr>
+            </a:pPr>
+            <a:r>
+              <a:rPr sz="1275" b="1">
+                <a:solidFill>
+                  <a:srgbClr val="FFFFFF"/>
+                </a:solidFill>
+                <a:latin typeface="Georgia"/>
+                <a:ea typeface="Georgia"/>
+                <a:cs typeface="Georgia"/>
+              </a:rPr>
+              <a:t>The useful endpoint arrives at DIV12. Triage should not wait blindly.</a:t>
+            </a:r>
+          </a:p>
+        </p:txBody>
+      </p:sp>
+      <p:sp>
+        <p:nvSpPr>
+          <p:cNvPr id="9" name="">
+            <a:extLst xmlns:a="http://schemas.openxmlformats.org/drawingml/2006/main">
+              <a:ext uri="{FF2B5EF4-FFF2-40B4-BE49-F238E27FC236}">
+                <a16:creationId xmlns:a16="http://schemas.microsoft.com/office/drawing/2014/main" id="{652076C8-7D39-4E29-BEF5-C476E1C50964}"/>
               </a:ext>
             </a:extLst>
           </p:cNvPr>
@@ -1985,10 +2042,10 @@
       </p:sp>
       <p:sp>
         <p:nvSpPr>
-          <p:cNvPr id="9" name="">
-            <a:extLst xmlns:a="http://schemas.openxmlformats.org/drawingml/2006/main">
-              <a:ext uri="{FF2B5EF4-FFF2-40B4-BE49-F238E27FC236}">
-                <a16:creationId xmlns:a16="http://schemas.microsoft.com/office/drawing/2014/main" id="{280F52F1-131E-4ACC-A517-70C89E6A6E43}"/>
+          <p:cNvPr id="10" name="">
+            <a:extLst xmlns:a="http://schemas.openxmlformats.org/drawingml/2006/main">
+              <a:ext uri="{FF2B5EF4-FFF2-40B4-BE49-F238E27FC236}">
+                <a16:creationId xmlns:a16="http://schemas.microsoft.com/office/drawing/2014/main" id="{AC2EF137-D6F7-4D2E-AEBD-798F37ACB6D4}"/>
               </a:ext>
             </a:extLst>
           </p:cNvPr>
@@ -2020,10 +2077,10 @@
       </p:sp>
       <p:sp>
         <p:nvSpPr>
-          <p:cNvPr id="10" name="">
-            <a:extLst xmlns:a="http://schemas.openxmlformats.org/drawingml/2006/main">
-              <a:ext uri="{FF2B5EF4-FFF2-40B4-BE49-F238E27FC236}">
-                <a16:creationId xmlns:a16="http://schemas.microsoft.com/office/drawing/2014/main" id="{BAAF0FE8-D658-432C-AD13-3EF47F414BB9}"/>
+          <p:cNvPr id="11" name="">
+            <a:extLst xmlns:a="http://schemas.openxmlformats.org/drawingml/2006/main">
+              <a:ext uri="{FF2B5EF4-FFF2-40B4-BE49-F238E27FC236}">
+                <a16:creationId xmlns:a16="http://schemas.microsoft.com/office/drawing/2014/main" id="{ED3E1FB5-B492-4BD1-8A3B-D6E9EAB21D37}"/>
               </a:ext>
             </a:extLst>
           </p:cNvPr>
@@ -2077,10 +2134,10 @@
       </p:sp>
       <p:sp>
         <p:nvSpPr>
-          <p:cNvPr id="11" name="">
-            <a:extLst xmlns:a="http://schemas.openxmlformats.org/drawingml/2006/main">
-              <a:ext uri="{FF2B5EF4-FFF2-40B4-BE49-F238E27FC236}">
-                <a16:creationId xmlns:a16="http://schemas.microsoft.com/office/drawing/2014/main" id="{DAF87E51-8B22-41E2-A2D0-8B02739DAA95}"/>
+          <p:cNvPr id="12" name="">
+            <a:extLst xmlns:a="http://schemas.openxmlformats.org/drawingml/2006/main">
+              <a:ext uri="{FF2B5EF4-FFF2-40B4-BE49-F238E27FC236}">
+                <a16:creationId xmlns:a16="http://schemas.microsoft.com/office/drawing/2014/main" id="{604CD673-C561-4898-8BA0-6D9750136337}"/>
               </a:ext>
             </a:extLst>
           </p:cNvPr>
@@ -2112,10 +2169,10 @@
       </p:sp>
       <p:sp>
         <p:nvSpPr>
-          <p:cNvPr id="12" name="">
-            <a:extLst xmlns:a="http://schemas.openxmlformats.org/drawingml/2006/main">
-              <a:ext uri="{FF2B5EF4-FFF2-40B4-BE49-F238E27FC236}">
-                <a16:creationId xmlns:a16="http://schemas.microsoft.com/office/drawing/2014/main" id="{D86E4751-92A1-4D9A-A64A-1A2C343A5F72}"/>
+          <p:cNvPr id="13" name="">
+            <a:extLst xmlns:a="http://schemas.openxmlformats.org/drawingml/2006/main">
+              <a:ext uri="{FF2B5EF4-FFF2-40B4-BE49-F238E27FC236}">
+                <a16:creationId xmlns:a16="http://schemas.microsoft.com/office/drawing/2014/main" id="{2AD7132B-2610-454D-909C-7311B49275E6}"/>
               </a:ext>
             </a:extLst>
           </p:cNvPr>
@@ -2147,10 +2204,10 @@
       </p:sp>
       <p:sp>
         <p:nvSpPr>
-          <p:cNvPr id="13" name="">
-            <a:extLst xmlns:a="http://schemas.openxmlformats.org/drawingml/2006/main">
-              <a:ext uri="{FF2B5EF4-FFF2-40B4-BE49-F238E27FC236}">
-                <a16:creationId xmlns:a16="http://schemas.microsoft.com/office/drawing/2014/main" id="{7AF60DA5-EB6F-4BAD-BC0F-FA28B8FF9804}"/>
+          <p:cNvPr id="14" name="">
+            <a:extLst xmlns:a="http://schemas.openxmlformats.org/drawingml/2006/main">
+              <a:ext uri="{FF2B5EF4-FFF2-40B4-BE49-F238E27FC236}">
+                <a16:creationId xmlns:a16="http://schemas.microsoft.com/office/drawing/2014/main" id="{3EB7BC88-C0E9-4354-934E-50867E0DAC8A}"/>
               </a:ext>
             </a:extLst>
           </p:cNvPr>
@@ -2204,10 +2261,10 @@
       </p:sp>
       <p:sp>
         <p:nvSpPr>
-          <p:cNvPr id="14" name="">
-            <a:extLst xmlns:a="http://schemas.openxmlformats.org/drawingml/2006/main">
-              <a:ext uri="{FF2B5EF4-FFF2-40B4-BE49-F238E27FC236}">
-                <a16:creationId xmlns:a16="http://schemas.microsoft.com/office/drawing/2014/main" id="{5A2DDB72-AE81-48CF-9E1B-872848F22C07}"/>
+          <p:cNvPr id="15" name="">
+            <a:extLst xmlns:a="http://schemas.openxmlformats.org/drawingml/2006/main">
+              <a:ext uri="{FF2B5EF4-FFF2-40B4-BE49-F238E27FC236}">
+                <a16:creationId xmlns:a16="http://schemas.microsoft.com/office/drawing/2014/main" id="{4D897C00-B42D-4182-B7CC-D4FB6F03A6B3}"/>
               </a:ext>
             </a:extLst>
           </p:cNvPr>
@@ -2239,10 +2296,10 @@
       </p:sp>
       <p:sp>
         <p:nvSpPr>
-          <p:cNvPr id="15" name="">
-            <a:extLst xmlns:a="http://schemas.openxmlformats.org/drawingml/2006/main">
-              <a:ext uri="{FF2B5EF4-FFF2-40B4-BE49-F238E27FC236}">
-                <a16:creationId xmlns:a16="http://schemas.microsoft.com/office/drawing/2014/main" id="{C1EB8979-97FE-44FF-B08D-E69BE3F51B24}"/>
+          <p:cNvPr id="16" name="">
+            <a:extLst xmlns:a="http://schemas.openxmlformats.org/drawingml/2006/main">
+              <a:ext uri="{FF2B5EF4-FFF2-40B4-BE49-F238E27FC236}">
+                <a16:creationId xmlns:a16="http://schemas.microsoft.com/office/drawing/2014/main" id="{49F9B804-8152-4912-8E68-B1A0C8542FC5}"/>
               </a:ext>
             </a:extLst>
           </p:cNvPr>
@@ -2274,10 +2331,10 @@
       </p:sp>
       <p:sp>
         <p:nvSpPr>
-          <p:cNvPr id="16" name="">
-            <a:extLst xmlns:a="http://schemas.openxmlformats.org/drawingml/2006/main">
-              <a:ext uri="{FF2B5EF4-FFF2-40B4-BE49-F238E27FC236}">
-                <a16:creationId xmlns:a16="http://schemas.microsoft.com/office/drawing/2014/main" id="{60354B12-E9D7-4C6D-BBF1-1897B3104DCC}"/>
+          <p:cNvPr id="17" name="">
+            <a:extLst xmlns:a="http://schemas.openxmlformats.org/drawingml/2006/main">
+              <a:ext uri="{FF2B5EF4-FFF2-40B4-BE49-F238E27FC236}">
+                <a16:creationId xmlns:a16="http://schemas.microsoft.com/office/drawing/2014/main" id="{73A3819C-990D-4BD8-9E4D-6DB8019F74C4}"/>
               </a:ext>
             </a:extLst>
           </p:cNvPr>
@@ -2331,10 +2388,10 @@
       </p:sp>
       <p:sp>
         <p:nvSpPr>
-          <p:cNvPr id="17" name="">
-            <a:extLst xmlns:a="http://schemas.openxmlformats.org/drawingml/2006/main">
-              <a:ext uri="{FF2B5EF4-FFF2-40B4-BE49-F238E27FC236}">
-                <a16:creationId xmlns:a16="http://schemas.microsoft.com/office/drawing/2014/main" id="{3C2A291B-09CC-4C89-9280-DEBA35C67DAD}"/>
+          <p:cNvPr id="18" name="">
+            <a:extLst xmlns:a="http://schemas.openxmlformats.org/drawingml/2006/main">
+              <a:ext uri="{FF2B5EF4-FFF2-40B4-BE49-F238E27FC236}">
+                <a16:creationId xmlns:a16="http://schemas.microsoft.com/office/drawing/2014/main" id="{FE180F7E-7EF4-4283-83A3-123DF977EFA1}"/>
               </a:ext>
             </a:extLst>
           </p:cNvPr>
@@ -2366,10 +2423,10 @@
       </p:sp>
       <p:sp>
         <p:nvSpPr>
-          <p:cNvPr id="18" name="">
-            <a:extLst xmlns:a="http://schemas.openxmlformats.org/drawingml/2006/main">
-              <a:ext uri="{FF2B5EF4-FFF2-40B4-BE49-F238E27FC236}">
-                <a16:creationId xmlns:a16="http://schemas.microsoft.com/office/drawing/2014/main" id="{28F169D8-CBCA-40D6-9932-E091707B6371}"/>
+          <p:cNvPr id="19" name="">
+            <a:extLst xmlns:a="http://schemas.openxmlformats.org/drawingml/2006/main">
+              <a:ext uri="{FF2B5EF4-FFF2-40B4-BE49-F238E27FC236}">
+                <a16:creationId xmlns:a16="http://schemas.microsoft.com/office/drawing/2014/main" id="{36936016-6E8C-44BF-8713-2C9BD97E8FF6}"/>
               </a:ext>
             </a:extLst>
           </p:cNvPr>
@@ -2423,10 +2480,10 @@
       </p:sp>
       <p:sp>
         <p:nvSpPr>
-          <p:cNvPr id="19" name="">
-            <a:extLst xmlns:a="http://schemas.openxmlformats.org/drawingml/2006/main">
-              <a:ext uri="{FF2B5EF4-FFF2-40B4-BE49-F238E27FC236}">
-                <a16:creationId xmlns:a16="http://schemas.microsoft.com/office/drawing/2014/main" id="{55C792D4-7593-424D-BADA-3CF19AF756A9}"/>
+          <p:cNvPr id="20" name="">
+            <a:extLst xmlns:a="http://schemas.openxmlformats.org/drawingml/2006/main">
+              <a:ext uri="{FF2B5EF4-FFF2-40B4-BE49-F238E27FC236}">
+                <a16:creationId xmlns:a16="http://schemas.microsoft.com/office/drawing/2014/main" id="{5319B3E2-F734-46F5-9A78-B91F416F8E6A}"/>
               </a:ext>
             </a:extLst>
           </p:cNvPr>
@@ -2480,10 +2537,10 @@
       </p:sp>
       <p:sp>
         <p:nvSpPr>
-          <p:cNvPr id="20" name="">
-            <a:extLst xmlns:a="http://schemas.openxmlformats.org/drawingml/2006/main">
-              <a:ext uri="{FF2B5EF4-FFF2-40B4-BE49-F238E27FC236}">
-                <a16:creationId xmlns:a16="http://schemas.microsoft.com/office/drawing/2014/main" id="{EA4ADF04-1D6D-449B-BC7B-3C7F80241192}"/>
+          <p:cNvPr id="21" name="">
+            <a:extLst xmlns:a="http://schemas.openxmlformats.org/drawingml/2006/main">
+              <a:ext uri="{FF2B5EF4-FFF2-40B4-BE49-F238E27FC236}">
+                <a16:creationId xmlns:a16="http://schemas.microsoft.com/office/drawing/2014/main" id="{915C09DE-26B1-4399-8CC4-BE7D0DA3F931}"/>
               </a:ext>
             </a:extLst>
           </p:cNvPr>
@@ -2537,10 +2594,10 @@
       </p:sp>
       <p:sp>
         <p:nvSpPr>
-          <p:cNvPr id="21" name="">
-            <a:extLst xmlns:a="http://schemas.openxmlformats.org/drawingml/2006/main">
-              <a:ext uri="{FF2B5EF4-FFF2-40B4-BE49-F238E27FC236}">
-                <a16:creationId xmlns:a16="http://schemas.microsoft.com/office/drawing/2014/main" id="{A3392379-98E7-433A-A6C3-20E95217AECC}"/>
+          <p:cNvPr id="22" name="">
+            <a:extLst xmlns:a="http://schemas.openxmlformats.org/drawingml/2006/main">
+              <a:ext uri="{FF2B5EF4-FFF2-40B4-BE49-F238E27FC236}">
+                <a16:creationId xmlns:a16="http://schemas.microsoft.com/office/drawing/2014/main" id="{EE834BFC-3759-44C3-9073-2F52FC88F76D}"/>
               </a:ext>
             </a:extLst>
           </p:cNvPr>
@@ -2595,7 +2652,7 @@
     </p:spTree>
     <p:extLst>
       <p:ext uri="{BB962C8B-B14F-4D97-AF65-F5344CB8AC3E}">
-        <p14:creationId xmlns:p14="http://schemas.microsoft.com/office/powerpoint/2010/main" val="883664220"/>
+        <p14:creationId xmlns:p14="http://schemas.microsoft.com/office/powerpoint/2010/main" val="1794267242"/>
       </p:ext>
     </p:extLst>
   </p:cSld>
@@ -2626,7 +2683,7 @@
           <p:cNvPr id="1" name="kicker-marker">
             <a:extLst xmlns:a="http://schemas.openxmlformats.org/drawingml/2006/main">
               <a:ext uri="{FF2B5EF4-FFF2-40B4-BE49-F238E27FC236}">
-                <a16:creationId xmlns:a16="http://schemas.microsoft.com/office/drawing/2014/main" id="{B722D6F2-D7F0-450C-ADA4-F0D4E5C67151}"/>
+                <a16:creationId xmlns:a16="http://schemas.microsoft.com/office/drawing/2014/main" id="{30E71C84-90E2-4180-A188-78D254609402}"/>
               </a:ext>
             </a:extLst>
           </p:cNvPr>
@@ -2661,7 +2718,7 @@
           <p:cNvPr id="2" name="kicker-label">
             <a:extLst xmlns:a="http://schemas.openxmlformats.org/drawingml/2006/main">
               <a:ext uri="{FF2B5EF4-FFF2-40B4-BE49-F238E27FC236}">
-                <a16:creationId xmlns:a16="http://schemas.microsoft.com/office/drawing/2014/main" id="{918EFA40-F821-41AC-8B3B-AB73841DB56E}"/>
+                <a16:creationId xmlns:a16="http://schemas.microsoft.com/office/drawing/2014/main" id="{F6D9ED39-7EF2-4181-907C-769ECC4CDFEF}"/>
               </a:ext>
             </a:extLst>
           </p:cNvPr>
@@ -2718,7 +2775,7 @@
           <p:cNvPr id="3" name="">
             <a:extLst xmlns:a="http://schemas.openxmlformats.org/drawingml/2006/main">
               <a:ext uri="{FF2B5EF4-FFF2-40B4-BE49-F238E27FC236}">
-                <a16:creationId xmlns:a16="http://schemas.microsoft.com/office/drawing/2014/main" id="{0AE40D4C-69C1-4A38-839B-99FCE80B441D}"/>
+                <a16:creationId xmlns:a16="http://schemas.microsoft.com/office/drawing/2014/main" id="{412EF5BE-9BF1-4AAB-A66C-9960D3A7F339}"/>
               </a:ext>
             </a:extLst>
           </p:cNvPr>
@@ -2775,7 +2832,7 @@
           <p:cNvPr id="4" name="">
             <a:extLst xmlns:a="http://schemas.openxmlformats.org/drawingml/2006/main">
               <a:ext uri="{FF2B5EF4-FFF2-40B4-BE49-F238E27FC236}">
-                <a16:creationId xmlns:a16="http://schemas.microsoft.com/office/drawing/2014/main" id="{BFFA18EC-2099-43C5-A1F5-B7D894A82F7C}"/>
+                <a16:creationId xmlns:a16="http://schemas.microsoft.com/office/drawing/2014/main" id="{7F34CBE1-08E9-4A8A-8C6D-C2B38B5F649D}"/>
               </a:ext>
             </a:extLst>
           </p:cNvPr>
@@ -2810,7 +2867,7 @@
           <p:cNvPr id="5" name="">
             <a:extLst xmlns:a="http://schemas.openxmlformats.org/drawingml/2006/main">
               <a:ext uri="{FF2B5EF4-FFF2-40B4-BE49-F238E27FC236}">
-                <a16:creationId xmlns:a16="http://schemas.microsoft.com/office/drawing/2014/main" id="{CC1CB5A8-6CB6-4B31-A62B-B57AB4312948}"/>
+                <a16:creationId xmlns:a16="http://schemas.microsoft.com/office/drawing/2014/main" id="{696AD1B2-CA31-4C8A-8FA0-E33854AAB872}"/>
               </a:ext>
             </a:extLst>
           </p:cNvPr>
@@ -2867,7 +2924,7 @@
           <p:cNvPr id="6" name="">
             <a:extLst xmlns:a="http://schemas.openxmlformats.org/drawingml/2006/main">
               <a:ext uri="{FF2B5EF4-FFF2-40B4-BE49-F238E27FC236}">
-                <a16:creationId xmlns:a16="http://schemas.microsoft.com/office/drawing/2014/main" id="{E7237B12-A02E-47F4-91F6-E128D4A6AB78}"/>
+                <a16:creationId xmlns:a16="http://schemas.microsoft.com/office/drawing/2014/main" id="{3D588B89-99F3-4AF4-A434-4BBE8AC062B5}"/>
               </a:ext>
             </a:extLst>
           </p:cNvPr>
@@ -2924,7 +2981,7 @@
           <p:cNvPr id="7" name="">
             <a:extLst xmlns:a="http://schemas.openxmlformats.org/drawingml/2006/main">
               <a:ext uri="{FF2B5EF4-FFF2-40B4-BE49-F238E27FC236}">
-                <a16:creationId xmlns:a16="http://schemas.microsoft.com/office/drawing/2014/main" id="{B3192D24-FA56-4828-A034-C381BC3215EB}"/>
+                <a16:creationId xmlns:a16="http://schemas.microsoft.com/office/drawing/2014/main" id="{3535163B-00D2-4661-A96E-B45EBEFE168A}"/>
               </a:ext>
             </a:extLst>
           </p:cNvPr>
@@ -2957,7 +3014,7 @@
           <p:cNvPr id="8" name="">
             <a:extLst xmlns:a="http://schemas.openxmlformats.org/drawingml/2006/main">
               <a:ext uri="{FF2B5EF4-FFF2-40B4-BE49-F238E27FC236}">
-                <a16:creationId xmlns:a16="http://schemas.microsoft.com/office/drawing/2014/main" id="{565ACD45-8557-489F-8F2D-62DE912A3C46}"/>
+                <a16:creationId xmlns:a16="http://schemas.microsoft.com/office/drawing/2014/main" id="{8CE641FA-3995-4B1A-92DC-BCD2BE9F1485}"/>
               </a:ext>
             </a:extLst>
           </p:cNvPr>
@@ -3014,7 +3071,7 @@
           <p:cNvPr id="9" name="">
             <a:extLst xmlns:a="http://schemas.openxmlformats.org/drawingml/2006/main">
               <a:ext uri="{FF2B5EF4-FFF2-40B4-BE49-F238E27FC236}">
-                <a16:creationId xmlns:a16="http://schemas.microsoft.com/office/drawing/2014/main" id="{93184698-DFA3-4D41-8AF7-CF0F65EB25FC}"/>
+                <a16:creationId xmlns:a16="http://schemas.microsoft.com/office/drawing/2014/main" id="{9393C77F-B7A5-4F77-91D4-53A1F5C41284}"/>
               </a:ext>
             </a:extLst>
           </p:cNvPr>
@@ -3071,7 +3128,7 @@
           <p:cNvPr id="10" name="">
             <a:extLst xmlns:a="http://schemas.openxmlformats.org/drawingml/2006/main">
               <a:ext uri="{FF2B5EF4-FFF2-40B4-BE49-F238E27FC236}">
-                <a16:creationId xmlns:a16="http://schemas.microsoft.com/office/drawing/2014/main" id="{DD94959B-5F88-4970-864C-4532D2CEC7CD}"/>
+                <a16:creationId xmlns:a16="http://schemas.microsoft.com/office/drawing/2014/main" id="{1B995D57-3A4E-4DEC-82B3-F14A5A6660FA}"/>
               </a:ext>
             </a:extLst>
           </p:cNvPr>
@@ -3126,7 +3183,7 @@
     </p:spTree>
     <p:extLst>
       <p:ext uri="{BB962C8B-B14F-4D97-AF65-F5344CB8AC3E}">
-        <p14:creationId xmlns:p14="http://schemas.microsoft.com/office/powerpoint/2010/main" val="599481825"/>
+        <p14:creationId xmlns:p14="http://schemas.microsoft.com/office/powerpoint/2010/main" val="1283608826"/>
       </p:ext>
     </p:extLst>
   </p:cSld>
@@ -3157,7 +3214,7 @@
           <p:cNvPr id="1" name="kicker-marker">
             <a:extLst xmlns:a="http://schemas.openxmlformats.org/drawingml/2006/main">
               <a:ext uri="{FF2B5EF4-FFF2-40B4-BE49-F238E27FC236}">
-                <a16:creationId xmlns:a16="http://schemas.microsoft.com/office/drawing/2014/main" id="{53E457CE-9C76-45EE-80D7-C7F4F20FF399}"/>
+                <a16:creationId xmlns:a16="http://schemas.microsoft.com/office/drawing/2014/main" id="{388FBB5A-C3DD-4E30-9FB4-878AC2221FD8}"/>
               </a:ext>
             </a:extLst>
           </p:cNvPr>
@@ -3192,7 +3249,7 @@
           <p:cNvPr id="2" name="kicker-label">
             <a:extLst xmlns:a="http://schemas.openxmlformats.org/drawingml/2006/main">
               <a:ext uri="{FF2B5EF4-FFF2-40B4-BE49-F238E27FC236}">
-                <a16:creationId xmlns:a16="http://schemas.microsoft.com/office/drawing/2014/main" id="{A456AB54-E057-4B1E-AADE-254DB4335FCE}"/>
+                <a16:creationId xmlns:a16="http://schemas.microsoft.com/office/drawing/2014/main" id="{66A01CD5-1E9F-4CDF-99FF-564B9F616F6F}"/>
               </a:ext>
             </a:extLst>
           </p:cNvPr>
@@ -3249,7 +3306,7 @@
           <p:cNvPr id="3" name="">
             <a:extLst xmlns:a="http://schemas.openxmlformats.org/drawingml/2006/main">
               <a:ext uri="{FF2B5EF4-FFF2-40B4-BE49-F238E27FC236}">
-                <a16:creationId xmlns:a16="http://schemas.microsoft.com/office/drawing/2014/main" id="{9815EC25-1AFE-4E8F-8D9C-2F4F2B657032}"/>
+                <a16:creationId xmlns:a16="http://schemas.microsoft.com/office/drawing/2014/main" id="{793F1B90-E067-41AE-9CF5-365010AEFC8A}"/>
               </a:ext>
             </a:extLst>
           </p:cNvPr>
@@ -3306,7 +3363,7 @@
           <p:cNvPr id="4" name="">
             <a:extLst xmlns:a="http://schemas.openxmlformats.org/drawingml/2006/main">
               <a:ext uri="{FF2B5EF4-FFF2-40B4-BE49-F238E27FC236}">
-                <a16:creationId xmlns:a16="http://schemas.microsoft.com/office/drawing/2014/main" id="{A8978A97-4FD7-493D-BADB-121F4C52D945}"/>
+                <a16:creationId xmlns:a16="http://schemas.microsoft.com/office/drawing/2014/main" id="{77705CA0-077A-4A98-92F2-48B7928B4F63}"/>
               </a:ext>
             </a:extLst>
           </p:cNvPr>
@@ -3341,7 +3398,7 @@
           <p:cNvPr id="5" name="">
             <a:extLst xmlns:a="http://schemas.openxmlformats.org/drawingml/2006/main">
               <a:ext uri="{FF2B5EF4-FFF2-40B4-BE49-F238E27FC236}">
-                <a16:creationId xmlns:a16="http://schemas.microsoft.com/office/drawing/2014/main" id="{25E32DFA-60A4-44C1-9B08-7F85F5CEA127}"/>
+                <a16:creationId xmlns:a16="http://schemas.microsoft.com/office/drawing/2014/main" id="{875FCB99-0CD0-474D-84B3-8E09BB62B75B}"/>
               </a:ext>
             </a:extLst>
           </p:cNvPr>
@@ -3398,7 +3455,7 @@
           <p:cNvPr id="6" name="">
             <a:extLst xmlns:a="http://schemas.openxmlformats.org/drawingml/2006/main">
               <a:ext uri="{FF2B5EF4-FFF2-40B4-BE49-F238E27FC236}">
-                <a16:creationId xmlns:a16="http://schemas.microsoft.com/office/drawing/2014/main" id="{D1ABB970-C00C-4666-BCDE-E5617D87EE7B}"/>
+                <a16:creationId xmlns:a16="http://schemas.microsoft.com/office/drawing/2014/main" id="{0A336433-54DF-49B9-9BB2-C7E86BFDFFBC}"/>
               </a:ext>
             </a:extLst>
           </p:cNvPr>
@@ -3455,7 +3512,7 @@
           <p:cNvPr id="7" name="">
             <a:extLst xmlns:a="http://schemas.openxmlformats.org/drawingml/2006/main">
               <a:ext uri="{FF2B5EF4-FFF2-40B4-BE49-F238E27FC236}">
-                <a16:creationId xmlns:a16="http://schemas.microsoft.com/office/drawing/2014/main" id="{64245EF9-8FA4-4A41-A33A-0623307D3067}"/>
+                <a16:creationId xmlns:a16="http://schemas.microsoft.com/office/drawing/2014/main" id="{F6D66E3D-F61C-42CA-A91B-2194B8E4AC9D}"/>
               </a:ext>
             </a:extLst>
           </p:cNvPr>
@@ -3490,7 +3547,7 @@
           <p:cNvPr id="8" name="">
             <a:extLst xmlns:a="http://schemas.openxmlformats.org/drawingml/2006/main">
               <a:ext uri="{FF2B5EF4-FFF2-40B4-BE49-F238E27FC236}">
-                <a16:creationId xmlns:a16="http://schemas.microsoft.com/office/drawing/2014/main" id="{F971C018-E188-4CEF-A63C-72D0A3D8DA14}"/>
+                <a16:creationId xmlns:a16="http://schemas.microsoft.com/office/drawing/2014/main" id="{22C51958-3FBC-4A29-AAD2-A613A9B8E8BE}"/>
               </a:ext>
             </a:extLst>
           </p:cNvPr>
@@ -3547,7 +3604,7 @@
           <p:cNvPr id="9" name="">
             <a:extLst xmlns:a="http://schemas.openxmlformats.org/drawingml/2006/main">
               <a:ext uri="{FF2B5EF4-FFF2-40B4-BE49-F238E27FC236}">
-                <a16:creationId xmlns:a16="http://schemas.microsoft.com/office/drawing/2014/main" id="{D0B85D88-33E9-4B2C-B31C-F2A606CA92F6}"/>
+                <a16:creationId xmlns:a16="http://schemas.microsoft.com/office/drawing/2014/main" id="{1C67ADF6-0DFA-4751-92C8-D776B03856AA}"/>
               </a:ext>
             </a:extLst>
           </p:cNvPr>
@@ -3604,7 +3661,7 @@
           <p:cNvPr id="10" name="">
             <a:extLst xmlns:a="http://schemas.openxmlformats.org/drawingml/2006/main">
               <a:ext uri="{FF2B5EF4-FFF2-40B4-BE49-F238E27FC236}">
-                <a16:creationId xmlns:a16="http://schemas.microsoft.com/office/drawing/2014/main" id="{423808C8-960B-466C-ACA5-E222ABBC2F13}"/>
+                <a16:creationId xmlns:a16="http://schemas.microsoft.com/office/drawing/2014/main" id="{CC9CBA86-ABEF-46EB-A153-FE2B1AFD2ABE}"/>
               </a:ext>
             </a:extLst>
           </p:cNvPr>
@@ -3661,7 +3718,7 @@
           <p:cNvPr id="11" name="">
             <a:extLst xmlns:a="http://schemas.openxmlformats.org/drawingml/2006/main">
               <a:ext uri="{FF2B5EF4-FFF2-40B4-BE49-F238E27FC236}">
-                <a16:creationId xmlns:a16="http://schemas.microsoft.com/office/drawing/2014/main" id="{39EF6BBA-969B-4B61-BFFE-EB732330C238}"/>
+                <a16:creationId xmlns:a16="http://schemas.microsoft.com/office/drawing/2014/main" id="{B13A2216-71FD-4813-837B-23A9816EB670}"/>
               </a:ext>
             </a:extLst>
           </p:cNvPr>
@@ -3718,7 +3775,7 @@
           <p:cNvPr id="12" name="">
             <a:extLst xmlns:a="http://schemas.openxmlformats.org/drawingml/2006/main">
               <a:ext uri="{FF2B5EF4-FFF2-40B4-BE49-F238E27FC236}">
-                <a16:creationId xmlns:a16="http://schemas.microsoft.com/office/drawing/2014/main" id="{2539E4EA-CE21-4F66-9E4C-EDD2F48706FF}"/>
+                <a16:creationId xmlns:a16="http://schemas.microsoft.com/office/drawing/2014/main" id="{5FAC2A56-717F-4336-9B93-4ED99371DE0A}"/>
               </a:ext>
             </a:extLst>
           </p:cNvPr>
@@ -3775,7 +3832,7 @@
           <p:cNvPr id="13" name="">
             <a:extLst xmlns:a="http://schemas.openxmlformats.org/drawingml/2006/main">
               <a:ext uri="{FF2B5EF4-FFF2-40B4-BE49-F238E27FC236}">
-                <a16:creationId xmlns:a16="http://schemas.microsoft.com/office/drawing/2014/main" id="{E11D9962-D28F-4FFE-A039-2895E1940506}"/>
+                <a16:creationId xmlns:a16="http://schemas.microsoft.com/office/drawing/2014/main" id="{20841291-96CA-4E1A-87B4-D83973602BD2}"/>
               </a:ext>
             </a:extLst>
           </p:cNvPr>
@@ -3832,7 +3889,7 @@
           <p:cNvPr id="14" name="">
             <a:extLst xmlns:a="http://schemas.openxmlformats.org/drawingml/2006/main">
               <a:ext uri="{FF2B5EF4-FFF2-40B4-BE49-F238E27FC236}">
-                <a16:creationId xmlns:a16="http://schemas.microsoft.com/office/drawing/2014/main" id="{5B50373E-DDF9-4BBF-9027-DAF5F7D48EC8}"/>
+                <a16:creationId xmlns:a16="http://schemas.microsoft.com/office/drawing/2014/main" id="{0F4CA6F5-5D54-48E1-A994-2A78FCFCD32C}"/>
               </a:ext>
             </a:extLst>
           </p:cNvPr>
@@ -3889,7 +3946,7 @@
           <p:cNvPr id="15" name="">
             <a:extLst xmlns:a="http://schemas.openxmlformats.org/drawingml/2006/main">
               <a:ext uri="{FF2B5EF4-FFF2-40B4-BE49-F238E27FC236}">
-                <a16:creationId xmlns:a16="http://schemas.microsoft.com/office/drawing/2014/main" id="{4ACEF6F5-7947-453E-A0CB-C22036A33504}"/>
+                <a16:creationId xmlns:a16="http://schemas.microsoft.com/office/drawing/2014/main" id="{D417CD5D-E035-4607-A156-84391DD7C14D}"/>
               </a:ext>
             </a:extLst>
           </p:cNvPr>
@@ -3946,7 +4003,7 @@
           <p:cNvPr id="16" name="">
             <a:extLst xmlns:a="http://schemas.openxmlformats.org/drawingml/2006/main">
               <a:ext uri="{FF2B5EF4-FFF2-40B4-BE49-F238E27FC236}">
-                <a16:creationId xmlns:a16="http://schemas.microsoft.com/office/drawing/2014/main" id="{564CB359-4F76-49BC-B974-1AA244452BD4}"/>
+                <a16:creationId xmlns:a16="http://schemas.microsoft.com/office/drawing/2014/main" id="{C67D4889-354A-4C45-99B0-11D2FB19F40E}"/>
               </a:ext>
             </a:extLst>
           </p:cNvPr>
@@ -3979,7 +4036,7 @@
           <p:cNvPr id="17" name="">
             <a:extLst xmlns:a="http://schemas.openxmlformats.org/drawingml/2006/main">
               <a:ext uri="{FF2B5EF4-FFF2-40B4-BE49-F238E27FC236}">
-                <a16:creationId xmlns:a16="http://schemas.microsoft.com/office/drawing/2014/main" id="{74D18F2E-3DD1-45D7-A882-D5329EB694B5}"/>
+                <a16:creationId xmlns:a16="http://schemas.microsoft.com/office/drawing/2014/main" id="{48A22D2C-10AF-401C-AED2-982CE6253107}"/>
               </a:ext>
             </a:extLst>
           </p:cNvPr>
@@ -4036,7 +4093,7 @@
           <p:cNvPr id="18" name="">
             <a:extLst xmlns:a="http://schemas.openxmlformats.org/drawingml/2006/main">
               <a:ext uri="{FF2B5EF4-FFF2-40B4-BE49-F238E27FC236}">
-                <a16:creationId xmlns:a16="http://schemas.microsoft.com/office/drawing/2014/main" id="{0260AD99-6C2D-4338-9CA9-2B5DCDA62566}"/>
+                <a16:creationId xmlns:a16="http://schemas.microsoft.com/office/drawing/2014/main" id="{EFCB9CA7-C86A-4E8D-9893-6DFB6F9F31A1}"/>
               </a:ext>
             </a:extLst>
           </p:cNvPr>
@@ -4093,7 +4150,7 @@
           <p:cNvPr id="19" name="">
             <a:extLst xmlns:a="http://schemas.openxmlformats.org/drawingml/2006/main">
               <a:ext uri="{FF2B5EF4-FFF2-40B4-BE49-F238E27FC236}">
-                <a16:creationId xmlns:a16="http://schemas.microsoft.com/office/drawing/2014/main" id="{002651F3-B8C6-4C7B-A0C0-A1A974C1E3F9}"/>
+                <a16:creationId xmlns:a16="http://schemas.microsoft.com/office/drawing/2014/main" id="{BE79A1D5-6854-44C2-B01D-F087BB254401}"/>
               </a:ext>
             </a:extLst>
           </p:cNvPr>
@@ -4126,7 +4183,7 @@
           <p:cNvPr id="20" name="">
             <a:extLst xmlns:a="http://schemas.openxmlformats.org/drawingml/2006/main">
               <a:ext uri="{FF2B5EF4-FFF2-40B4-BE49-F238E27FC236}">
-                <a16:creationId xmlns:a16="http://schemas.microsoft.com/office/drawing/2014/main" id="{785FDA1C-4912-47EC-86CC-0223605BE6F0}"/>
+                <a16:creationId xmlns:a16="http://schemas.microsoft.com/office/drawing/2014/main" id="{D11936DA-62B1-488D-97AC-8686202152F5}"/>
               </a:ext>
             </a:extLst>
           </p:cNvPr>
@@ -4183,7 +4240,7 @@
           <p:cNvPr id="21" name="">
             <a:extLst xmlns:a="http://schemas.openxmlformats.org/drawingml/2006/main">
               <a:ext uri="{FF2B5EF4-FFF2-40B4-BE49-F238E27FC236}">
-                <a16:creationId xmlns:a16="http://schemas.microsoft.com/office/drawing/2014/main" id="{728C5B35-5024-4F50-A6A2-BD30C52906B5}"/>
+                <a16:creationId xmlns:a16="http://schemas.microsoft.com/office/drawing/2014/main" id="{F1195B42-A3DC-4EF6-BE94-8C55D3D3A1A5}"/>
               </a:ext>
             </a:extLst>
           </p:cNvPr>
@@ -4240,7 +4297,7 @@
           <p:cNvPr id="22" name="">
             <a:extLst xmlns:a="http://schemas.openxmlformats.org/drawingml/2006/main">
               <a:ext uri="{FF2B5EF4-FFF2-40B4-BE49-F238E27FC236}">
-                <a16:creationId xmlns:a16="http://schemas.microsoft.com/office/drawing/2014/main" id="{6115CE62-F74F-4AEC-8BFC-99628C77D330}"/>
+                <a16:creationId xmlns:a16="http://schemas.microsoft.com/office/drawing/2014/main" id="{5177D7C6-93DD-4CE9-AC49-D406C2942468}"/>
               </a:ext>
             </a:extLst>
           </p:cNvPr>
@@ -4273,7 +4330,7 @@
           <p:cNvPr id="23" name="">
             <a:extLst xmlns:a="http://schemas.openxmlformats.org/drawingml/2006/main">
               <a:ext uri="{FF2B5EF4-FFF2-40B4-BE49-F238E27FC236}">
-                <a16:creationId xmlns:a16="http://schemas.microsoft.com/office/drawing/2014/main" id="{9B29ECC9-8FD7-42C2-B2A1-8BCEFB7FF665}"/>
+                <a16:creationId xmlns:a16="http://schemas.microsoft.com/office/drawing/2014/main" id="{33CEB882-247D-403A-AD6C-9D76DF37AF9A}"/>
               </a:ext>
             </a:extLst>
           </p:cNvPr>
@@ -4330,7 +4387,7 @@
           <p:cNvPr id="24" name="">
             <a:extLst xmlns:a="http://schemas.openxmlformats.org/drawingml/2006/main">
               <a:ext uri="{FF2B5EF4-FFF2-40B4-BE49-F238E27FC236}">
-                <a16:creationId xmlns:a16="http://schemas.microsoft.com/office/drawing/2014/main" id="{4D93FD54-1B0C-487A-80EC-6B6DDFE21502}"/>
+                <a16:creationId xmlns:a16="http://schemas.microsoft.com/office/drawing/2014/main" id="{CA78DC5C-BA21-405A-8507-60E43ED8F7DF}"/>
               </a:ext>
             </a:extLst>
           </p:cNvPr>
@@ -4387,7 +4444,7 @@
           <p:cNvPr id="25" name="">
             <a:extLst xmlns:a="http://schemas.openxmlformats.org/drawingml/2006/main">
               <a:ext uri="{FF2B5EF4-FFF2-40B4-BE49-F238E27FC236}">
-                <a16:creationId xmlns:a16="http://schemas.microsoft.com/office/drawing/2014/main" id="{DFE3A452-5501-40F7-AD94-A00B8FCA15FE}"/>
+                <a16:creationId xmlns:a16="http://schemas.microsoft.com/office/drawing/2014/main" id="{188C1E4A-2830-4F52-A0BA-55C549495DD4}"/>
               </a:ext>
             </a:extLst>
           </p:cNvPr>
@@ -4420,7 +4477,7 @@
           <p:cNvPr id="26" name="">
             <a:extLst xmlns:a="http://schemas.openxmlformats.org/drawingml/2006/main">
               <a:ext uri="{FF2B5EF4-FFF2-40B4-BE49-F238E27FC236}">
-                <a16:creationId xmlns:a16="http://schemas.microsoft.com/office/drawing/2014/main" id="{D421FF9D-37A4-4EC2-AAC8-1CC87E1BB9CA}"/>
+                <a16:creationId xmlns:a16="http://schemas.microsoft.com/office/drawing/2014/main" id="{F6156B72-A8DB-4A75-B753-1FFAB8FF9BD8}"/>
               </a:ext>
             </a:extLst>
           </p:cNvPr>
@@ -4477,7 +4534,7 @@
           <p:cNvPr id="27" name="">
             <a:extLst xmlns:a="http://schemas.openxmlformats.org/drawingml/2006/main">
               <a:ext uri="{FF2B5EF4-FFF2-40B4-BE49-F238E27FC236}">
-                <a16:creationId xmlns:a16="http://schemas.microsoft.com/office/drawing/2014/main" id="{691299DA-364E-43A0-BCEB-A0A31A5692EA}"/>
+                <a16:creationId xmlns:a16="http://schemas.microsoft.com/office/drawing/2014/main" id="{31533387-F918-42DD-9DF9-25FAED1C4C5D}"/>
               </a:ext>
             </a:extLst>
           </p:cNvPr>
@@ -4534,7 +4591,7 @@
           <p:cNvPr id="28" name="">
             <a:extLst xmlns:a="http://schemas.openxmlformats.org/drawingml/2006/main">
               <a:ext uri="{FF2B5EF4-FFF2-40B4-BE49-F238E27FC236}">
-                <a16:creationId xmlns:a16="http://schemas.microsoft.com/office/drawing/2014/main" id="{2522A5D9-2929-445E-A4CF-87A572DD7BAF}"/>
+                <a16:creationId xmlns:a16="http://schemas.microsoft.com/office/drawing/2014/main" id="{BE3175AC-2932-4CED-A47D-D36F30CD1F2E}"/>
               </a:ext>
             </a:extLst>
           </p:cNvPr>
@@ -4589,7 +4646,7 @@
     </p:spTree>
     <p:extLst>
       <p:ext uri="{BB962C8B-B14F-4D97-AF65-F5344CB8AC3E}">
-        <p14:creationId xmlns:p14="http://schemas.microsoft.com/office/powerpoint/2010/main" val="1093032741"/>
+        <p14:creationId xmlns:p14="http://schemas.microsoft.com/office/powerpoint/2010/main" val="1856312264"/>
       </p:ext>
     </p:extLst>
   </p:cSld>
@@ -4620,7 +4677,7 @@
           <p:cNvPr id="1" name="kicker-marker">
             <a:extLst xmlns:a="http://schemas.openxmlformats.org/drawingml/2006/main">
               <a:ext uri="{FF2B5EF4-FFF2-40B4-BE49-F238E27FC236}">
-                <a16:creationId xmlns:a16="http://schemas.microsoft.com/office/drawing/2014/main" id="{B4D3D62C-7780-4C57-A9F8-8336226E4B5A}"/>
+                <a16:creationId xmlns:a16="http://schemas.microsoft.com/office/drawing/2014/main" id="{A8C83C49-F6BF-4611-9F81-7552A426E81F}"/>
               </a:ext>
             </a:extLst>
           </p:cNvPr>
@@ -4655,7 +4712,7 @@
           <p:cNvPr id="2" name="kicker-label">
             <a:extLst xmlns:a="http://schemas.openxmlformats.org/drawingml/2006/main">
               <a:ext uri="{FF2B5EF4-FFF2-40B4-BE49-F238E27FC236}">
-                <a16:creationId xmlns:a16="http://schemas.microsoft.com/office/drawing/2014/main" id="{21330E10-7A2D-4553-B1DB-3CBA468EDCEB}"/>
+                <a16:creationId xmlns:a16="http://schemas.microsoft.com/office/drawing/2014/main" id="{F669F1DF-CBF1-4C4D-86ED-C859D8BBDD38}"/>
               </a:ext>
             </a:extLst>
           </p:cNvPr>
@@ -4712,7 +4769,7 @@
           <p:cNvPr id="3" name="">
             <a:extLst xmlns:a="http://schemas.openxmlformats.org/drawingml/2006/main">
               <a:ext uri="{FF2B5EF4-FFF2-40B4-BE49-F238E27FC236}">
-                <a16:creationId xmlns:a16="http://schemas.microsoft.com/office/drawing/2014/main" id="{25301A92-52CE-47C8-BA71-5B7F2FF2318B}"/>
+                <a16:creationId xmlns:a16="http://schemas.microsoft.com/office/drawing/2014/main" id="{866EB1B1-3BB1-4B69-8D9D-30542634DD02}"/>
               </a:ext>
             </a:extLst>
           </p:cNvPr>
@@ -4769,7 +4826,7 @@
           <p:cNvPr id="4" name="">
             <a:extLst xmlns:a="http://schemas.openxmlformats.org/drawingml/2006/main">
               <a:ext uri="{FF2B5EF4-FFF2-40B4-BE49-F238E27FC236}">
-                <a16:creationId xmlns:a16="http://schemas.microsoft.com/office/drawing/2014/main" id="{461A9F90-D438-4B94-BE62-3BD1E0BA9DC8}"/>
+                <a16:creationId xmlns:a16="http://schemas.microsoft.com/office/drawing/2014/main" id="{198E657A-4FD6-4A21-A92E-12C904DB55F2}"/>
               </a:ext>
             </a:extLst>
           </p:cNvPr>
@@ -4804,7 +4861,7 @@
           <p:cNvPr id="5" name="">
             <a:extLst xmlns:a="http://schemas.openxmlformats.org/drawingml/2006/main">
               <a:ext uri="{FF2B5EF4-FFF2-40B4-BE49-F238E27FC236}">
-                <a16:creationId xmlns:a16="http://schemas.microsoft.com/office/drawing/2014/main" id="{C908251B-EEB9-406E-A524-E677D9AE44DE}"/>
+                <a16:creationId xmlns:a16="http://schemas.microsoft.com/office/drawing/2014/main" id="{31197417-A0F6-4C00-BB13-574FF8234584}"/>
               </a:ext>
             </a:extLst>
           </p:cNvPr>
@@ -4861,7 +4918,7 @@
           <p:cNvPr id="6" name="">
             <a:extLst xmlns:a="http://schemas.openxmlformats.org/drawingml/2006/main">
               <a:ext uri="{FF2B5EF4-FFF2-40B4-BE49-F238E27FC236}">
-                <a16:creationId xmlns:a16="http://schemas.microsoft.com/office/drawing/2014/main" id="{EF85775A-1CBA-4420-A813-372ACB0A369F}"/>
+                <a16:creationId xmlns:a16="http://schemas.microsoft.com/office/drawing/2014/main" id="{2E75B748-A695-472B-89E8-2D708F920BFD}"/>
               </a:ext>
             </a:extLst>
           </p:cNvPr>
@@ -4918,7 +4975,7 @@
           <p:cNvPr id="7" name="">
             <a:extLst xmlns:a="http://schemas.openxmlformats.org/drawingml/2006/main">
               <a:ext uri="{FF2B5EF4-FFF2-40B4-BE49-F238E27FC236}">
-                <a16:creationId xmlns:a16="http://schemas.microsoft.com/office/drawing/2014/main" id="{51C0A37F-90A0-4684-9871-5BB3C7081E65}"/>
+                <a16:creationId xmlns:a16="http://schemas.microsoft.com/office/drawing/2014/main" id="{D3E59326-12A5-444E-A230-AA0128B83E51}"/>
               </a:ext>
             </a:extLst>
           </p:cNvPr>
@@ -4953,7 +5010,7 @@
           <p:cNvPr id="8" name="">
             <a:extLst xmlns:a="http://schemas.openxmlformats.org/drawingml/2006/main">
               <a:ext uri="{FF2B5EF4-FFF2-40B4-BE49-F238E27FC236}">
-                <a16:creationId xmlns:a16="http://schemas.microsoft.com/office/drawing/2014/main" id="{BE59B20E-3254-47C5-B37F-C9A9D93E3007}"/>
+                <a16:creationId xmlns:a16="http://schemas.microsoft.com/office/drawing/2014/main" id="{393D30A6-054A-4C45-949C-7255276CE0C9}"/>
               </a:ext>
             </a:extLst>
           </p:cNvPr>
@@ -5010,7 +5067,7 @@
           <p:cNvPr id="9" name="">
             <a:extLst xmlns:a="http://schemas.openxmlformats.org/drawingml/2006/main">
               <a:ext uri="{FF2B5EF4-FFF2-40B4-BE49-F238E27FC236}">
-                <a16:creationId xmlns:a16="http://schemas.microsoft.com/office/drawing/2014/main" id="{EDA2B376-CE5C-4296-995F-16DD64D95A29}"/>
+                <a16:creationId xmlns:a16="http://schemas.microsoft.com/office/drawing/2014/main" id="{213B0AB9-6838-4D24-86AF-6A3586226292}"/>
               </a:ext>
             </a:extLst>
           </p:cNvPr>
@@ -5067,7 +5124,7 @@
           <p:cNvPr id="10" name="">
             <a:extLst xmlns:a="http://schemas.openxmlformats.org/drawingml/2006/main">
               <a:ext uri="{FF2B5EF4-FFF2-40B4-BE49-F238E27FC236}">
-                <a16:creationId xmlns:a16="http://schemas.microsoft.com/office/drawing/2014/main" id="{BE66AA27-20BF-4286-A658-3B43F74DFA4A}"/>
+                <a16:creationId xmlns:a16="http://schemas.microsoft.com/office/drawing/2014/main" id="{FC842F41-73E2-4838-818A-351C9C9F79A6}"/>
               </a:ext>
             </a:extLst>
           </p:cNvPr>
@@ -5124,7 +5181,7 @@
           <p:cNvPr id="11" name="">
             <a:extLst xmlns:a="http://schemas.openxmlformats.org/drawingml/2006/main">
               <a:ext uri="{FF2B5EF4-FFF2-40B4-BE49-F238E27FC236}">
-                <a16:creationId xmlns:a16="http://schemas.microsoft.com/office/drawing/2014/main" id="{C144C0A8-3078-48F5-86B9-63FBE0F1600E}"/>
+                <a16:creationId xmlns:a16="http://schemas.microsoft.com/office/drawing/2014/main" id="{A5491E45-DCEF-4AB6-B2BE-138F1639CA02}"/>
               </a:ext>
             </a:extLst>
           </p:cNvPr>
@@ -5181,7 +5238,7 @@
           <p:cNvPr id="12" name="">
             <a:extLst xmlns:a="http://schemas.openxmlformats.org/drawingml/2006/main">
               <a:ext uri="{FF2B5EF4-FFF2-40B4-BE49-F238E27FC236}">
-                <a16:creationId xmlns:a16="http://schemas.microsoft.com/office/drawing/2014/main" id="{B117D3F6-2497-46BB-ADAD-15678484914B}"/>
+                <a16:creationId xmlns:a16="http://schemas.microsoft.com/office/drawing/2014/main" id="{20E29287-21DD-4C9B-8FA5-0490DE01D8D8}"/>
               </a:ext>
             </a:extLst>
           </p:cNvPr>
@@ -5238,7 +5295,7 @@
           <p:cNvPr id="13" name="">
             <a:extLst xmlns:a="http://schemas.openxmlformats.org/drawingml/2006/main">
               <a:ext uri="{FF2B5EF4-FFF2-40B4-BE49-F238E27FC236}">
-                <a16:creationId xmlns:a16="http://schemas.microsoft.com/office/drawing/2014/main" id="{69F8661B-EBB2-42D7-ABD2-EC098B862929}"/>
+                <a16:creationId xmlns:a16="http://schemas.microsoft.com/office/drawing/2014/main" id="{917E29E4-42C2-42F6-9837-DB8B1E08CD7A}"/>
               </a:ext>
             </a:extLst>
           </p:cNvPr>
@@ -5295,7 +5352,7 @@
           <p:cNvPr id="14" name="">
             <a:extLst xmlns:a="http://schemas.openxmlformats.org/drawingml/2006/main">
               <a:ext uri="{FF2B5EF4-FFF2-40B4-BE49-F238E27FC236}">
-                <a16:creationId xmlns:a16="http://schemas.microsoft.com/office/drawing/2014/main" id="{9F5CD1D4-E860-4B15-8038-2DBD38B0E746}"/>
+                <a16:creationId xmlns:a16="http://schemas.microsoft.com/office/drawing/2014/main" id="{8B417AD4-923A-4510-A52A-8D3B8AF00AB8}"/>
               </a:ext>
             </a:extLst>
           </p:cNvPr>
@@ -5416,7 +5473,7 @@
           <p:cNvPr id="15" name="">
             <a:extLst xmlns:a="http://schemas.openxmlformats.org/drawingml/2006/main">
               <a:ext uri="{FF2B5EF4-FFF2-40B4-BE49-F238E27FC236}">
-                <a16:creationId xmlns:a16="http://schemas.microsoft.com/office/drawing/2014/main" id="{7AEB9D84-93F7-4B58-A631-19133EB183E8}"/>
+                <a16:creationId xmlns:a16="http://schemas.microsoft.com/office/drawing/2014/main" id="{0ABF2E99-D3C0-4180-AB5F-8C393D7B556A}"/>
               </a:ext>
             </a:extLst>
           </p:cNvPr>
@@ -5471,7 +5528,7 @@
     </p:spTree>
     <p:extLst>
       <p:ext uri="{BB962C8B-B14F-4D97-AF65-F5344CB8AC3E}">
-        <p14:creationId xmlns:p14="http://schemas.microsoft.com/office/powerpoint/2010/main" val="2130111799"/>
+        <p14:creationId xmlns:p14="http://schemas.microsoft.com/office/powerpoint/2010/main" val="1105551815"/>
       </p:ext>
     </p:extLst>
   </p:cSld>
@@ -5502,7 +5559,7 @@
           <p:cNvPr id="1" name="kicker-marker">
             <a:extLst xmlns:a="http://schemas.openxmlformats.org/drawingml/2006/main">
               <a:ext uri="{FF2B5EF4-FFF2-40B4-BE49-F238E27FC236}">
-                <a16:creationId xmlns:a16="http://schemas.microsoft.com/office/drawing/2014/main" id="{1D91C466-1235-4135-B7D9-ED1246CF138C}"/>
+                <a16:creationId xmlns:a16="http://schemas.microsoft.com/office/drawing/2014/main" id="{DBE1055A-EC4C-4899-8B3C-54FEBAB87325}"/>
               </a:ext>
             </a:extLst>
           </p:cNvPr>
@@ -5537,7 +5594,7 @@
           <p:cNvPr id="2" name="kicker-label">
             <a:extLst xmlns:a="http://schemas.openxmlformats.org/drawingml/2006/main">
               <a:ext uri="{FF2B5EF4-FFF2-40B4-BE49-F238E27FC236}">
-                <a16:creationId xmlns:a16="http://schemas.microsoft.com/office/drawing/2014/main" id="{DA1B16C9-5834-488C-A48B-FA67FD3F50EF}"/>
+                <a16:creationId xmlns:a16="http://schemas.microsoft.com/office/drawing/2014/main" id="{590A3907-2769-418D-A1E7-F0BD680F30B2}"/>
               </a:ext>
             </a:extLst>
           </p:cNvPr>
@@ -5594,7 +5651,7 @@
           <p:cNvPr id="3" name="">
             <a:extLst xmlns:a="http://schemas.openxmlformats.org/drawingml/2006/main">
               <a:ext uri="{FF2B5EF4-FFF2-40B4-BE49-F238E27FC236}">
-                <a16:creationId xmlns:a16="http://schemas.microsoft.com/office/drawing/2014/main" id="{719961F0-9BFE-4883-AFD6-5541BBB42C91}"/>
+                <a16:creationId xmlns:a16="http://schemas.microsoft.com/office/drawing/2014/main" id="{5EB6B5CE-A0A8-4C3D-97A0-5FA0AB1A3707}"/>
               </a:ext>
             </a:extLst>
           </p:cNvPr>
@@ -5651,7 +5708,7 @@
           <p:cNvPr id="4" name="">
             <a:extLst xmlns:a="http://schemas.openxmlformats.org/drawingml/2006/main">
               <a:ext uri="{FF2B5EF4-FFF2-40B4-BE49-F238E27FC236}">
-                <a16:creationId xmlns:a16="http://schemas.microsoft.com/office/drawing/2014/main" id="{433204CD-D65A-48BB-9036-0BED2932C7B3}"/>
+                <a16:creationId xmlns:a16="http://schemas.microsoft.com/office/drawing/2014/main" id="{3282F0F3-007E-47A1-9C01-67439F42886B}"/>
               </a:ext>
             </a:extLst>
           </p:cNvPr>
@@ -5708,7 +5765,7 @@
           <p:cNvPr id="5" name="">
             <a:extLst xmlns:a="http://schemas.openxmlformats.org/drawingml/2006/main">
               <a:ext uri="{FF2B5EF4-FFF2-40B4-BE49-F238E27FC236}">
-                <a16:creationId xmlns:a16="http://schemas.microsoft.com/office/drawing/2014/main" id="{34159879-80CD-4994-94B2-772524A1AC59}"/>
+                <a16:creationId xmlns:a16="http://schemas.microsoft.com/office/drawing/2014/main" id="{528AA731-479B-4126-AC1A-21C7B64E57AB}"/>
               </a:ext>
             </a:extLst>
           </p:cNvPr>
@@ -5743,7 +5800,7 @@
           <p:cNvPr id="6" name="">
             <a:extLst xmlns:a="http://schemas.openxmlformats.org/drawingml/2006/main">
               <a:ext uri="{FF2B5EF4-FFF2-40B4-BE49-F238E27FC236}">
-                <a16:creationId xmlns:a16="http://schemas.microsoft.com/office/drawing/2014/main" id="{FFBA8E37-B486-435F-8057-D28B66305547}"/>
+                <a16:creationId xmlns:a16="http://schemas.microsoft.com/office/drawing/2014/main" id="{0379AAED-CD7A-4D2C-BBBF-64D4BE991360}"/>
               </a:ext>
             </a:extLst>
           </p:cNvPr>
@@ -5800,7 +5857,7 @@
           <p:cNvPr id="7" name="">
             <a:extLst xmlns:a="http://schemas.openxmlformats.org/drawingml/2006/main">
               <a:ext uri="{FF2B5EF4-FFF2-40B4-BE49-F238E27FC236}">
-                <a16:creationId xmlns:a16="http://schemas.microsoft.com/office/drawing/2014/main" id="{637B86BD-0374-41F7-BCB6-796B584D35D4}"/>
+                <a16:creationId xmlns:a16="http://schemas.microsoft.com/office/drawing/2014/main" id="{02E928DD-4FA3-4A2D-B23B-9D1C3640B748}"/>
               </a:ext>
             </a:extLst>
           </p:cNvPr>
@@ -5857,7 +5914,7 @@
           <p:cNvPr id="8" name="">
             <a:extLst xmlns:a="http://schemas.openxmlformats.org/drawingml/2006/main">
               <a:ext uri="{FF2B5EF4-FFF2-40B4-BE49-F238E27FC236}">
-                <a16:creationId xmlns:a16="http://schemas.microsoft.com/office/drawing/2014/main" id="{9674937E-BD8A-4784-86A5-2D5128A44511}"/>
+                <a16:creationId xmlns:a16="http://schemas.microsoft.com/office/drawing/2014/main" id="{88CD8286-4164-4383-A50A-006573C6167F}"/>
               </a:ext>
             </a:extLst>
           </p:cNvPr>
@@ -5892,7 +5949,7 @@
           <p:cNvPr id="9" name="">
             <a:extLst xmlns:a="http://schemas.openxmlformats.org/drawingml/2006/main">
               <a:ext uri="{FF2B5EF4-FFF2-40B4-BE49-F238E27FC236}">
-                <a16:creationId xmlns:a16="http://schemas.microsoft.com/office/drawing/2014/main" id="{5501497A-9087-4542-881F-5A0264725966}"/>
+                <a16:creationId xmlns:a16="http://schemas.microsoft.com/office/drawing/2014/main" id="{22E0FCE2-7C1D-4B56-8F71-24830A0B24F6}"/>
               </a:ext>
             </a:extLst>
           </p:cNvPr>
@@ -5925,7 +5982,7 @@
           <p:cNvPr id="10" name="">
             <a:extLst xmlns:a="http://schemas.openxmlformats.org/drawingml/2006/main">
               <a:ext uri="{FF2B5EF4-FFF2-40B4-BE49-F238E27FC236}">
-                <a16:creationId xmlns:a16="http://schemas.microsoft.com/office/drawing/2014/main" id="{7CA6BE0A-07BE-493E-A593-85A429D06B6E}"/>
+                <a16:creationId xmlns:a16="http://schemas.microsoft.com/office/drawing/2014/main" id="{715AB14C-7166-4FB3-95E7-A7BAE319DE44}"/>
               </a:ext>
             </a:extLst>
           </p:cNvPr>
@@ -5960,7 +6017,7 @@
           <p:cNvPr id="11" name="">
             <a:extLst xmlns:a="http://schemas.openxmlformats.org/drawingml/2006/main">
               <a:ext uri="{FF2B5EF4-FFF2-40B4-BE49-F238E27FC236}">
-                <a16:creationId xmlns:a16="http://schemas.microsoft.com/office/drawing/2014/main" id="{025F0B37-528D-4860-A2DA-3D1EF0E796C7}"/>
+                <a16:creationId xmlns:a16="http://schemas.microsoft.com/office/drawing/2014/main" id="{83656044-3050-4518-B36D-113EA9E9FB99}"/>
               </a:ext>
             </a:extLst>
           </p:cNvPr>
@@ -6017,7 +6074,7 @@
           <p:cNvPr id="12" name="">
             <a:extLst xmlns:a="http://schemas.openxmlformats.org/drawingml/2006/main">
               <a:ext uri="{FF2B5EF4-FFF2-40B4-BE49-F238E27FC236}">
-                <a16:creationId xmlns:a16="http://schemas.microsoft.com/office/drawing/2014/main" id="{411CCAAE-97DA-443A-AE1D-6CB541192815}"/>
+                <a16:creationId xmlns:a16="http://schemas.microsoft.com/office/drawing/2014/main" id="{8DFCAA08-529B-42BE-806B-477AC84318E8}"/>
               </a:ext>
             </a:extLst>
           </p:cNvPr>
@@ -6074,7 +6131,7 @@
           <p:cNvPr id="13" name="">
             <a:extLst xmlns:a="http://schemas.openxmlformats.org/drawingml/2006/main">
               <a:ext uri="{FF2B5EF4-FFF2-40B4-BE49-F238E27FC236}">
-                <a16:creationId xmlns:a16="http://schemas.microsoft.com/office/drawing/2014/main" id="{1DC43063-25AF-43BA-B0E9-1A59BFA7E0A3}"/>
+                <a16:creationId xmlns:a16="http://schemas.microsoft.com/office/drawing/2014/main" id="{7C60D1BA-F98E-42A8-A417-98E6B377473D}"/>
               </a:ext>
             </a:extLst>
           </p:cNvPr>
@@ -6109,7 +6166,7 @@
           <p:cNvPr id="14" name="">
             <a:extLst xmlns:a="http://schemas.openxmlformats.org/drawingml/2006/main">
               <a:ext uri="{FF2B5EF4-FFF2-40B4-BE49-F238E27FC236}">
-                <a16:creationId xmlns:a16="http://schemas.microsoft.com/office/drawing/2014/main" id="{49FCD549-2458-4849-9B36-069CBE0C3E3E}"/>
+                <a16:creationId xmlns:a16="http://schemas.microsoft.com/office/drawing/2014/main" id="{61E895AB-5A79-42AE-AED2-C68358955228}"/>
               </a:ext>
             </a:extLst>
           </p:cNvPr>
@@ -6142,7 +6199,7 @@
           <p:cNvPr id="15" name="">
             <a:extLst xmlns:a="http://schemas.openxmlformats.org/drawingml/2006/main">
               <a:ext uri="{FF2B5EF4-FFF2-40B4-BE49-F238E27FC236}">
-                <a16:creationId xmlns:a16="http://schemas.microsoft.com/office/drawing/2014/main" id="{7EE00B69-704C-4938-B78D-B1FE20B48905}"/>
+                <a16:creationId xmlns:a16="http://schemas.microsoft.com/office/drawing/2014/main" id="{6C5BAB95-9340-4A07-8CBF-CC0DF51604F5}"/>
               </a:ext>
             </a:extLst>
           </p:cNvPr>
@@ -6177,7 +6234,7 @@
           <p:cNvPr id="16" name="">
             <a:extLst xmlns:a="http://schemas.openxmlformats.org/drawingml/2006/main">
               <a:ext uri="{FF2B5EF4-FFF2-40B4-BE49-F238E27FC236}">
-                <a16:creationId xmlns:a16="http://schemas.microsoft.com/office/drawing/2014/main" id="{A8D6AA4F-B21F-4B07-A80B-68541343DE83}"/>
+                <a16:creationId xmlns:a16="http://schemas.microsoft.com/office/drawing/2014/main" id="{343C41CA-980B-4BA9-A43D-7B93348361DC}"/>
               </a:ext>
             </a:extLst>
           </p:cNvPr>
@@ -6234,7 +6291,7 @@
           <p:cNvPr id="17" name="">
             <a:extLst xmlns:a="http://schemas.openxmlformats.org/drawingml/2006/main">
               <a:ext uri="{FF2B5EF4-FFF2-40B4-BE49-F238E27FC236}">
-                <a16:creationId xmlns:a16="http://schemas.microsoft.com/office/drawing/2014/main" id="{936E3863-9EA6-4086-BF0F-598864EC3540}"/>
+                <a16:creationId xmlns:a16="http://schemas.microsoft.com/office/drawing/2014/main" id="{4ECC76D0-0EBF-4BC1-8778-4D0C3F7DB58A}"/>
               </a:ext>
             </a:extLst>
           </p:cNvPr>
@@ -6291,7 +6348,7 @@
           <p:cNvPr id="18" name="">
             <a:extLst xmlns:a="http://schemas.openxmlformats.org/drawingml/2006/main">
               <a:ext uri="{FF2B5EF4-FFF2-40B4-BE49-F238E27FC236}">
-                <a16:creationId xmlns:a16="http://schemas.microsoft.com/office/drawing/2014/main" id="{6EED8906-FB55-462A-B512-902CB1CDF2D3}"/>
+                <a16:creationId xmlns:a16="http://schemas.microsoft.com/office/drawing/2014/main" id="{8B87BBB3-EF80-403A-8785-3F4104D261C1}"/>
               </a:ext>
             </a:extLst>
           </p:cNvPr>
@@ -6326,7 +6383,7 @@
           <p:cNvPr id="19" name="">
             <a:extLst xmlns:a="http://schemas.openxmlformats.org/drawingml/2006/main">
               <a:ext uri="{FF2B5EF4-FFF2-40B4-BE49-F238E27FC236}">
-                <a16:creationId xmlns:a16="http://schemas.microsoft.com/office/drawing/2014/main" id="{08019ABB-5D4C-4E35-85C5-7D1ED0D90772}"/>
+                <a16:creationId xmlns:a16="http://schemas.microsoft.com/office/drawing/2014/main" id="{FB1F0420-241E-4ACC-9CA8-8ADDF2871BE2}"/>
               </a:ext>
             </a:extLst>
           </p:cNvPr>
@@ -6359,7 +6416,7 @@
           <p:cNvPr id="20" name="">
             <a:extLst xmlns:a="http://schemas.openxmlformats.org/drawingml/2006/main">
               <a:ext uri="{FF2B5EF4-FFF2-40B4-BE49-F238E27FC236}">
-                <a16:creationId xmlns:a16="http://schemas.microsoft.com/office/drawing/2014/main" id="{BFA16600-C937-4624-9E31-68BD4C1E2C06}"/>
+                <a16:creationId xmlns:a16="http://schemas.microsoft.com/office/drawing/2014/main" id="{226C0D0D-8C93-4CF4-A7E5-4951FA226B83}"/>
               </a:ext>
             </a:extLst>
           </p:cNvPr>
@@ -6394,7 +6451,7 @@
           <p:cNvPr id="21" name="">
             <a:extLst xmlns:a="http://schemas.openxmlformats.org/drawingml/2006/main">
               <a:ext uri="{FF2B5EF4-FFF2-40B4-BE49-F238E27FC236}">
-                <a16:creationId xmlns:a16="http://schemas.microsoft.com/office/drawing/2014/main" id="{CC9049E6-BC05-4BA9-A66B-6257923965F0}"/>
+                <a16:creationId xmlns:a16="http://schemas.microsoft.com/office/drawing/2014/main" id="{029A0BAC-E2E9-4CAF-95C7-F8685765BDB6}"/>
               </a:ext>
             </a:extLst>
           </p:cNvPr>
@@ -6451,7 +6508,7 @@
           <p:cNvPr id="22" name="">
             <a:extLst xmlns:a="http://schemas.openxmlformats.org/drawingml/2006/main">
               <a:ext uri="{FF2B5EF4-FFF2-40B4-BE49-F238E27FC236}">
-                <a16:creationId xmlns:a16="http://schemas.microsoft.com/office/drawing/2014/main" id="{2F3EEDC7-CE01-4C47-B8E1-65A1C82D0C0F}"/>
+                <a16:creationId xmlns:a16="http://schemas.microsoft.com/office/drawing/2014/main" id="{3741C18D-621E-426F-B6A7-C1466123C935}"/>
               </a:ext>
             </a:extLst>
           </p:cNvPr>
@@ -6508,7 +6565,7 @@
           <p:cNvPr id="23" name="">
             <a:extLst xmlns:a="http://schemas.openxmlformats.org/drawingml/2006/main">
               <a:ext uri="{FF2B5EF4-FFF2-40B4-BE49-F238E27FC236}">
-                <a16:creationId xmlns:a16="http://schemas.microsoft.com/office/drawing/2014/main" id="{12C2471C-881A-48A1-BC88-17F8AC12E6A4}"/>
+                <a16:creationId xmlns:a16="http://schemas.microsoft.com/office/drawing/2014/main" id="{1D9304CE-570A-41BD-BF3C-4E4F37912CF6}"/>
               </a:ext>
             </a:extLst>
           </p:cNvPr>
@@ -6541,7 +6598,7 @@
           <p:cNvPr id="24" name="">
             <a:extLst xmlns:a="http://schemas.openxmlformats.org/drawingml/2006/main">
               <a:ext uri="{FF2B5EF4-FFF2-40B4-BE49-F238E27FC236}">
-                <a16:creationId xmlns:a16="http://schemas.microsoft.com/office/drawing/2014/main" id="{A86FAE72-FE47-4EF6-9C5E-9D3485A85DD0}"/>
+                <a16:creationId xmlns:a16="http://schemas.microsoft.com/office/drawing/2014/main" id="{CC18AA19-907E-4174-BDBD-89458041D0FB}"/>
               </a:ext>
             </a:extLst>
           </p:cNvPr>
@@ -6576,7 +6633,7 @@
           <p:cNvPr id="25" name="">
             <a:extLst xmlns:a="http://schemas.openxmlformats.org/drawingml/2006/main">
               <a:ext uri="{FF2B5EF4-FFF2-40B4-BE49-F238E27FC236}">
-                <a16:creationId xmlns:a16="http://schemas.microsoft.com/office/drawing/2014/main" id="{0A044641-803A-461E-A411-46783C07F136}"/>
+                <a16:creationId xmlns:a16="http://schemas.microsoft.com/office/drawing/2014/main" id="{2C145E95-E32E-42F6-8E35-6DB5D4A06666}"/>
               </a:ext>
             </a:extLst>
           </p:cNvPr>
@@ -6633,7 +6690,7 @@
           <p:cNvPr id="26" name="">
             <a:extLst xmlns:a="http://schemas.openxmlformats.org/drawingml/2006/main">
               <a:ext uri="{FF2B5EF4-FFF2-40B4-BE49-F238E27FC236}">
-                <a16:creationId xmlns:a16="http://schemas.microsoft.com/office/drawing/2014/main" id="{7D21230A-4144-4E8B-9BF5-CA31305D8BEF}"/>
+                <a16:creationId xmlns:a16="http://schemas.microsoft.com/office/drawing/2014/main" id="{275CA181-F345-4DC7-AAB7-7DD38CC48D14}"/>
               </a:ext>
             </a:extLst>
           </p:cNvPr>
@@ -6690,7 +6747,7 @@
           <p:cNvPr id="27" name="">
             <a:extLst xmlns:a="http://schemas.openxmlformats.org/drawingml/2006/main">
               <a:ext uri="{FF2B5EF4-FFF2-40B4-BE49-F238E27FC236}">
-                <a16:creationId xmlns:a16="http://schemas.microsoft.com/office/drawing/2014/main" id="{48EA2A75-3420-4239-8F96-2BEB7A19117E}"/>
+                <a16:creationId xmlns:a16="http://schemas.microsoft.com/office/drawing/2014/main" id="{AC5E81D5-C3C3-44D3-9478-6B5A898E7A00}"/>
               </a:ext>
             </a:extLst>
           </p:cNvPr>
@@ -6745,7 +6802,7 @@
     </p:spTree>
     <p:extLst>
       <p:ext uri="{BB962C8B-B14F-4D97-AF65-F5344CB8AC3E}">
-        <p14:creationId xmlns:p14="http://schemas.microsoft.com/office/powerpoint/2010/main" val="1910521850"/>
+        <p14:creationId xmlns:p14="http://schemas.microsoft.com/office/powerpoint/2010/main" val="1643016787"/>
       </p:ext>
     </p:extLst>
   </p:cSld>
@@ -6776,7 +6833,7 @@
           <p:cNvPr id="1" name="kicker-marker">
             <a:extLst xmlns:a="http://schemas.openxmlformats.org/drawingml/2006/main">
               <a:ext uri="{FF2B5EF4-FFF2-40B4-BE49-F238E27FC236}">
-                <a16:creationId xmlns:a16="http://schemas.microsoft.com/office/drawing/2014/main" id="{971C4925-8EA3-4715-B057-1CD652192884}"/>
+                <a16:creationId xmlns:a16="http://schemas.microsoft.com/office/drawing/2014/main" id="{239C9E52-0A93-4EDE-904E-1019D8A7EF01}"/>
               </a:ext>
             </a:extLst>
           </p:cNvPr>
@@ -6811,7 +6868,7 @@
           <p:cNvPr id="2" name="kicker-label">
             <a:extLst xmlns:a="http://schemas.openxmlformats.org/drawingml/2006/main">
               <a:ext uri="{FF2B5EF4-FFF2-40B4-BE49-F238E27FC236}">
-                <a16:creationId xmlns:a16="http://schemas.microsoft.com/office/drawing/2014/main" id="{F15E3E5A-D481-4DFD-8CBD-3840BB3E36AF}"/>
+                <a16:creationId xmlns:a16="http://schemas.microsoft.com/office/drawing/2014/main" id="{99473798-C931-43B9-832A-C0446D3881D9}"/>
               </a:ext>
             </a:extLst>
           </p:cNvPr>
@@ -6868,7 +6925,7 @@
           <p:cNvPr id="3" name="">
             <a:extLst xmlns:a="http://schemas.openxmlformats.org/drawingml/2006/main">
               <a:ext uri="{FF2B5EF4-FFF2-40B4-BE49-F238E27FC236}">
-                <a16:creationId xmlns:a16="http://schemas.microsoft.com/office/drawing/2014/main" id="{6B5FA37E-B029-42A5-8F80-CEEA00CA5F76}"/>
+                <a16:creationId xmlns:a16="http://schemas.microsoft.com/office/drawing/2014/main" id="{D976CD98-EF94-4F8F-94B2-A5762D2B1EE2}"/>
               </a:ext>
             </a:extLst>
           </p:cNvPr>
@@ -6925,7 +6982,7 @@
           <p:cNvPr id="4" name="">
             <a:extLst xmlns:a="http://schemas.openxmlformats.org/drawingml/2006/main">
               <a:ext uri="{FF2B5EF4-FFF2-40B4-BE49-F238E27FC236}">
-                <a16:creationId xmlns:a16="http://schemas.microsoft.com/office/drawing/2014/main" id="{32C9C064-98E8-47E0-80E5-B7D7D742FE59}"/>
+                <a16:creationId xmlns:a16="http://schemas.microsoft.com/office/drawing/2014/main" id="{75D4E399-2346-4978-9C28-558E189426FB}"/>
               </a:ext>
             </a:extLst>
           </p:cNvPr>
@@ -6960,7 +7017,7 @@
           <p:cNvPr id="5" name="">
             <a:extLst xmlns:a="http://schemas.openxmlformats.org/drawingml/2006/main">
               <a:ext uri="{FF2B5EF4-FFF2-40B4-BE49-F238E27FC236}">
-                <a16:creationId xmlns:a16="http://schemas.microsoft.com/office/drawing/2014/main" id="{12A92486-913F-4F1C-87FB-6937DD8539BE}"/>
+                <a16:creationId xmlns:a16="http://schemas.microsoft.com/office/drawing/2014/main" id="{7BD61647-7A4F-47E0-BB84-3969CE3FC712}"/>
               </a:ext>
             </a:extLst>
           </p:cNvPr>
@@ -7017,7 +7074,7 @@
           <p:cNvPr id="6" name="">
             <a:extLst xmlns:a="http://schemas.openxmlformats.org/drawingml/2006/main">
               <a:ext uri="{FF2B5EF4-FFF2-40B4-BE49-F238E27FC236}">
-                <a16:creationId xmlns:a16="http://schemas.microsoft.com/office/drawing/2014/main" id="{48315472-8F6A-47A8-BF57-7D31840C3587}"/>
+                <a16:creationId xmlns:a16="http://schemas.microsoft.com/office/drawing/2014/main" id="{A6E080C8-0E41-426B-96E9-D356976618E2}"/>
               </a:ext>
             </a:extLst>
           </p:cNvPr>
@@ -7074,7 +7131,7 @@
           <p:cNvPr id="7" name="">
             <a:extLst xmlns:a="http://schemas.openxmlformats.org/drawingml/2006/main">
               <a:ext uri="{FF2B5EF4-FFF2-40B4-BE49-F238E27FC236}">
-                <a16:creationId xmlns:a16="http://schemas.microsoft.com/office/drawing/2014/main" id="{795B6694-437C-47C1-AA7B-DFC8C9D8A089}"/>
+                <a16:creationId xmlns:a16="http://schemas.microsoft.com/office/drawing/2014/main" id="{A3799448-61B2-4BC5-AEBA-C3FEA37E2BCA}"/>
               </a:ext>
             </a:extLst>
           </p:cNvPr>
@@ -7107,7 +7164,7 @@
           <p:cNvPr id="8" name="">
             <a:extLst xmlns:a="http://schemas.openxmlformats.org/drawingml/2006/main">
               <a:ext uri="{FF2B5EF4-FFF2-40B4-BE49-F238E27FC236}">
-                <a16:creationId xmlns:a16="http://schemas.microsoft.com/office/drawing/2014/main" id="{5D877601-90A3-4A6E-8BFD-4EB43D8D91F1}"/>
+                <a16:creationId xmlns:a16="http://schemas.microsoft.com/office/drawing/2014/main" id="{09CE6B10-C822-4CBE-9950-9D5A8F22AD66}"/>
               </a:ext>
             </a:extLst>
           </p:cNvPr>
@@ -7164,7 +7221,7 @@
           <p:cNvPr id="9" name="">
             <a:extLst xmlns:a="http://schemas.openxmlformats.org/drawingml/2006/main">
               <a:ext uri="{FF2B5EF4-FFF2-40B4-BE49-F238E27FC236}">
-                <a16:creationId xmlns:a16="http://schemas.microsoft.com/office/drawing/2014/main" id="{A49FB925-79F1-40CF-9149-9EE845EE83F0}"/>
+                <a16:creationId xmlns:a16="http://schemas.microsoft.com/office/drawing/2014/main" id="{2CABF1AA-F547-4C18-B61E-E1E4CAF11B66}"/>
               </a:ext>
             </a:extLst>
           </p:cNvPr>
@@ -7285,7 +7342,7 @@
           <p:cNvPr id="10" name="">
             <a:extLst xmlns:a="http://schemas.openxmlformats.org/drawingml/2006/main">
               <a:ext uri="{FF2B5EF4-FFF2-40B4-BE49-F238E27FC236}">
-                <a16:creationId xmlns:a16="http://schemas.microsoft.com/office/drawing/2014/main" id="{F380E124-9F63-4D7B-9D57-7B2E1A0CFA81}"/>
+                <a16:creationId xmlns:a16="http://schemas.microsoft.com/office/drawing/2014/main" id="{86B9EB20-4C37-4678-9826-84FA0958D2E6}"/>
               </a:ext>
             </a:extLst>
           </p:cNvPr>
@@ -7318,7 +7375,7 @@
           <p:cNvPr id="11" name="">
             <a:extLst xmlns:a="http://schemas.openxmlformats.org/drawingml/2006/main">
               <a:ext uri="{FF2B5EF4-FFF2-40B4-BE49-F238E27FC236}">
-                <a16:creationId xmlns:a16="http://schemas.microsoft.com/office/drawing/2014/main" id="{7597BF1C-B4D4-4BAF-B6B9-79E6E02E272B}"/>
+                <a16:creationId xmlns:a16="http://schemas.microsoft.com/office/drawing/2014/main" id="{63F4BF45-A6E5-4F1C-BED9-830A5C9FD067}"/>
               </a:ext>
             </a:extLst>
           </p:cNvPr>
@@ -7375,7 +7432,7 @@
           <p:cNvPr id="12" name="">
             <a:extLst xmlns:a="http://schemas.openxmlformats.org/drawingml/2006/main">
               <a:ext uri="{FF2B5EF4-FFF2-40B4-BE49-F238E27FC236}">
-                <a16:creationId xmlns:a16="http://schemas.microsoft.com/office/drawing/2014/main" id="{F35214EF-07DD-4560-B6B0-F264889AE55D}"/>
+                <a16:creationId xmlns:a16="http://schemas.microsoft.com/office/drawing/2014/main" id="{F62A50AA-C854-4CE5-95C9-DF21AD976587}"/>
               </a:ext>
             </a:extLst>
           </p:cNvPr>
@@ -7496,7 +7553,7 @@
           <p:cNvPr id="13" name="">
             <a:extLst xmlns:a="http://schemas.openxmlformats.org/drawingml/2006/main">
               <a:ext uri="{FF2B5EF4-FFF2-40B4-BE49-F238E27FC236}">
-                <a16:creationId xmlns:a16="http://schemas.microsoft.com/office/drawing/2014/main" id="{3B3E275F-CD80-4B9F-8EE3-07A39C150D21}"/>
+                <a16:creationId xmlns:a16="http://schemas.microsoft.com/office/drawing/2014/main" id="{88E56CCE-320D-4929-8C41-9F9E9ED68269}"/>
               </a:ext>
             </a:extLst>
           </p:cNvPr>
@@ -7551,7 +7608,7 @@
     </p:spTree>
     <p:extLst>
       <p:ext uri="{BB962C8B-B14F-4D97-AF65-F5344CB8AC3E}">
-        <p14:creationId xmlns:p14="http://schemas.microsoft.com/office/powerpoint/2010/main" val="2033871735"/>
+        <p14:creationId xmlns:p14="http://schemas.microsoft.com/office/powerpoint/2010/main" val="1890861046"/>
       </p:ext>
     </p:extLst>
   </p:cSld>
@@ -7582,7 +7639,7 @@
           <p:cNvPr id="1" name="kicker-marker">
             <a:extLst xmlns:a="http://schemas.openxmlformats.org/drawingml/2006/main">
               <a:ext uri="{FF2B5EF4-FFF2-40B4-BE49-F238E27FC236}">
-                <a16:creationId xmlns:a16="http://schemas.microsoft.com/office/drawing/2014/main" id="{ECA928F1-1CC8-4ED6-9A9E-19967C97A3C2}"/>
+                <a16:creationId xmlns:a16="http://schemas.microsoft.com/office/drawing/2014/main" id="{0C3E4E7B-6C07-4FCF-9215-3BDE22D8AC92}"/>
               </a:ext>
             </a:extLst>
           </p:cNvPr>
@@ -7617,7 +7674,7 @@
           <p:cNvPr id="2" name="kicker-label">
             <a:extLst xmlns:a="http://schemas.openxmlformats.org/drawingml/2006/main">
               <a:ext uri="{FF2B5EF4-FFF2-40B4-BE49-F238E27FC236}">
-                <a16:creationId xmlns:a16="http://schemas.microsoft.com/office/drawing/2014/main" id="{5DF0B499-3DB7-4B5C-88A9-EE74E6193804}"/>
+                <a16:creationId xmlns:a16="http://schemas.microsoft.com/office/drawing/2014/main" id="{CAE88A90-B2B9-45F8-B30D-AF5F32208FD2}"/>
               </a:ext>
             </a:extLst>
           </p:cNvPr>
@@ -7674,7 +7731,7 @@
           <p:cNvPr id="3" name="">
             <a:extLst xmlns:a="http://schemas.openxmlformats.org/drawingml/2006/main">
               <a:ext uri="{FF2B5EF4-FFF2-40B4-BE49-F238E27FC236}">
-                <a16:creationId xmlns:a16="http://schemas.microsoft.com/office/drawing/2014/main" id="{C8CF61DD-BC2A-49BC-A187-40352A11DBA8}"/>
+                <a16:creationId xmlns:a16="http://schemas.microsoft.com/office/drawing/2014/main" id="{AF1F5BE5-2FFC-4B67-8A82-5D8B42136B7C}"/>
               </a:ext>
             </a:extLst>
           </p:cNvPr>
@@ -7731,7 +7788,7 @@
           <p:cNvPr id="4" name="">
             <a:extLst xmlns:a="http://schemas.openxmlformats.org/drawingml/2006/main">
               <a:ext uri="{FF2B5EF4-FFF2-40B4-BE49-F238E27FC236}">
-                <a16:creationId xmlns:a16="http://schemas.microsoft.com/office/drawing/2014/main" id="{7D445029-77DA-4124-AD5E-A1144BA6CA55}"/>
+                <a16:creationId xmlns:a16="http://schemas.microsoft.com/office/drawing/2014/main" id="{47A6E6FB-C6AA-43AD-A016-F46BEFF5CA5F}"/>
               </a:ext>
             </a:extLst>
           </p:cNvPr>
@@ -7788,7 +7845,7 @@
           <p:cNvPr id="5" name="">
             <a:extLst xmlns:a="http://schemas.openxmlformats.org/drawingml/2006/main">
               <a:ext uri="{FF2B5EF4-FFF2-40B4-BE49-F238E27FC236}">
-                <a16:creationId xmlns:a16="http://schemas.microsoft.com/office/drawing/2014/main" id="{2196BB92-F4E2-496C-8646-B70D20C11C14}"/>
+                <a16:creationId xmlns:a16="http://schemas.microsoft.com/office/drawing/2014/main" id="{A5E81566-D1AE-4DE5-AB14-517FA1D3A0E3}"/>
               </a:ext>
             </a:extLst>
           </p:cNvPr>
@@ -7823,7 +7880,7 @@
           <p:cNvPr id="6" name="">
             <a:extLst xmlns:a="http://schemas.openxmlformats.org/drawingml/2006/main">
               <a:ext uri="{FF2B5EF4-FFF2-40B4-BE49-F238E27FC236}">
-                <a16:creationId xmlns:a16="http://schemas.microsoft.com/office/drawing/2014/main" id="{FDEE86F4-D2AF-4C8B-A737-CF58AA258A4D}"/>
+                <a16:creationId xmlns:a16="http://schemas.microsoft.com/office/drawing/2014/main" id="{5B3AF09E-09BA-4E9C-B893-60B4D3B66824}"/>
               </a:ext>
             </a:extLst>
           </p:cNvPr>
@@ -7880,7 +7937,7 @@
           <p:cNvPr id="7" name="">
             <a:extLst xmlns:a="http://schemas.openxmlformats.org/drawingml/2006/main">
               <a:ext uri="{FF2B5EF4-FFF2-40B4-BE49-F238E27FC236}">
-                <a16:creationId xmlns:a16="http://schemas.microsoft.com/office/drawing/2014/main" id="{4872CF51-7355-46B7-AC14-11717ABAB13A}"/>
+                <a16:creationId xmlns:a16="http://schemas.microsoft.com/office/drawing/2014/main" id="{9081D6DD-CDBA-4390-AA8A-6AF74C0A795A}"/>
               </a:ext>
             </a:extLst>
           </p:cNvPr>
@@ -7937,7 +7994,7 @@
           <p:cNvPr id="8" name="">
             <a:extLst xmlns:a="http://schemas.openxmlformats.org/drawingml/2006/main">
               <a:ext uri="{FF2B5EF4-FFF2-40B4-BE49-F238E27FC236}">
-                <a16:creationId xmlns:a16="http://schemas.microsoft.com/office/drawing/2014/main" id="{2740E7BD-9121-4F1E-8E55-916FCFD3EECB}"/>
+                <a16:creationId xmlns:a16="http://schemas.microsoft.com/office/drawing/2014/main" id="{D755D521-9BFE-4542-BCFC-ABEB404153D6}"/>
               </a:ext>
             </a:extLst>
           </p:cNvPr>
@@ -7970,7 +8027,7 @@
           <p:cNvPr id="9" name="">
             <a:extLst xmlns:a="http://schemas.openxmlformats.org/drawingml/2006/main">
               <a:ext uri="{FF2B5EF4-FFF2-40B4-BE49-F238E27FC236}">
-                <a16:creationId xmlns:a16="http://schemas.microsoft.com/office/drawing/2014/main" id="{9DC5831C-1733-4685-88F2-555F81012F25}"/>
+                <a16:creationId xmlns:a16="http://schemas.microsoft.com/office/drawing/2014/main" id="{B92F804A-2397-4CBF-BB15-CB315C2B3248}"/>
               </a:ext>
             </a:extLst>
           </p:cNvPr>
@@ -8027,7 +8084,7 @@
           <p:cNvPr id="10" name="">
             <a:extLst xmlns:a="http://schemas.openxmlformats.org/drawingml/2006/main">
               <a:ext uri="{FF2B5EF4-FFF2-40B4-BE49-F238E27FC236}">
-                <a16:creationId xmlns:a16="http://schemas.microsoft.com/office/drawing/2014/main" id="{7A2442FF-F7EA-4DEB-B9EA-C505D4D73B61}"/>
+                <a16:creationId xmlns:a16="http://schemas.microsoft.com/office/drawing/2014/main" id="{D0D4B4A9-89EB-4B78-B3F7-C664166D64AB}"/>
               </a:ext>
             </a:extLst>
           </p:cNvPr>
@@ -8111,7 +8168,7 @@
           <p:cNvPr id="11" name="">
             <a:extLst xmlns:a="http://schemas.openxmlformats.org/drawingml/2006/main">
               <a:ext uri="{FF2B5EF4-FFF2-40B4-BE49-F238E27FC236}">
-                <a16:creationId xmlns:a16="http://schemas.microsoft.com/office/drawing/2014/main" id="{F51BF90D-4CE8-4A6E-99B4-F8D00AF7B711}"/>
+                <a16:creationId xmlns:a16="http://schemas.microsoft.com/office/drawing/2014/main" id="{71658213-CDBA-4EC3-A4A9-066059B604A3}"/>
               </a:ext>
             </a:extLst>
           </p:cNvPr>
@@ -8146,7 +8203,7 @@
           <p:cNvPr id="12" name="">
             <a:extLst xmlns:a="http://schemas.openxmlformats.org/drawingml/2006/main">
               <a:ext uri="{FF2B5EF4-FFF2-40B4-BE49-F238E27FC236}">
-                <a16:creationId xmlns:a16="http://schemas.microsoft.com/office/drawing/2014/main" id="{68CD3560-7281-4A97-A1A3-88C7F5BC4956}"/>
+                <a16:creationId xmlns:a16="http://schemas.microsoft.com/office/drawing/2014/main" id="{898920FA-A30C-4B2C-AEA9-AF003052D4D2}"/>
               </a:ext>
             </a:extLst>
           </p:cNvPr>
@@ -8179,7 +8236,7 @@
           <p:cNvPr id="13" name="">
             <a:extLst xmlns:a="http://schemas.openxmlformats.org/drawingml/2006/main">
               <a:ext uri="{FF2B5EF4-FFF2-40B4-BE49-F238E27FC236}">
-                <a16:creationId xmlns:a16="http://schemas.microsoft.com/office/drawing/2014/main" id="{9AB8384B-BBD1-4DD5-A3E4-29BC69C99BCB}"/>
+                <a16:creationId xmlns:a16="http://schemas.microsoft.com/office/drawing/2014/main" id="{5199665C-7CDA-4DBD-9EEB-21439C500F4A}"/>
               </a:ext>
             </a:extLst>
           </p:cNvPr>
@@ -8236,7 +8293,7 @@
           <p:cNvPr id="14" name="">
             <a:extLst xmlns:a="http://schemas.openxmlformats.org/drawingml/2006/main">
               <a:ext uri="{FF2B5EF4-FFF2-40B4-BE49-F238E27FC236}">
-                <a16:creationId xmlns:a16="http://schemas.microsoft.com/office/drawing/2014/main" id="{A16FBF5F-7CC3-47B2-90B8-227EA8F3DBD9}"/>
+                <a16:creationId xmlns:a16="http://schemas.microsoft.com/office/drawing/2014/main" id="{5D7BEB52-419C-4642-B5F7-7A885DB299F8}"/>
               </a:ext>
             </a:extLst>
           </p:cNvPr>
@@ -8320,7 +8377,7 @@
           <p:cNvPr id="15" name="">
             <a:extLst xmlns:a="http://schemas.openxmlformats.org/drawingml/2006/main">
               <a:ext uri="{FF2B5EF4-FFF2-40B4-BE49-F238E27FC236}">
-                <a16:creationId xmlns:a16="http://schemas.microsoft.com/office/drawing/2014/main" id="{2355FB46-9110-4D7D-B664-2484C682EEF8}"/>
+                <a16:creationId xmlns:a16="http://schemas.microsoft.com/office/drawing/2014/main" id="{2F853F79-AFE0-4F40-8565-B9004231CF0E}"/>
               </a:ext>
             </a:extLst>
           </p:cNvPr>
@@ -8355,7 +8412,7 @@
           <p:cNvPr id="16" name="">
             <a:extLst xmlns:a="http://schemas.openxmlformats.org/drawingml/2006/main">
               <a:ext uri="{FF2B5EF4-FFF2-40B4-BE49-F238E27FC236}">
-                <a16:creationId xmlns:a16="http://schemas.microsoft.com/office/drawing/2014/main" id="{4E2D88EB-07FE-4791-B739-5848D7DBD24D}"/>
+                <a16:creationId xmlns:a16="http://schemas.microsoft.com/office/drawing/2014/main" id="{E48B7482-4641-4A45-961F-51CD75357A59}"/>
               </a:ext>
             </a:extLst>
           </p:cNvPr>
@@ -8388,7 +8445,7 @@
           <p:cNvPr id="17" name="">
             <a:extLst xmlns:a="http://schemas.openxmlformats.org/drawingml/2006/main">
               <a:ext uri="{FF2B5EF4-FFF2-40B4-BE49-F238E27FC236}">
-                <a16:creationId xmlns:a16="http://schemas.microsoft.com/office/drawing/2014/main" id="{2E807117-7D88-49CE-B791-EEDD6C763AAD}"/>
+                <a16:creationId xmlns:a16="http://schemas.microsoft.com/office/drawing/2014/main" id="{964CF577-3E9D-4451-9BBF-781223CDB592}"/>
               </a:ext>
             </a:extLst>
           </p:cNvPr>
@@ -8445,7 +8502,7 @@
           <p:cNvPr id="18" name="">
             <a:extLst xmlns:a="http://schemas.openxmlformats.org/drawingml/2006/main">
               <a:ext uri="{FF2B5EF4-FFF2-40B4-BE49-F238E27FC236}">
-                <a16:creationId xmlns:a16="http://schemas.microsoft.com/office/drawing/2014/main" id="{97F60001-370F-40C9-8E5F-C9F2F85A92DC}"/>
+                <a16:creationId xmlns:a16="http://schemas.microsoft.com/office/drawing/2014/main" id="{85B91EFA-949A-4F3B-8D2E-CD5B52D97E5D}"/>
               </a:ext>
             </a:extLst>
           </p:cNvPr>
@@ -8502,7 +8559,7 @@
           <p:cNvPr id="19" name="">
             <a:extLst xmlns:a="http://schemas.openxmlformats.org/drawingml/2006/main">
               <a:ext uri="{FF2B5EF4-FFF2-40B4-BE49-F238E27FC236}">
-                <a16:creationId xmlns:a16="http://schemas.microsoft.com/office/drawing/2014/main" id="{0CF60894-9AB9-45B7-B704-8985730049AF}"/>
+                <a16:creationId xmlns:a16="http://schemas.microsoft.com/office/drawing/2014/main" id="{CBA0EACA-9A99-4CFA-B492-EB7E7D03D908}"/>
               </a:ext>
             </a:extLst>
           </p:cNvPr>
@@ -8557,7 +8614,7 @@
     </p:spTree>
     <p:extLst>
       <p:ext uri="{BB962C8B-B14F-4D97-AF65-F5344CB8AC3E}">
-        <p14:creationId xmlns:p14="http://schemas.microsoft.com/office/powerpoint/2010/main" val="1513840293"/>
+        <p14:creationId xmlns:p14="http://schemas.microsoft.com/office/powerpoint/2010/main" val="2015351249"/>
       </p:ext>
     </p:extLst>
   </p:cSld>
@@ -8588,7 +8645,7 @@
           <p:cNvPr id="1" name="kicker-marker">
             <a:extLst xmlns:a="http://schemas.openxmlformats.org/drawingml/2006/main">
               <a:ext uri="{FF2B5EF4-FFF2-40B4-BE49-F238E27FC236}">
-                <a16:creationId xmlns:a16="http://schemas.microsoft.com/office/drawing/2014/main" id="{42F478DE-D534-4F57-B0BE-D3AF42CB0322}"/>
+                <a16:creationId xmlns:a16="http://schemas.microsoft.com/office/drawing/2014/main" id="{2DFC53BA-5AAB-4223-9026-866698816C70}"/>
               </a:ext>
             </a:extLst>
           </p:cNvPr>
@@ -8623,7 +8680,7 @@
           <p:cNvPr id="2" name="kicker-label">
             <a:extLst xmlns:a="http://schemas.openxmlformats.org/drawingml/2006/main">
               <a:ext uri="{FF2B5EF4-FFF2-40B4-BE49-F238E27FC236}">
-                <a16:creationId xmlns:a16="http://schemas.microsoft.com/office/drawing/2014/main" id="{614F5951-C721-4BD3-94CB-8E17B22726FA}"/>
+                <a16:creationId xmlns:a16="http://schemas.microsoft.com/office/drawing/2014/main" id="{383A957C-2972-4E3D-A1CE-A003CFFE5253}"/>
               </a:ext>
             </a:extLst>
           </p:cNvPr>
@@ -8680,7 +8737,7 @@
           <p:cNvPr id="3" name="">
             <a:extLst xmlns:a="http://schemas.openxmlformats.org/drawingml/2006/main">
               <a:ext uri="{FF2B5EF4-FFF2-40B4-BE49-F238E27FC236}">
-                <a16:creationId xmlns:a16="http://schemas.microsoft.com/office/drawing/2014/main" id="{0FD8194F-7075-4F52-AE9A-A62CD3378CD7}"/>
+                <a16:creationId xmlns:a16="http://schemas.microsoft.com/office/drawing/2014/main" id="{8FF54BD8-CA05-410A-9A53-0F2E90BF9902}"/>
               </a:ext>
             </a:extLst>
           </p:cNvPr>
@@ -8737,7 +8794,7 @@
           <p:cNvPr id="4" name="">
             <a:extLst xmlns:a="http://schemas.openxmlformats.org/drawingml/2006/main">
               <a:ext uri="{FF2B5EF4-FFF2-40B4-BE49-F238E27FC236}">
-                <a16:creationId xmlns:a16="http://schemas.microsoft.com/office/drawing/2014/main" id="{035AD410-58A1-4111-91BF-B1A76883534C}"/>
+                <a16:creationId xmlns:a16="http://schemas.microsoft.com/office/drawing/2014/main" id="{CA4FB42F-5FFD-481B-A605-83F4C1772FD2}"/>
               </a:ext>
             </a:extLst>
           </p:cNvPr>
@@ -8794,7 +8851,7 @@
           <p:cNvPr id="5" name="">
             <a:extLst xmlns:a="http://schemas.openxmlformats.org/drawingml/2006/main">
               <a:ext uri="{FF2B5EF4-FFF2-40B4-BE49-F238E27FC236}">
-                <a16:creationId xmlns:a16="http://schemas.microsoft.com/office/drawing/2014/main" id="{EE147622-06CC-406A-ABC2-6E483D714026}"/>
+                <a16:creationId xmlns:a16="http://schemas.microsoft.com/office/drawing/2014/main" id="{8FEBFEAC-1CF3-46DC-AE20-2CDF67AC3368}"/>
               </a:ext>
             </a:extLst>
           </p:cNvPr>
@@ -8829,7 +8886,7 @@
           <p:cNvPr id="6" name="">
             <a:extLst xmlns:a="http://schemas.openxmlformats.org/drawingml/2006/main">
               <a:ext uri="{FF2B5EF4-FFF2-40B4-BE49-F238E27FC236}">
-                <a16:creationId xmlns:a16="http://schemas.microsoft.com/office/drawing/2014/main" id="{3D771ECF-BE37-4587-915C-8D55A393AEFA}"/>
+                <a16:creationId xmlns:a16="http://schemas.microsoft.com/office/drawing/2014/main" id="{A9CFCB55-9E8B-4018-92BD-7AD601B0E0C0}"/>
               </a:ext>
             </a:extLst>
           </p:cNvPr>
@@ -8886,7 +8943,7 @@
           <p:cNvPr id="7" name="">
             <a:extLst xmlns:a="http://schemas.openxmlformats.org/drawingml/2006/main">
               <a:ext uri="{FF2B5EF4-FFF2-40B4-BE49-F238E27FC236}">
-                <a16:creationId xmlns:a16="http://schemas.microsoft.com/office/drawing/2014/main" id="{A5C9EBD3-18D1-41D0-B001-CBC4BB8E8D9B}"/>
+                <a16:creationId xmlns:a16="http://schemas.microsoft.com/office/drawing/2014/main" id="{5361C564-BA2B-41B6-8334-F67DEEBDB577}"/>
               </a:ext>
             </a:extLst>
           </p:cNvPr>
@@ -8943,7 +9000,7 @@
           <p:cNvPr id="8" name="">
             <a:extLst xmlns:a="http://schemas.openxmlformats.org/drawingml/2006/main">
               <a:ext uri="{FF2B5EF4-FFF2-40B4-BE49-F238E27FC236}">
-                <a16:creationId xmlns:a16="http://schemas.microsoft.com/office/drawing/2014/main" id="{8DD29DA8-7E54-489D-84BA-C16495598E36}"/>
+                <a16:creationId xmlns:a16="http://schemas.microsoft.com/office/drawing/2014/main" id="{04800195-04EF-4AC8-97E3-7ADD793A2218}"/>
               </a:ext>
             </a:extLst>
           </p:cNvPr>
@@ -9000,7 +9057,7 @@
           <p:cNvPr id="9" name="">
             <a:extLst xmlns:a="http://schemas.openxmlformats.org/drawingml/2006/main">
               <a:ext uri="{FF2B5EF4-FFF2-40B4-BE49-F238E27FC236}">
-                <a16:creationId xmlns:a16="http://schemas.microsoft.com/office/drawing/2014/main" id="{9C7B50E6-69EE-4833-A7B9-A39F3E5254B5}"/>
+                <a16:creationId xmlns:a16="http://schemas.microsoft.com/office/drawing/2014/main" id="{6D5E8E24-A1F4-4954-896C-EFEBF3F00950}"/>
               </a:ext>
             </a:extLst>
           </p:cNvPr>
@@ -9035,7 +9092,7 @@
           <p:cNvPr id="10" name="">
             <a:extLst xmlns:a="http://schemas.openxmlformats.org/drawingml/2006/main">
               <a:ext uri="{FF2B5EF4-FFF2-40B4-BE49-F238E27FC236}">
-                <a16:creationId xmlns:a16="http://schemas.microsoft.com/office/drawing/2014/main" id="{B479E728-8783-4E89-9013-066AF287A7A0}"/>
+                <a16:creationId xmlns:a16="http://schemas.microsoft.com/office/drawing/2014/main" id="{7A09089C-32CC-41E4-AA03-BA3F80104F6F}"/>
               </a:ext>
             </a:extLst>
           </p:cNvPr>
@@ -9070,7 +9127,7 @@
           <p:cNvPr id="11" name="">
             <a:extLst xmlns:a="http://schemas.openxmlformats.org/drawingml/2006/main">
               <a:ext uri="{FF2B5EF4-FFF2-40B4-BE49-F238E27FC236}">
-                <a16:creationId xmlns:a16="http://schemas.microsoft.com/office/drawing/2014/main" id="{7E6B3AD4-EB1F-447F-A7C0-EF2FA1E294B2}"/>
+                <a16:creationId xmlns:a16="http://schemas.microsoft.com/office/drawing/2014/main" id="{5DA9B373-5BEF-4758-9E63-4345B0736215}"/>
               </a:ext>
             </a:extLst>
           </p:cNvPr>
@@ -9127,7 +9184,7 @@
           <p:cNvPr id="12" name="">
             <a:extLst xmlns:a="http://schemas.openxmlformats.org/drawingml/2006/main">
               <a:ext uri="{FF2B5EF4-FFF2-40B4-BE49-F238E27FC236}">
-                <a16:creationId xmlns:a16="http://schemas.microsoft.com/office/drawing/2014/main" id="{9F4C335F-7668-41D6-80E6-14692A36AEC6}"/>
+                <a16:creationId xmlns:a16="http://schemas.microsoft.com/office/drawing/2014/main" id="{EE6E007D-1D05-4CD3-87F7-D83A6A6015AC}"/>
               </a:ext>
             </a:extLst>
           </p:cNvPr>
@@ -9184,7 +9241,7 @@
           <p:cNvPr id="13" name="">
             <a:extLst xmlns:a="http://schemas.openxmlformats.org/drawingml/2006/main">
               <a:ext uri="{FF2B5EF4-FFF2-40B4-BE49-F238E27FC236}">
-                <a16:creationId xmlns:a16="http://schemas.microsoft.com/office/drawing/2014/main" id="{8CBA2A58-FA06-4D8D-B98D-739C310D63DF}"/>
+                <a16:creationId xmlns:a16="http://schemas.microsoft.com/office/drawing/2014/main" id="{92DF742B-C112-4811-A9EC-821F64920131}"/>
               </a:ext>
             </a:extLst>
           </p:cNvPr>
@@ -9219,7 +9276,7 @@
           <p:cNvPr id="14" name="">
             <a:extLst xmlns:a="http://schemas.openxmlformats.org/drawingml/2006/main">
               <a:ext uri="{FF2B5EF4-FFF2-40B4-BE49-F238E27FC236}">
-                <a16:creationId xmlns:a16="http://schemas.microsoft.com/office/drawing/2014/main" id="{EA3C745B-5BC5-4051-8B19-238C90ED3F7E}"/>
+                <a16:creationId xmlns:a16="http://schemas.microsoft.com/office/drawing/2014/main" id="{77218D4E-D99D-4839-ACB9-B29A06F72685}"/>
               </a:ext>
             </a:extLst>
           </p:cNvPr>
@@ -9254,7 +9311,7 @@
           <p:cNvPr id="15" name="">
             <a:extLst xmlns:a="http://schemas.openxmlformats.org/drawingml/2006/main">
               <a:ext uri="{FF2B5EF4-FFF2-40B4-BE49-F238E27FC236}">
-                <a16:creationId xmlns:a16="http://schemas.microsoft.com/office/drawing/2014/main" id="{B55898CD-68C3-4D23-9D7C-34D04C07D3B0}"/>
+                <a16:creationId xmlns:a16="http://schemas.microsoft.com/office/drawing/2014/main" id="{061138D0-ECDA-45D6-B074-D150920D8BA9}"/>
               </a:ext>
             </a:extLst>
           </p:cNvPr>
@@ -9311,7 +9368,7 @@
           <p:cNvPr id="16" name="">
             <a:extLst xmlns:a="http://schemas.openxmlformats.org/drawingml/2006/main">
               <a:ext uri="{FF2B5EF4-FFF2-40B4-BE49-F238E27FC236}">
-                <a16:creationId xmlns:a16="http://schemas.microsoft.com/office/drawing/2014/main" id="{FFA442A0-78D0-4C96-9086-3E72030785B6}"/>
+                <a16:creationId xmlns:a16="http://schemas.microsoft.com/office/drawing/2014/main" id="{404DDB08-87B9-4FD1-AE63-4F40F2D6AEDF}"/>
               </a:ext>
             </a:extLst>
           </p:cNvPr>
@@ -9368,7 +9425,7 @@
           <p:cNvPr id="17" name="">
             <a:extLst xmlns:a="http://schemas.openxmlformats.org/drawingml/2006/main">
               <a:ext uri="{FF2B5EF4-FFF2-40B4-BE49-F238E27FC236}">
-                <a16:creationId xmlns:a16="http://schemas.microsoft.com/office/drawing/2014/main" id="{E37AACEC-BE5B-4C0D-B870-3A1328A19D1A}"/>
+                <a16:creationId xmlns:a16="http://schemas.microsoft.com/office/drawing/2014/main" id="{40262A50-9F43-463F-BAA1-37449798E64D}"/>
               </a:ext>
             </a:extLst>
           </p:cNvPr>
@@ -9403,7 +9460,7 @@
           <p:cNvPr id="18" name="">
             <a:extLst xmlns:a="http://schemas.openxmlformats.org/drawingml/2006/main">
               <a:ext uri="{FF2B5EF4-FFF2-40B4-BE49-F238E27FC236}">
-                <a16:creationId xmlns:a16="http://schemas.microsoft.com/office/drawing/2014/main" id="{FEC25432-EC31-4DFA-8C7B-91BD404479B1}"/>
+                <a16:creationId xmlns:a16="http://schemas.microsoft.com/office/drawing/2014/main" id="{0F6EF9C4-44E3-4D85-B5C7-00874C90DABC}"/>
               </a:ext>
             </a:extLst>
           </p:cNvPr>
@@ -9438,7 +9495,7 @@
           <p:cNvPr id="19" name="">
             <a:extLst xmlns:a="http://schemas.openxmlformats.org/drawingml/2006/main">
               <a:ext uri="{FF2B5EF4-FFF2-40B4-BE49-F238E27FC236}">
-                <a16:creationId xmlns:a16="http://schemas.microsoft.com/office/drawing/2014/main" id="{BC31BC25-9933-4FE4-9107-14768F39BCDD}"/>
+                <a16:creationId xmlns:a16="http://schemas.microsoft.com/office/drawing/2014/main" id="{980A7029-723E-4200-B61C-4B28992C73CD}"/>
               </a:ext>
             </a:extLst>
           </p:cNvPr>
@@ -9495,7 +9552,7 @@
           <p:cNvPr id="20" name="">
             <a:extLst xmlns:a="http://schemas.openxmlformats.org/drawingml/2006/main">
               <a:ext uri="{FF2B5EF4-FFF2-40B4-BE49-F238E27FC236}">
-                <a16:creationId xmlns:a16="http://schemas.microsoft.com/office/drawing/2014/main" id="{AA053415-9930-45F0-B802-00F59759FF01}"/>
+                <a16:creationId xmlns:a16="http://schemas.microsoft.com/office/drawing/2014/main" id="{0B1F8FE1-CE3B-4EE6-921D-6E97ADD560AA}"/>
               </a:ext>
             </a:extLst>
           </p:cNvPr>
@@ -9552,7 +9609,7 @@
           <p:cNvPr id="21" name="">
             <a:extLst xmlns:a="http://schemas.openxmlformats.org/drawingml/2006/main">
               <a:ext uri="{FF2B5EF4-FFF2-40B4-BE49-F238E27FC236}">
-                <a16:creationId xmlns:a16="http://schemas.microsoft.com/office/drawing/2014/main" id="{C4562E01-1A24-444B-B1B4-4CE706D8A3AE}"/>
+                <a16:creationId xmlns:a16="http://schemas.microsoft.com/office/drawing/2014/main" id="{87C863C7-498E-48B3-A949-8C3F13EF6A42}"/>
               </a:ext>
             </a:extLst>
           </p:cNvPr>
@@ -9587,7 +9644,7 @@
           <p:cNvPr id="22" name="">
             <a:extLst xmlns:a="http://schemas.openxmlformats.org/drawingml/2006/main">
               <a:ext uri="{FF2B5EF4-FFF2-40B4-BE49-F238E27FC236}">
-                <a16:creationId xmlns:a16="http://schemas.microsoft.com/office/drawing/2014/main" id="{9C76E7B8-2E66-4D56-B925-83D1DB391945}"/>
+                <a16:creationId xmlns:a16="http://schemas.microsoft.com/office/drawing/2014/main" id="{645AD368-ED43-4713-A05D-C94D821D01E1}"/>
               </a:ext>
             </a:extLst>
           </p:cNvPr>
@@ -9622,7 +9679,7 @@
           <p:cNvPr id="23" name="">
             <a:extLst xmlns:a="http://schemas.openxmlformats.org/drawingml/2006/main">
               <a:ext uri="{FF2B5EF4-FFF2-40B4-BE49-F238E27FC236}">
-                <a16:creationId xmlns:a16="http://schemas.microsoft.com/office/drawing/2014/main" id="{5AD4E1A3-1F8D-4ED3-9521-00B0335EBC1C}"/>
+                <a16:creationId xmlns:a16="http://schemas.microsoft.com/office/drawing/2014/main" id="{9A6155CD-8FBA-486D-BEFA-93C6AB1C759E}"/>
               </a:ext>
             </a:extLst>
           </p:cNvPr>
@@ -9679,7 +9736,7 @@
           <p:cNvPr id="24" name="">
             <a:extLst xmlns:a="http://schemas.openxmlformats.org/drawingml/2006/main">
               <a:ext uri="{FF2B5EF4-FFF2-40B4-BE49-F238E27FC236}">
-                <a16:creationId xmlns:a16="http://schemas.microsoft.com/office/drawing/2014/main" id="{D97F61F4-335A-495D-8CEC-E8A6F8339131}"/>
+                <a16:creationId xmlns:a16="http://schemas.microsoft.com/office/drawing/2014/main" id="{A49E2061-0222-4983-978C-0438F7221443}"/>
               </a:ext>
             </a:extLst>
           </p:cNvPr>
@@ -9736,7 +9793,7 @@
           <p:cNvPr id="25" name="">
             <a:extLst xmlns:a="http://schemas.openxmlformats.org/drawingml/2006/main">
               <a:ext uri="{FF2B5EF4-FFF2-40B4-BE49-F238E27FC236}">
-                <a16:creationId xmlns:a16="http://schemas.microsoft.com/office/drawing/2014/main" id="{BECBEFC9-8CB3-4D03-BF49-29969688211E}"/>
+                <a16:creationId xmlns:a16="http://schemas.microsoft.com/office/drawing/2014/main" id="{D96CAFE3-0F9C-4D9C-874C-82E29732EABD}"/>
               </a:ext>
             </a:extLst>
           </p:cNvPr>
@@ -9771,7 +9828,7 @@
           <p:cNvPr id="26" name="">
             <a:extLst xmlns:a="http://schemas.openxmlformats.org/drawingml/2006/main">
               <a:ext uri="{FF2B5EF4-FFF2-40B4-BE49-F238E27FC236}">
-                <a16:creationId xmlns:a16="http://schemas.microsoft.com/office/drawing/2014/main" id="{B36EF1D0-88B2-403A-97AB-B596E6EFF4B3}"/>
+                <a16:creationId xmlns:a16="http://schemas.microsoft.com/office/drawing/2014/main" id="{BDCFA1B5-E2AE-4457-9D5F-F556513B2AFC}"/>
               </a:ext>
             </a:extLst>
           </p:cNvPr>
@@ -9806,7 +9863,7 @@
           <p:cNvPr id="27" name="">
             <a:extLst xmlns:a="http://schemas.openxmlformats.org/drawingml/2006/main">
               <a:ext uri="{FF2B5EF4-FFF2-40B4-BE49-F238E27FC236}">
-                <a16:creationId xmlns:a16="http://schemas.microsoft.com/office/drawing/2014/main" id="{26BD34EA-85C2-4481-B756-CCA0464D0E12}"/>
+                <a16:creationId xmlns:a16="http://schemas.microsoft.com/office/drawing/2014/main" id="{3C1121C4-8763-4F2E-8B72-BDD59A679DEC}"/>
               </a:ext>
             </a:extLst>
           </p:cNvPr>
@@ -9863,7 +9920,7 @@
           <p:cNvPr id="28" name="">
             <a:extLst xmlns:a="http://schemas.openxmlformats.org/drawingml/2006/main">
               <a:ext uri="{FF2B5EF4-FFF2-40B4-BE49-F238E27FC236}">
-                <a16:creationId xmlns:a16="http://schemas.microsoft.com/office/drawing/2014/main" id="{9207D82F-2622-478C-B220-3C7BA1974360}"/>
+                <a16:creationId xmlns:a16="http://schemas.microsoft.com/office/drawing/2014/main" id="{A6F284B6-D137-4A32-8894-CE6D4E8C1D6A}"/>
               </a:ext>
             </a:extLst>
           </p:cNvPr>
@@ -9898,7 +9955,7 @@
           <p:cNvPr id="29" name="">
             <a:extLst xmlns:a="http://schemas.openxmlformats.org/drawingml/2006/main">
               <a:ext uri="{FF2B5EF4-FFF2-40B4-BE49-F238E27FC236}">
-                <a16:creationId xmlns:a16="http://schemas.microsoft.com/office/drawing/2014/main" id="{DA45D898-D670-41A7-97E1-C59956401980}"/>
+                <a16:creationId xmlns:a16="http://schemas.microsoft.com/office/drawing/2014/main" id="{F3AFC82D-DE3F-48B8-838A-A20B7672469E}"/>
               </a:ext>
             </a:extLst>
           </p:cNvPr>
@@ -9955,7 +10012,7 @@
           <p:cNvPr id="30" name="">
             <a:extLst xmlns:a="http://schemas.openxmlformats.org/drawingml/2006/main">
               <a:ext uri="{FF2B5EF4-FFF2-40B4-BE49-F238E27FC236}">
-                <a16:creationId xmlns:a16="http://schemas.microsoft.com/office/drawing/2014/main" id="{380DC2D2-04D0-4677-BC18-D78BC5682B63}"/>
+                <a16:creationId xmlns:a16="http://schemas.microsoft.com/office/drawing/2014/main" id="{FC2FF683-752B-4D32-B07F-F12EE73BFBCE}"/>
               </a:ext>
             </a:extLst>
           </p:cNvPr>
@@ -10012,7 +10069,7 @@
           <p:cNvPr id="31" name="">
             <a:extLst xmlns:a="http://schemas.openxmlformats.org/drawingml/2006/main">
               <a:ext uri="{FF2B5EF4-FFF2-40B4-BE49-F238E27FC236}">
-                <a16:creationId xmlns:a16="http://schemas.microsoft.com/office/drawing/2014/main" id="{B2FF9349-5E95-440D-88BF-9C39FF038537}"/>
+                <a16:creationId xmlns:a16="http://schemas.microsoft.com/office/drawing/2014/main" id="{0A99E18A-760F-40BF-AB25-97E68A2FCFF4}"/>
               </a:ext>
             </a:extLst>
           </p:cNvPr>
@@ -10069,7 +10126,7 @@
           <p:cNvPr id="32" name="">
             <a:extLst xmlns:a="http://schemas.openxmlformats.org/drawingml/2006/main">
               <a:ext uri="{FF2B5EF4-FFF2-40B4-BE49-F238E27FC236}">
-                <a16:creationId xmlns:a16="http://schemas.microsoft.com/office/drawing/2014/main" id="{0F57B764-FC35-4B53-B8DB-D14E8BA22CE7}"/>
+                <a16:creationId xmlns:a16="http://schemas.microsoft.com/office/drawing/2014/main" id="{6AB641DE-3358-4DF7-8EB5-3C19FE23BA2D}"/>
               </a:ext>
             </a:extLst>
           </p:cNvPr>
@@ -10104,7 +10161,7 @@
           <p:cNvPr id="33" name="">
             <a:extLst xmlns:a="http://schemas.openxmlformats.org/drawingml/2006/main">
               <a:ext uri="{FF2B5EF4-FFF2-40B4-BE49-F238E27FC236}">
-                <a16:creationId xmlns:a16="http://schemas.microsoft.com/office/drawing/2014/main" id="{6BDDF7FA-358E-45BB-A557-E4DDF74D6E36}"/>
+                <a16:creationId xmlns:a16="http://schemas.microsoft.com/office/drawing/2014/main" id="{6FC9A04A-DC07-44FB-A48C-BBAEA3373657}"/>
               </a:ext>
             </a:extLst>
           </p:cNvPr>
@@ -10188,7 +10245,7 @@
           <p:cNvPr id="34" name="">
             <a:extLst xmlns:a="http://schemas.openxmlformats.org/drawingml/2006/main">
               <a:ext uri="{FF2B5EF4-FFF2-40B4-BE49-F238E27FC236}">
-                <a16:creationId xmlns:a16="http://schemas.microsoft.com/office/drawing/2014/main" id="{6F06F4EE-1F6E-468E-9F76-6973F0BA88E0}"/>
+                <a16:creationId xmlns:a16="http://schemas.microsoft.com/office/drawing/2014/main" id="{10958B8D-E9E8-45A8-9E79-754B5703E412}"/>
               </a:ext>
             </a:extLst>
           </p:cNvPr>
@@ -10245,7 +10302,7 @@
           <p:cNvPr id="35" name="">
             <a:extLst xmlns:a="http://schemas.openxmlformats.org/drawingml/2006/main">
               <a:ext uri="{FF2B5EF4-FFF2-40B4-BE49-F238E27FC236}">
-                <a16:creationId xmlns:a16="http://schemas.microsoft.com/office/drawing/2014/main" id="{69CA1AE7-0958-4C66-BE97-3891002AB25F}"/>
+                <a16:creationId xmlns:a16="http://schemas.microsoft.com/office/drawing/2014/main" id="{6DE8775B-EBF6-4079-8DA6-BC97358651F0}"/>
               </a:ext>
             </a:extLst>
           </p:cNvPr>
@@ -10300,7 +10357,7 @@
     </p:spTree>
     <p:extLst>
       <p:ext uri="{BB962C8B-B14F-4D97-AF65-F5344CB8AC3E}">
-        <p14:creationId xmlns:p14="http://schemas.microsoft.com/office/powerpoint/2010/main" val="309231714"/>
+        <p14:creationId xmlns:p14="http://schemas.microsoft.com/office/powerpoint/2010/main" val="680111935"/>
       </p:ext>
     </p:extLst>
   </p:cSld>
@@ -10331,7 +10388,7 @@
           <p:cNvPr id="1" name="kicker-marker">
             <a:extLst xmlns:a="http://schemas.openxmlformats.org/drawingml/2006/main">
               <a:ext uri="{FF2B5EF4-FFF2-40B4-BE49-F238E27FC236}">
-                <a16:creationId xmlns:a16="http://schemas.microsoft.com/office/drawing/2014/main" id="{6989BBA4-8366-407C-8EA8-209E58C08634}"/>
+                <a16:creationId xmlns:a16="http://schemas.microsoft.com/office/drawing/2014/main" id="{ECFEFFBD-76F2-4A35-889B-9000BC46A9FE}"/>
               </a:ext>
             </a:extLst>
           </p:cNvPr>
@@ -10366,7 +10423,7 @@
           <p:cNvPr id="2" name="kicker-label">
             <a:extLst xmlns:a="http://schemas.openxmlformats.org/drawingml/2006/main">
               <a:ext uri="{FF2B5EF4-FFF2-40B4-BE49-F238E27FC236}">
-                <a16:creationId xmlns:a16="http://schemas.microsoft.com/office/drawing/2014/main" id="{CF5D2E0C-D573-45EB-BD8C-20ED7DFB2163}"/>
+                <a16:creationId xmlns:a16="http://schemas.microsoft.com/office/drawing/2014/main" id="{E4B6FD1C-71ED-4677-B1FA-84205797C93A}"/>
               </a:ext>
             </a:extLst>
           </p:cNvPr>
@@ -10423,7 +10480,7 @@
           <p:cNvPr id="3" name="">
             <a:extLst xmlns:a="http://schemas.openxmlformats.org/drawingml/2006/main">
               <a:ext uri="{FF2B5EF4-FFF2-40B4-BE49-F238E27FC236}">
-                <a16:creationId xmlns:a16="http://schemas.microsoft.com/office/drawing/2014/main" id="{B8EFF9E7-8B84-41B0-9D02-573C51B023A0}"/>
+                <a16:creationId xmlns:a16="http://schemas.microsoft.com/office/drawing/2014/main" id="{CCF66F80-89F7-4606-812B-65224B300C49}"/>
               </a:ext>
             </a:extLst>
           </p:cNvPr>
@@ -10480,7 +10537,7 @@
           <p:cNvPr id="4" name="">
             <a:extLst xmlns:a="http://schemas.openxmlformats.org/drawingml/2006/main">
               <a:ext uri="{FF2B5EF4-FFF2-40B4-BE49-F238E27FC236}">
-                <a16:creationId xmlns:a16="http://schemas.microsoft.com/office/drawing/2014/main" id="{60281A34-BBE7-4642-9DF9-55196C8C6A44}"/>
+                <a16:creationId xmlns:a16="http://schemas.microsoft.com/office/drawing/2014/main" id="{66FFE1B3-647C-4AD4-B935-ED0C805CA67B}"/>
               </a:ext>
             </a:extLst>
           </p:cNvPr>
@@ -10515,7 +10572,7 @@
           <p:cNvPr id="5" name="">
             <a:extLst xmlns:a="http://schemas.openxmlformats.org/drawingml/2006/main">
               <a:ext uri="{FF2B5EF4-FFF2-40B4-BE49-F238E27FC236}">
-                <a16:creationId xmlns:a16="http://schemas.microsoft.com/office/drawing/2014/main" id="{0952C1D4-FE33-46E8-A14D-715248F94FAE}"/>
+                <a16:creationId xmlns:a16="http://schemas.microsoft.com/office/drawing/2014/main" id="{029A01E9-F9FF-4E2C-98E0-31113AEEEFAB}"/>
               </a:ext>
             </a:extLst>
           </p:cNvPr>
@@ -10572,7 +10629,7 @@
           <p:cNvPr id="6" name="">
             <a:extLst xmlns:a="http://schemas.openxmlformats.org/drawingml/2006/main">
               <a:ext uri="{FF2B5EF4-FFF2-40B4-BE49-F238E27FC236}">
-                <a16:creationId xmlns:a16="http://schemas.microsoft.com/office/drawing/2014/main" id="{2217D0DB-9ED5-4AFC-8A62-CD60CC7A85B1}"/>
+                <a16:creationId xmlns:a16="http://schemas.microsoft.com/office/drawing/2014/main" id="{32F0FF88-4199-4FB8-A630-321879416FBC}"/>
               </a:ext>
             </a:extLst>
           </p:cNvPr>
@@ -10629,7 +10686,7 @@
           <p:cNvPr id="7" name="">
             <a:extLst xmlns:a="http://schemas.openxmlformats.org/drawingml/2006/main">
               <a:ext uri="{FF2B5EF4-FFF2-40B4-BE49-F238E27FC236}">
-                <a16:creationId xmlns:a16="http://schemas.microsoft.com/office/drawing/2014/main" id="{0BD466B0-4D2B-48CE-BD7C-0FDAF1A9752B}"/>
+                <a16:creationId xmlns:a16="http://schemas.microsoft.com/office/drawing/2014/main" id="{AA1BD527-C4A6-4AB0-A802-FDCCEC04E781}"/>
               </a:ext>
             </a:extLst>
           </p:cNvPr>
@@ -10662,7 +10719,7 @@
           <p:cNvPr id="8" name="">
             <a:extLst xmlns:a="http://schemas.openxmlformats.org/drawingml/2006/main">
               <a:ext uri="{FF2B5EF4-FFF2-40B4-BE49-F238E27FC236}">
-                <a16:creationId xmlns:a16="http://schemas.microsoft.com/office/drawing/2014/main" id="{942B5D08-6A69-4C8F-A6F5-E736197F25D8}"/>
+                <a16:creationId xmlns:a16="http://schemas.microsoft.com/office/drawing/2014/main" id="{D7413BA5-8BE1-4280-9D0C-EBB5AD611A03}"/>
               </a:ext>
             </a:extLst>
           </p:cNvPr>
@@ -10719,7 +10776,7 @@
           <p:cNvPr id="9" name="">
             <a:extLst xmlns:a="http://schemas.openxmlformats.org/drawingml/2006/main">
               <a:ext uri="{FF2B5EF4-FFF2-40B4-BE49-F238E27FC236}">
-                <a16:creationId xmlns:a16="http://schemas.microsoft.com/office/drawing/2014/main" id="{58360234-05AF-40B8-85AA-7230DC41943C}"/>
+                <a16:creationId xmlns:a16="http://schemas.microsoft.com/office/drawing/2014/main" id="{8CE0CB15-B468-426D-B0FE-E5C2BA4C3CFB}"/>
               </a:ext>
             </a:extLst>
           </p:cNvPr>
@@ -10776,7 +10833,7 @@
           <p:cNvPr id="10" name="">
             <a:extLst xmlns:a="http://schemas.openxmlformats.org/drawingml/2006/main">
               <a:ext uri="{FF2B5EF4-FFF2-40B4-BE49-F238E27FC236}">
-                <a16:creationId xmlns:a16="http://schemas.microsoft.com/office/drawing/2014/main" id="{7411FD2B-0721-41E2-9B72-A07EB9EF48A8}"/>
+                <a16:creationId xmlns:a16="http://schemas.microsoft.com/office/drawing/2014/main" id="{B4072A94-836C-4E0C-9868-D43CF56B8780}"/>
               </a:ext>
             </a:extLst>
           </p:cNvPr>
@@ -10811,7 +10868,7 @@
           <p:cNvPr id="11" name="">
             <a:extLst xmlns:a="http://schemas.openxmlformats.org/drawingml/2006/main">
               <a:ext uri="{FF2B5EF4-FFF2-40B4-BE49-F238E27FC236}">
-                <a16:creationId xmlns:a16="http://schemas.microsoft.com/office/drawing/2014/main" id="{53B132C0-D722-40F5-8718-8AE1D8F4D040}"/>
+                <a16:creationId xmlns:a16="http://schemas.microsoft.com/office/drawing/2014/main" id="{0B9586F4-84F4-4432-8D20-A5D3F1BCF6AD}"/>
               </a:ext>
             </a:extLst>
           </p:cNvPr>
@@ -10844,7 +10901,7 @@
           <p:cNvPr id="12" name="">
             <a:extLst xmlns:a="http://schemas.openxmlformats.org/drawingml/2006/main">
               <a:ext uri="{FF2B5EF4-FFF2-40B4-BE49-F238E27FC236}">
-                <a16:creationId xmlns:a16="http://schemas.microsoft.com/office/drawing/2014/main" id="{3FB9F40A-3BCF-4473-A64A-73C67BFFF4EC}"/>
+                <a16:creationId xmlns:a16="http://schemas.microsoft.com/office/drawing/2014/main" id="{73FAAE10-7BA0-410C-88C9-5F2199539E90}"/>
               </a:ext>
             </a:extLst>
           </p:cNvPr>
@@ -10901,7 +10958,7 @@
           <p:cNvPr id="13" name="">
             <a:extLst xmlns:a="http://schemas.openxmlformats.org/drawingml/2006/main">
               <a:ext uri="{FF2B5EF4-FFF2-40B4-BE49-F238E27FC236}">
-                <a16:creationId xmlns:a16="http://schemas.microsoft.com/office/drawing/2014/main" id="{1E3AAAB6-DC83-4E61-99A7-C3B504EEFA45}"/>
+                <a16:creationId xmlns:a16="http://schemas.microsoft.com/office/drawing/2014/main" id="{C7CC42D7-501F-474C-8B35-4D396E79BCC9}"/>
               </a:ext>
             </a:extLst>
           </p:cNvPr>
@@ -11039,7 +11096,7 @@
           <p:cNvPr id="14" name="">
             <a:extLst xmlns:a="http://schemas.openxmlformats.org/drawingml/2006/main">
               <a:ext uri="{FF2B5EF4-FFF2-40B4-BE49-F238E27FC236}">
-                <a16:creationId xmlns:a16="http://schemas.microsoft.com/office/drawing/2014/main" id="{0E5809DB-35EA-4590-A07A-DE16605B3D53}"/>
+                <a16:creationId xmlns:a16="http://schemas.microsoft.com/office/drawing/2014/main" id="{D0D6B5BD-250E-4677-B1C0-C9CA6F5B90A0}"/>
               </a:ext>
             </a:extLst>
           </p:cNvPr>
@@ -11074,7 +11131,7 @@
           <p:cNvPr id="15" name="">
             <a:extLst xmlns:a="http://schemas.openxmlformats.org/drawingml/2006/main">
               <a:ext uri="{FF2B5EF4-FFF2-40B4-BE49-F238E27FC236}">
-                <a16:creationId xmlns:a16="http://schemas.microsoft.com/office/drawing/2014/main" id="{4A7EEE01-6539-4058-AE56-0C55B1372888}"/>
+                <a16:creationId xmlns:a16="http://schemas.microsoft.com/office/drawing/2014/main" id="{2CAA2024-25E6-4826-9097-21BE20E59018}"/>
               </a:ext>
             </a:extLst>
           </p:cNvPr>
@@ -11107,7 +11164,7 @@
           <p:cNvPr id="16" name="">
             <a:extLst xmlns:a="http://schemas.openxmlformats.org/drawingml/2006/main">
               <a:ext uri="{FF2B5EF4-FFF2-40B4-BE49-F238E27FC236}">
-                <a16:creationId xmlns:a16="http://schemas.microsoft.com/office/drawing/2014/main" id="{C208DE32-7FDC-44AA-87EA-96F3E1D2E9E2}"/>
+                <a16:creationId xmlns:a16="http://schemas.microsoft.com/office/drawing/2014/main" id="{7F87195E-4B22-4AD4-A053-8B5D0971B5C2}"/>
               </a:ext>
             </a:extLst>
           </p:cNvPr>
@@ -11164,7 +11221,7 @@
           <p:cNvPr id="17" name="">
             <a:extLst xmlns:a="http://schemas.openxmlformats.org/drawingml/2006/main">
               <a:ext uri="{FF2B5EF4-FFF2-40B4-BE49-F238E27FC236}">
-                <a16:creationId xmlns:a16="http://schemas.microsoft.com/office/drawing/2014/main" id="{3FADD62B-1170-4516-A629-FD345C56F2D2}"/>
+                <a16:creationId xmlns:a16="http://schemas.microsoft.com/office/drawing/2014/main" id="{857EF978-3A01-45A7-A3A6-DCB7FDDA62D3}"/>
               </a:ext>
             </a:extLst>
           </p:cNvPr>
@@ -11275,7 +11332,7 @@
           <p:cNvPr id="18" name="">
             <a:extLst xmlns:a="http://schemas.openxmlformats.org/drawingml/2006/main">
               <a:ext uri="{FF2B5EF4-FFF2-40B4-BE49-F238E27FC236}">
-                <a16:creationId xmlns:a16="http://schemas.microsoft.com/office/drawing/2014/main" id="{90CB045C-F780-4A9C-A34F-F0E68823AD23}"/>
+                <a16:creationId xmlns:a16="http://schemas.microsoft.com/office/drawing/2014/main" id="{D57649FD-F240-41B5-848D-47EEEF3940EE}"/>
               </a:ext>
             </a:extLst>
           </p:cNvPr>
@@ -11330,7 +11387,7 @@
     </p:spTree>
     <p:extLst>
       <p:ext uri="{BB962C8B-B14F-4D97-AF65-F5344CB8AC3E}">
-        <p14:creationId xmlns:p14="http://schemas.microsoft.com/office/powerpoint/2010/main" val="736287431"/>
+        <p14:creationId xmlns:p14="http://schemas.microsoft.com/office/powerpoint/2010/main" val="1122780708"/>
       </p:ext>
     </p:extLst>
   </p:cSld>
@@ -11361,7 +11418,7 @@
           <p:cNvPr id="1" name="kicker-marker">
             <a:extLst xmlns:a="http://schemas.openxmlformats.org/drawingml/2006/main">
               <a:ext uri="{FF2B5EF4-FFF2-40B4-BE49-F238E27FC236}">
-                <a16:creationId xmlns:a16="http://schemas.microsoft.com/office/drawing/2014/main" id="{8827EDF8-0332-4FD9-BA06-3D81A20AB094}"/>
+                <a16:creationId xmlns:a16="http://schemas.microsoft.com/office/drawing/2014/main" id="{A879D66A-C219-4501-A5C8-BE7C84E99889}"/>
               </a:ext>
             </a:extLst>
           </p:cNvPr>
@@ -11396,7 +11453,7 @@
           <p:cNvPr id="2" name="kicker-label">
             <a:extLst xmlns:a="http://schemas.openxmlformats.org/drawingml/2006/main">
               <a:ext uri="{FF2B5EF4-FFF2-40B4-BE49-F238E27FC236}">
-                <a16:creationId xmlns:a16="http://schemas.microsoft.com/office/drawing/2014/main" id="{68138569-FD69-4A1F-8F15-4D5E9A43912F}"/>
+                <a16:creationId xmlns:a16="http://schemas.microsoft.com/office/drawing/2014/main" id="{3F801202-360D-4BBF-8CF0-6B8FF1E5E929}"/>
               </a:ext>
             </a:extLst>
           </p:cNvPr>
@@ -11453,7 +11510,7 @@
           <p:cNvPr id="3" name="">
             <a:extLst xmlns:a="http://schemas.openxmlformats.org/drawingml/2006/main">
               <a:ext uri="{FF2B5EF4-FFF2-40B4-BE49-F238E27FC236}">
-                <a16:creationId xmlns:a16="http://schemas.microsoft.com/office/drawing/2014/main" id="{6E8C370F-DC0B-4142-8F47-1A93269E9AB7}"/>
+                <a16:creationId xmlns:a16="http://schemas.microsoft.com/office/drawing/2014/main" id="{2173993F-72D7-4F01-A7E6-A7D8011983D7}"/>
               </a:ext>
             </a:extLst>
           </p:cNvPr>
@@ -11510,7 +11567,7 @@
           <p:cNvPr id="4" name="">
             <a:extLst xmlns:a="http://schemas.openxmlformats.org/drawingml/2006/main">
               <a:ext uri="{FF2B5EF4-FFF2-40B4-BE49-F238E27FC236}">
-                <a16:creationId xmlns:a16="http://schemas.microsoft.com/office/drawing/2014/main" id="{69FDDC10-0C70-4A66-8AA1-A0727127B9DE}"/>
+                <a16:creationId xmlns:a16="http://schemas.microsoft.com/office/drawing/2014/main" id="{44ECB12F-7D71-44F1-89A6-FFA42652DE06}"/>
               </a:ext>
             </a:extLst>
           </p:cNvPr>
@@ -11545,7 +11602,7 @@
           <p:cNvPr id="5" name="">
             <a:extLst xmlns:a="http://schemas.openxmlformats.org/drawingml/2006/main">
               <a:ext uri="{FF2B5EF4-FFF2-40B4-BE49-F238E27FC236}">
-                <a16:creationId xmlns:a16="http://schemas.microsoft.com/office/drawing/2014/main" id="{E4C7E03E-C8E5-4D25-A4B0-6C1797BF4662}"/>
+                <a16:creationId xmlns:a16="http://schemas.microsoft.com/office/drawing/2014/main" id="{E16B4003-9DF1-4370-BF1B-71931155146E}"/>
               </a:ext>
             </a:extLst>
           </p:cNvPr>
@@ -11602,7 +11659,7 @@
           <p:cNvPr id="6" name="">
             <a:extLst xmlns:a="http://schemas.openxmlformats.org/drawingml/2006/main">
               <a:ext uri="{FF2B5EF4-FFF2-40B4-BE49-F238E27FC236}">
-                <a16:creationId xmlns:a16="http://schemas.microsoft.com/office/drawing/2014/main" id="{A9DA0AEA-F216-4389-892B-1EEB68D1F46D}"/>
+                <a16:creationId xmlns:a16="http://schemas.microsoft.com/office/drawing/2014/main" id="{17FBF279-A310-4B44-B52C-20B8FAF418CA}"/>
               </a:ext>
             </a:extLst>
           </p:cNvPr>
@@ -11659,7 +11716,7 @@
           <p:cNvPr id="7" name="">
             <a:extLst xmlns:a="http://schemas.openxmlformats.org/drawingml/2006/main">
               <a:ext uri="{FF2B5EF4-FFF2-40B4-BE49-F238E27FC236}">
-                <a16:creationId xmlns:a16="http://schemas.microsoft.com/office/drawing/2014/main" id="{3A78A4F8-0C51-40E7-A5D3-DE446A7E7CB3}"/>
+                <a16:creationId xmlns:a16="http://schemas.microsoft.com/office/drawing/2014/main" id="{F27DC4F1-4DC3-4786-8BA8-BDC63D6102DB}"/>
               </a:ext>
             </a:extLst>
           </p:cNvPr>
@@ -11694,7 +11751,7 @@
           <p:cNvPr id="8" name="">
             <a:extLst xmlns:a="http://schemas.openxmlformats.org/drawingml/2006/main">
               <a:ext uri="{FF2B5EF4-FFF2-40B4-BE49-F238E27FC236}">
-                <a16:creationId xmlns:a16="http://schemas.microsoft.com/office/drawing/2014/main" id="{F9C803A3-80B1-4DAF-87FB-B0309E83CD9D}"/>
+                <a16:creationId xmlns:a16="http://schemas.microsoft.com/office/drawing/2014/main" id="{84622651-7E1A-4DD7-B337-040E65D136F6}"/>
               </a:ext>
             </a:extLst>
           </p:cNvPr>
@@ -11729,7 +11786,7 @@
           <p:cNvPr id="9" name="">
             <a:extLst xmlns:a="http://schemas.openxmlformats.org/drawingml/2006/main">
               <a:ext uri="{FF2B5EF4-FFF2-40B4-BE49-F238E27FC236}">
-                <a16:creationId xmlns:a16="http://schemas.microsoft.com/office/drawing/2014/main" id="{2816E627-96B9-498B-9A2F-2D480777D86A}"/>
+                <a16:creationId xmlns:a16="http://schemas.microsoft.com/office/drawing/2014/main" id="{C5C0FE12-3832-4082-89B2-4F85B55FD060}"/>
               </a:ext>
             </a:extLst>
           </p:cNvPr>
@@ -11786,7 +11843,7 @@
           <p:cNvPr id="10" name="">
             <a:extLst xmlns:a="http://schemas.openxmlformats.org/drawingml/2006/main">
               <a:ext uri="{FF2B5EF4-FFF2-40B4-BE49-F238E27FC236}">
-                <a16:creationId xmlns:a16="http://schemas.microsoft.com/office/drawing/2014/main" id="{503802A4-AEB9-48DF-8082-694D86497D33}"/>
+                <a16:creationId xmlns:a16="http://schemas.microsoft.com/office/drawing/2014/main" id="{B640A7B5-2163-42A4-9D81-54800BA0E8D9}"/>
               </a:ext>
             </a:extLst>
           </p:cNvPr>
@@ -11821,7 +11878,7 @@
           <p:cNvPr id="11" name="">
             <a:extLst xmlns:a="http://schemas.openxmlformats.org/drawingml/2006/main">
               <a:ext uri="{FF2B5EF4-FFF2-40B4-BE49-F238E27FC236}">
-                <a16:creationId xmlns:a16="http://schemas.microsoft.com/office/drawing/2014/main" id="{2BAEF4BC-6EB3-4979-B4F2-02860630FE74}"/>
+                <a16:creationId xmlns:a16="http://schemas.microsoft.com/office/drawing/2014/main" id="{24C15596-1560-4D1E-8D72-DE565F0C3C27}"/>
               </a:ext>
             </a:extLst>
           </p:cNvPr>
@@ -11856,7 +11913,7 @@
           <p:cNvPr id="12" name="">
             <a:extLst xmlns:a="http://schemas.openxmlformats.org/drawingml/2006/main">
               <a:ext uri="{FF2B5EF4-FFF2-40B4-BE49-F238E27FC236}">
-                <a16:creationId xmlns:a16="http://schemas.microsoft.com/office/drawing/2014/main" id="{96747B7E-5DEA-45B2-BC3A-94A8C8E11961}"/>
+                <a16:creationId xmlns:a16="http://schemas.microsoft.com/office/drawing/2014/main" id="{E8EE56FC-C5BA-4A26-B03C-2F16926E5E96}"/>
               </a:ext>
             </a:extLst>
           </p:cNvPr>
@@ -11891,7 +11948,7 @@
           <p:cNvPr id="13" name="">
             <a:extLst xmlns:a="http://schemas.openxmlformats.org/drawingml/2006/main">
               <a:ext uri="{FF2B5EF4-FFF2-40B4-BE49-F238E27FC236}">
-                <a16:creationId xmlns:a16="http://schemas.microsoft.com/office/drawing/2014/main" id="{9BAE2CA5-368C-46D9-8F1B-608BCF1482B1}"/>
+                <a16:creationId xmlns:a16="http://schemas.microsoft.com/office/drawing/2014/main" id="{46CB9D37-579B-446B-B112-36130616A70A}"/>
               </a:ext>
             </a:extLst>
           </p:cNvPr>
@@ -11926,7 +11983,7 @@
           <p:cNvPr id="14" name="">
             <a:extLst xmlns:a="http://schemas.openxmlformats.org/drawingml/2006/main">
               <a:ext uri="{FF2B5EF4-FFF2-40B4-BE49-F238E27FC236}">
-                <a16:creationId xmlns:a16="http://schemas.microsoft.com/office/drawing/2014/main" id="{8429F855-3F16-491E-AF50-3FA7462307DF}"/>
+                <a16:creationId xmlns:a16="http://schemas.microsoft.com/office/drawing/2014/main" id="{05E33097-94DA-48E7-8684-A8905D03D64D}"/>
               </a:ext>
             </a:extLst>
           </p:cNvPr>
@@ -11961,7 +12018,7 @@
           <p:cNvPr id="15" name="">
             <a:extLst xmlns:a="http://schemas.openxmlformats.org/drawingml/2006/main">
               <a:ext uri="{FF2B5EF4-FFF2-40B4-BE49-F238E27FC236}">
-                <a16:creationId xmlns:a16="http://schemas.microsoft.com/office/drawing/2014/main" id="{01515FEC-D7F6-4410-85A5-E3E7B30DD43F}"/>
+                <a16:creationId xmlns:a16="http://schemas.microsoft.com/office/drawing/2014/main" id="{069FA901-B912-4E2E-9E74-E97B1747242F}"/>
               </a:ext>
             </a:extLst>
           </p:cNvPr>
@@ -11996,7 +12053,7 @@
           <p:cNvPr id="16" name="">
             <a:extLst xmlns:a="http://schemas.openxmlformats.org/drawingml/2006/main">
               <a:ext uri="{FF2B5EF4-FFF2-40B4-BE49-F238E27FC236}">
-                <a16:creationId xmlns:a16="http://schemas.microsoft.com/office/drawing/2014/main" id="{3D919C4C-8A5A-4759-8DB7-395645A6EBA2}"/>
+                <a16:creationId xmlns:a16="http://schemas.microsoft.com/office/drawing/2014/main" id="{E1D37762-58E8-432C-A468-64E3BCD948DE}"/>
               </a:ext>
             </a:extLst>
           </p:cNvPr>
@@ -12053,7 +12110,7 @@
           <p:cNvPr id="17" name="">
             <a:extLst xmlns:a="http://schemas.openxmlformats.org/drawingml/2006/main">
               <a:ext uri="{FF2B5EF4-FFF2-40B4-BE49-F238E27FC236}">
-                <a16:creationId xmlns:a16="http://schemas.microsoft.com/office/drawing/2014/main" id="{B0CD291D-302C-45B6-A893-55F18EF2584E}"/>
+                <a16:creationId xmlns:a16="http://schemas.microsoft.com/office/drawing/2014/main" id="{8E1BF622-57BD-4EB7-B802-CE953E86037F}"/>
               </a:ext>
             </a:extLst>
           </p:cNvPr>
@@ -12088,7 +12145,7 @@
           <p:cNvPr id="18" name="">
             <a:extLst xmlns:a="http://schemas.openxmlformats.org/drawingml/2006/main">
               <a:ext uri="{FF2B5EF4-FFF2-40B4-BE49-F238E27FC236}">
-                <a16:creationId xmlns:a16="http://schemas.microsoft.com/office/drawing/2014/main" id="{AFE8572E-7568-4EDC-A4D8-F00A13A07F60}"/>
+                <a16:creationId xmlns:a16="http://schemas.microsoft.com/office/drawing/2014/main" id="{C85A749A-8E6A-41AF-A812-4A655EB369CB}"/>
               </a:ext>
             </a:extLst>
           </p:cNvPr>
@@ -12145,7 +12202,7 @@
           <p:cNvPr id="19" name="">
             <a:extLst xmlns:a="http://schemas.openxmlformats.org/drawingml/2006/main">
               <a:ext uri="{FF2B5EF4-FFF2-40B4-BE49-F238E27FC236}">
-                <a16:creationId xmlns:a16="http://schemas.microsoft.com/office/drawing/2014/main" id="{41471484-1320-499C-9A29-2F7A5455C5FF}"/>
+                <a16:creationId xmlns:a16="http://schemas.microsoft.com/office/drawing/2014/main" id="{FF159D2E-1AF0-4625-9A7F-FA7002E0BC34}"/>
               </a:ext>
             </a:extLst>
           </p:cNvPr>
@@ -12180,7 +12237,7 @@
           <p:cNvPr id="20" name="">
             <a:extLst xmlns:a="http://schemas.openxmlformats.org/drawingml/2006/main">
               <a:ext uri="{FF2B5EF4-FFF2-40B4-BE49-F238E27FC236}">
-                <a16:creationId xmlns:a16="http://schemas.microsoft.com/office/drawing/2014/main" id="{0FF4EA4E-3881-4952-9828-7E4CFB8FEE24}"/>
+                <a16:creationId xmlns:a16="http://schemas.microsoft.com/office/drawing/2014/main" id="{23EA3A2C-9BD5-4235-8E19-EAFDFFC81426}"/>
               </a:ext>
             </a:extLst>
           </p:cNvPr>
@@ -12237,7 +12294,7 @@
           <p:cNvPr id="21" name="">
             <a:extLst xmlns:a="http://schemas.openxmlformats.org/drawingml/2006/main">
               <a:ext uri="{FF2B5EF4-FFF2-40B4-BE49-F238E27FC236}">
-                <a16:creationId xmlns:a16="http://schemas.microsoft.com/office/drawing/2014/main" id="{F9DE9A89-76F9-41E3-88B0-B31CD5C77CE5}"/>
+                <a16:creationId xmlns:a16="http://schemas.microsoft.com/office/drawing/2014/main" id="{1C5375B2-7008-472B-BE28-2832B2D14DD6}"/>
               </a:ext>
             </a:extLst>
           </p:cNvPr>
@@ -12272,7 +12329,7 @@
           <p:cNvPr id="22" name="">
             <a:extLst xmlns:a="http://schemas.openxmlformats.org/drawingml/2006/main">
               <a:ext uri="{FF2B5EF4-FFF2-40B4-BE49-F238E27FC236}">
-                <a16:creationId xmlns:a16="http://schemas.microsoft.com/office/drawing/2014/main" id="{4721C058-1026-41E5-939E-EBB6776FA3F1}"/>
+                <a16:creationId xmlns:a16="http://schemas.microsoft.com/office/drawing/2014/main" id="{50DF33ED-A708-43D0-96A1-606F815CA238}"/>
               </a:ext>
             </a:extLst>
           </p:cNvPr>
@@ -12329,7 +12386,7 @@
           <p:cNvPr id="23" name="">
             <a:extLst xmlns:a="http://schemas.openxmlformats.org/drawingml/2006/main">
               <a:ext uri="{FF2B5EF4-FFF2-40B4-BE49-F238E27FC236}">
-                <a16:creationId xmlns:a16="http://schemas.microsoft.com/office/drawing/2014/main" id="{C835A525-D186-4BB0-8E1F-E8A615A84534}"/>
+                <a16:creationId xmlns:a16="http://schemas.microsoft.com/office/drawing/2014/main" id="{A418F22D-FBB6-4C7E-B7C8-B3984B1D7F51}"/>
               </a:ext>
             </a:extLst>
           </p:cNvPr>
@@ -12364,7 +12421,7 @@
           <p:cNvPr id="24" name="">
             <a:extLst xmlns:a="http://schemas.openxmlformats.org/drawingml/2006/main">
               <a:ext uri="{FF2B5EF4-FFF2-40B4-BE49-F238E27FC236}">
-                <a16:creationId xmlns:a16="http://schemas.microsoft.com/office/drawing/2014/main" id="{BEF59D23-1148-4A1E-B858-C6624D3F64A9}"/>
+                <a16:creationId xmlns:a16="http://schemas.microsoft.com/office/drawing/2014/main" id="{00C3C533-76C4-40C8-BC37-A170C010BDF8}"/>
               </a:ext>
             </a:extLst>
           </p:cNvPr>
@@ -12421,7 +12478,7 @@
           <p:cNvPr id="25" name="">
             <a:extLst xmlns:a="http://schemas.openxmlformats.org/drawingml/2006/main">
               <a:ext uri="{FF2B5EF4-FFF2-40B4-BE49-F238E27FC236}">
-                <a16:creationId xmlns:a16="http://schemas.microsoft.com/office/drawing/2014/main" id="{CD66F9C7-8C99-4FF3-A8F6-12CC112E20C4}"/>
+                <a16:creationId xmlns:a16="http://schemas.microsoft.com/office/drawing/2014/main" id="{FF35AF1B-734E-4833-A623-4A2A52EBDF50}"/>
               </a:ext>
             </a:extLst>
           </p:cNvPr>
@@ -12476,7 +12533,7 @@
     </p:spTree>
     <p:extLst>
       <p:ext uri="{BB962C8B-B14F-4D97-AF65-F5344CB8AC3E}">
-        <p14:creationId xmlns:p14="http://schemas.microsoft.com/office/powerpoint/2010/main" val="266683244"/>
+        <p14:creationId xmlns:p14="http://schemas.microsoft.com/office/powerpoint/2010/main" val="457478370"/>
       </p:ext>
     </p:extLst>
   </p:cSld>
@@ -12507,7 +12564,7 @@
           <p:cNvPr id="1" name="kicker-marker">
             <a:extLst xmlns:a="http://schemas.openxmlformats.org/drawingml/2006/main">
               <a:ext uri="{FF2B5EF4-FFF2-40B4-BE49-F238E27FC236}">
-                <a16:creationId xmlns:a16="http://schemas.microsoft.com/office/drawing/2014/main" id="{08F74556-188D-4F71-A3C3-ABD3E8E44828}"/>
+                <a16:creationId xmlns:a16="http://schemas.microsoft.com/office/drawing/2014/main" id="{0724E11D-05A3-4D49-AAA7-C0B9DE68BA0D}"/>
               </a:ext>
             </a:extLst>
           </p:cNvPr>
@@ -12542,7 +12599,7 @@
           <p:cNvPr id="2" name="kicker-label">
             <a:extLst xmlns:a="http://schemas.openxmlformats.org/drawingml/2006/main">
               <a:ext uri="{FF2B5EF4-FFF2-40B4-BE49-F238E27FC236}">
-                <a16:creationId xmlns:a16="http://schemas.microsoft.com/office/drawing/2014/main" id="{18019D25-7D9E-4FD8-BC12-73940F09C9F7}"/>
+                <a16:creationId xmlns:a16="http://schemas.microsoft.com/office/drawing/2014/main" id="{8C31DB25-8623-4FC0-AE2C-A22D13F8C43A}"/>
               </a:ext>
             </a:extLst>
           </p:cNvPr>
@@ -12599,7 +12656,7 @@
           <p:cNvPr id="3" name="">
             <a:extLst xmlns:a="http://schemas.openxmlformats.org/drawingml/2006/main">
               <a:ext uri="{FF2B5EF4-FFF2-40B4-BE49-F238E27FC236}">
-                <a16:creationId xmlns:a16="http://schemas.microsoft.com/office/drawing/2014/main" id="{AF0ADB85-9DD5-41B5-BF5F-0B23722E8EA9}"/>
+                <a16:creationId xmlns:a16="http://schemas.microsoft.com/office/drawing/2014/main" id="{622BB40E-3C9E-410D-BE0E-E3258052C4D2}"/>
               </a:ext>
             </a:extLst>
           </p:cNvPr>
@@ -12656,7 +12713,7 @@
           <p:cNvPr id="4" name="">
             <a:extLst xmlns:a="http://schemas.openxmlformats.org/drawingml/2006/main">
               <a:ext uri="{FF2B5EF4-FFF2-40B4-BE49-F238E27FC236}">
-                <a16:creationId xmlns:a16="http://schemas.microsoft.com/office/drawing/2014/main" id="{D6781206-50F9-44E0-B255-080DC40B1D56}"/>
+                <a16:creationId xmlns:a16="http://schemas.microsoft.com/office/drawing/2014/main" id="{C3DA2661-4F86-4913-A00A-C09342EB9E42}"/>
               </a:ext>
             </a:extLst>
           </p:cNvPr>
@@ -12713,7 +12770,7 @@
           <p:cNvPr id="5" name="">
             <a:extLst xmlns:a="http://schemas.openxmlformats.org/drawingml/2006/main">
               <a:ext uri="{FF2B5EF4-FFF2-40B4-BE49-F238E27FC236}">
-                <a16:creationId xmlns:a16="http://schemas.microsoft.com/office/drawing/2014/main" id="{17AFF28D-5B92-47A9-9D71-7200F619647A}"/>
+                <a16:creationId xmlns:a16="http://schemas.microsoft.com/office/drawing/2014/main" id="{8164D85F-6FFA-4AB7-A5D5-F55D9653A4CD}"/>
               </a:ext>
             </a:extLst>
           </p:cNvPr>
@@ -12748,7 +12805,7 @@
           <p:cNvPr id="6" name="">
             <a:extLst xmlns:a="http://schemas.openxmlformats.org/drawingml/2006/main">
               <a:ext uri="{FF2B5EF4-FFF2-40B4-BE49-F238E27FC236}">
-                <a16:creationId xmlns:a16="http://schemas.microsoft.com/office/drawing/2014/main" id="{63FB0D1F-8010-418F-9298-EFFC85FFAC91}"/>
+                <a16:creationId xmlns:a16="http://schemas.microsoft.com/office/drawing/2014/main" id="{7F49C819-138F-403B-A0A6-27443E33EE5C}"/>
               </a:ext>
             </a:extLst>
           </p:cNvPr>
@@ -12805,7 +12862,7 @@
           <p:cNvPr id="7" name="">
             <a:extLst xmlns:a="http://schemas.openxmlformats.org/drawingml/2006/main">
               <a:ext uri="{FF2B5EF4-FFF2-40B4-BE49-F238E27FC236}">
-                <a16:creationId xmlns:a16="http://schemas.microsoft.com/office/drawing/2014/main" id="{9F08A37C-A66A-410B-89EC-72D3DB0657DF}"/>
+                <a16:creationId xmlns:a16="http://schemas.microsoft.com/office/drawing/2014/main" id="{03842C29-017C-4C25-802A-27C70F94A1B1}"/>
               </a:ext>
             </a:extLst>
           </p:cNvPr>
@@ -12862,7 +12919,7 @@
           <p:cNvPr id="8" name="">
             <a:extLst xmlns:a="http://schemas.openxmlformats.org/drawingml/2006/main">
               <a:ext uri="{FF2B5EF4-FFF2-40B4-BE49-F238E27FC236}">
-                <a16:creationId xmlns:a16="http://schemas.microsoft.com/office/drawing/2014/main" id="{FD01C82F-CE07-4F19-92D5-42C0DE3C0736}"/>
+                <a16:creationId xmlns:a16="http://schemas.microsoft.com/office/drawing/2014/main" id="{401F06D3-2F41-47C2-A301-4F000F9FA150}"/>
               </a:ext>
             </a:extLst>
           </p:cNvPr>
@@ -12919,7 +12976,7 @@
           <p:cNvPr id="9" name="">
             <a:extLst xmlns:a="http://schemas.openxmlformats.org/drawingml/2006/main">
               <a:ext uri="{FF2B5EF4-FFF2-40B4-BE49-F238E27FC236}">
-                <a16:creationId xmlns:a16="http://schemas.microsoft.com/office/drawing/2014/main" id="{781877AD-ED79-4EE2-929F-858237B9B351}"/>
+                <a16:creationId xmlns:a16="http://schemas.microsoft.com/office/drawing/2014/main" id="{FC1E5667-0F59-47F2-8A65-D713C47FB65F}"/>
               </a:ext>
             </a:extLst>
           </p:cNvPr>
@@ -12954,7 +13011,7 @@
           <p:cNvPr id="10" name="">
             <a:extLst xmlns:a="http://schemas.openxmlformats.org/drawingml/2006/main">
               <a:ext uri="{FF2B5EF4-FFF2-40B4-BE49-F238E27FC236}">
-                <a16:creationId xmlns:a16="http://schemas.microsoft.com/office/drawing/2014/main" id="{25853231-30F6-48C2-90AF-909BCE1FF9BD}"/>
+                <a16:creationId xmlns:a16="http://schemas.microsoft.com/office/drawing/2014/main" id="{175C16E0-5DDA-4F62-948C-D556BE3F9EB7}"/>
               </a:ext>
             </a:extLst>
           </p:cNvPr>
@@ -12989,7 +13046,7 @@
           <p:cNvPr id="11" name="">
             <a:extLst xmlns:a="http://schemas.openxmlformats.org/drawingml/2006/main">
               <a:ext uri="{FF2B5EF4-FFF2-40B4-BE49-F238E27FC236}">
-                <a16:creationId xmlns:a16="http://schemas.microsoft.com/office/drawing/2014/main" id="{941F376A-4BA4-4D24-BF49-DE04EF80CCA5}"/>
+                <a16:creationId xmlns:a16="http://schemas.microsoft.com/office/drawing/2014/main" id="{FF2F5A16-1FFB-4808-BE85-127ABCFCB3E2}"/>
               </a:ext>
             </a:extLst>
           </p:cNvPr>
@@ -13024,7 +13081,7 @@
           <p:cNvPr id="12" name="">
             <a:extLst xmlns:a="http://schemas.openxmlformats.org/drawingml/2006/main">
               <a:ext uri="{FF2B5EF4-FFF2-40B4-BE49-F238E27FC236}">
-                <a16:creationId xmlns:a16="http://schemas.microsoft.com/office/drawing/2014/main" id="{77DEAC49-FD07-4D9B-BDBB-755B4B55837B}"/>
+                <a16:creationId xmlns:a16="http://schemas.microsoft.com/office/drawing/2014/main" id="{D8F3FF02-30D3-4491-B177-591E7707AD6C}"/>
               </a:ext>
             </a:extLst>
           </p:cNvPr>
@@ -13081,7 +13138,7 @@
           <p:cNvPr id="13" name="">
             <a:extLst xmlns:a="http://schemas.openxmlformats.org/drawingml/2006/main">
               <a:ext uri="{FF2B5EF4-FFF2-40B4-BE49-F238E27FC236}">
-                <a16:creationId xmlns:a16="http://schemas.microsoft.com/office/drawing/2014/main" id="{D8BD0262-DC39-4FDC-9A87-FD4F2F0AE5FA}"/>
+                <a16:creationId xmlns:a16="http://schemas.microsoft.com/office/drawing/2014/main" id="{075728B4-C773-4F98-B348-0A4DD00C2DD0}"/>
               </a:ext>
             </a:extLst>
           </p:cNvPr>
@@ -13138,7 +13195,7 @@
           <p:cNvPr id="14" name="">
             <a:extLst xmlns:a="http://schemas.openxmlformats.org/drawingml/2006/main">
               <a:ext uri="{FF2B5EF4-FFF2-40B4-BE49-F238E27FC236}">
-                <a16:creationId xmlns:a16="http://schemas.microsoft.com/office/drawing/2014/main" id="{BB83156A-60E2-484D-85E1-1BDFD4A59269}"/>
+                <a16:creationId xmlns:a16="http://schemas.microsoft.com/office/drawing/2014/main" id="{E201A325-0446-429C-87D4-CC89A9738A47}"/>
               </a:ext>
             </a:extLst>
           </p:cNvPr>
@@ -13195,7 +13252,7 @@
           <p:cNvPr id="15" name="">
             <a:extLst xmlns:a="http://schemas.openxmlformats.org/drawingml/2006/main">
               <a:ext uri="{FF2B5EF4-FFF2-40B4-BE49-F238E27FC236}">
-                <a16:creationId xmlns:a16="http://schemas.microsoft.com/office/drawing/2014/main" id="{4B36D996-72E7-4B93-8550-30BCE3C7811C}"/>
+                <a16:creationId xmlns:a16="http://schemas.microsoft.com/office/drawing/2014/main" id="{ED579B21-33CC-40AE-A44D-FA5F2E665EAC}"/>
               </a:ext>
             </a:extLst>
           </p:cNvPr>
@@ -13230,7 +13287,7 @@
           <p:cNvPr id="16" name="">
             <a:extLst xmlns:a="http://schemas.openxmlformats.org/drawingml/2006/main">
               <a:ext uri="{FF2B5EF4-FFF2-40B4-BE49-F238E27FC236}">
-                <a16:creationId xmlns:a16="http://schemas.microsoft.com/office/drawing/2014/main" id="{C375D074-665A-46C5-9653-AF2E6FAAA3D7}"/>
+                <a16:creationId xmlns:a16="http://schemas.microsoft.com/office/drawing/2014/main" id="{045AC413-87B8-4949-AC19-777422614F0D}"/>
               </a:ext>
             </a:extLst>
           </p:cNvPr>
@@ -13265,7 +13322,7 @@
           <p:cNvPr id="17" name="">
             <a:extLst xmlns:a="http://schemas.openxmlformats.org/drawingml/2006/main">
               <a:ext uri="{FF2B5EF4-FFF2-40B4-BE49-F238E27FC236}">
-                <a16:creationId xmlns:a16="http://schemas.microsoft.com/office/drawing/2014/main" id="{99A8CE73-8771-444D-A641-8E60B8A1D6A9}"/>
+                <a16:creationId xmlns:a16="http://schemas.microsoft.com/office/drawing/2014/main" id="{F496BC31-94A6-4EFD-85A5-21E40A0B7C8D}"/>
               </a:ext>
             </a:extLst>
           </p:cNvPr>
@@ -13300,7 +13357,7 @@
           <p:cNvPr id="18" name="">
             <a:extLst xmlns:a="http://schemas.openxmlformats.org/drawingml/2006/main">
               <a:ext uri="{FF2B5EF4-FFF2-40B4-BE49-F238E27FC236}">
-                <a16:creationId xmlns:a16="http://schemas.microsoft.com/office/drawing/2014/main" id="{5E7DAB7C-86CC-46C7-8AC4-73908C3C8DAD}"/>
+                <a16:creationId xmlns:a16="http://schemas.microsoft.com/office/drawing/2014/main" id="{9CDD4DA5-7481-4863-8736-BF6EE66CA676}"/>
               </a:ext>
             </a:extLst>
           </p:cNvPr>
@@ -13357,7 +13414,7 @@
           <p:cNvPr id="19" name="">
             <a:extLst xmlns:a="http://schemas.openxmlformats.org/drawingml/2006/main">
               <a:ext uri="{FF2B5EF4-FFF2-40B4-BE49-F238E27FC236}">
-                <a16:creationId xmlns:a16="http://schemas.microsoft.com/office/drawing/2014/main" id="{4809BEFE-6F2E-49B7-BA92-6BFAF73337B8}"/>
+                <a16:creationId xmlns:a16="http://schemas.microsoft.com/office/drawing/2014/main" id="{AB7FDA15-DDD1-457D-A416-DDB4D3174552}"/>
               </a:ext>
             </a:extLst>
           </p:cNvPr>
@@ -13414,7 +13471,7 @@
           <p:cNvPr id="20" name="">
             <a:extLst xmlns:a="http://schemas.openxmlformats.org/drawingml/2006/main">
               <a:ext uri="{FF2B5EF4-FFF2-40B4-BE49-F238E27FC236}">
-                <a16:creationId xmlns:a16="http://schemas.microsoft.com/office/drawing/2014/main" id="{F20867EB-95D6-48DB-B66D-810051780E78}"/>
+                <a16:creationId xmlns:a16="http://schemas.microsoft.com/office/drawing/2014/main" id="{F3AA4664-7A5A-45E8-A28F-2DCD99BD9BE5}"/>
               </a:ext>
             </a:extLst>
           </p:cNvPr>
@@ -13471,7 +13528,7 @@
           <p:cNvPr id="21" name="">
             <a:extLst xmlns:a="http://schemas.openxmlformats.org/drawingml/2006/main">
               <a:ext uri="{FF2B5EF4-FFF2-40B4-BE49-F238E27FC236}">
-                <a16:creationId xmlns:a16="http://schemas.microsoft.com/office/drawing/2014/main" id="{4ECBC0AE-8FB6-46C5-A59B-22ADDB10E6DA}"/>
+                <a16:creationId xmlns:a16="http://schemas.microsoft.com/office/drawing/2014/main" id="{002AFE7B-3B28-4C97-A62C-C760248B8D7D}"/>
               </a:ext>
             </a:extLst>
           </p:cNvPr>
@@ -13506,7 +13563,7 @@
           <p:cNvPr id="22" name="">
             <a:extLst xmlns:a="http://schemas.openxmlformats.org/drawingml/2006/main">
               <a:ext uri="{FF2B5EF4-FFF2-40B4-BE49-F238E27FC236}">
-                <a16:creationId xmlns:a16="http://schemas.microsoft.com/office/drawing/2014/main" id="{BEB076D6-1800-4A3E-8636-CFA9A1FE44A3}"/>
+                <a16:creationId xmlns:a16="http://schemas.microsoft.com/office/drawing/2014/main" id="{67E6C76C-B505-456A-B146-486FF49C62D7}"/>
               </a:ext>
             </a:extLst>
           </p:cNvPr>
@@ -13541,7 +13598,7 @@
           <p:cNvPr id="23" name="">
             <a:extLst xmlns:a="http://schemas.openxmlformats.org/drawingml/2006/main">
               <a:ext uri="{FF2B5EF4-FFF2-40B4-BE49-F238E27FC236}">
-                <a16:creationId xmlns:a16="http://schemas.microsoft.com/office/drawing/2014/main" id="{6A97FB15-71EB-4345-B83C-A1D44C188A2E}"/>
+                <a16:creationId xmlns:a16="http://schemas.microsoft.com/office/drawing/2014/main" id="{3A614B08-8FB1-463C-9810-1AFD96976849}"/>
               </a:ext>
             </a:extLst>
           </p:cNvPr>
@@ -13576,7 +13633,7 @@
           <p:cNvPr id="24" name="">
             <a:extLst xmlns:a="http://schemas.openxmlformats.org/drawingml/2006/main">
               <a:ext uri="{FF2B5EF4-FFF2-40B4-BE49-F238E27FC236}">
-                <a16:creationId xmlns:a16="http://schemas.microsoft.com/office/drawing/2014/main" id="{8435D0C4-C387-4463-A1B3-FE02264B6655}"/>
+                <a16:creationId xmlns:a16="http://schemas.microsoft.com/office/drawing/2014/main" id="{BEF182CF-E5A4-45FB-B9FD-143C0DBDB2F0}"/>
               </a:ext>
             </a:extLst>
           </p:cNvPr>
@@ -13633,7 +13690,7 @@
           <p:cNvPr id="25" name="">
             <a:extLst xmlns:a="http://schemas.openxmlformats.org/drawingml/2006/main">
               <a:ext uri="{FF2B5EF4-FFF2-40B4-BE49-F238E27FC236}">
-                <a16:creationId xmlns:a16="http://schemas.microsoft.com/office/drawing/2014/main" id="{C0A9426D-C460-4859-A69A-C4C50AF70A9B}"/>
+                <a16:creationId xmlns:a16="http://schemas.microsoft.com/office/drawing/2014/main" id="{669AD8D3-E6DD-499E-B92C-1FFF6D9DD051}"/>
               </a:ext>
             </a:extLst>
           </p:cNvPr>
@@ -13690,7 +13747,7 @@
           <p:cNvPr id="26" name="">
             <a:extLst xmlns:a="http://schemas.openxmlformats.org/drawingml/2006/main">
               <a:ext uri="{FF2B5EF4-FFF2-40B4-BE49-F238E27FC236}">
-                <a16:creationId xmlns:a16="http://schemas.microsoft.com/office/drawing/2014/main" id="{FF18B8DB-C968-4538-9965-9597BA1A1A93}"/>
+                <a16:creationId xmlns:a16="http://schemas.microsoft.com/office/drawing/2014/main" id="{CAD0194E-42AE-4698-A91C-31CBC7FCC4A3}"/>
               </a:ext>
             </a:extLst>
           </p:cNvPr>
@@ -13747,7 +13804,7 @@
           <p:cNvPr id="27" name="">
             <a:extLst xmlns:a="http://schemas.openxmlformats.org/drawingml/2006/main">
               <a:ext uri="{FF2B5EF4-FFF2-40B4-BE49-F238E27FC236}">
-                <a16:creationId xmlns:a16="http://schemas.microsoft.com/office/drawing/2014/main" id="{E3E1273A-7B3F-42E5-96CE-A0D0989DC739}"/>
+                <a16:creationId xmlns:a16="http://schemas.microsoft.com/office/drawing/2014/main" id="{28BFE789-F3EA-4D8F-AB46-4E4987210A33}"/>
               </a:ext>
             </a:extLst>
           </p:cNvPr>
@@ -13782,7 +13839,7 @@
           <p:cNvPr id="28" name="">
             <a:extLst xmlns:a="http://schemas.openxmlformats.org/drawingml/2006/main">
               <a:ext uri="{FF2B5EF4-FFF2-40B4-BE49-F238E27FC236}">
-                <a16:creationId xmlns:a16="http://schemas.microsoft.com/office/drawing/2014/main" id="{CE993C76-F03F-4291-9009-E9849B22FF8B}"/>
+                <a16:creationId xmlns:a16="http://schemas.microsoft.com/office/drawing/2014/main" id="{B8B93B59-005F-4E89-9A01-48AA16FA0656}"/>
               </a:ext>
             </a:extLst>
           </p:cNvPr>
@@ -13817,7 +13874,7 @@
           <p:cNvPr id="29" name="">
             <a:extLst xmlns:a="http://schemas.openxmlformats.org/drawingml/2006/main">
               <a:ext uri="{FF2B5EF4-FFF2-40B4-BE49-F238E27FC236}">
-                <a16:creationId xmlns:a16="http://schemas.microsoft.com/office/drawing/2014/main" id="{370F3FC1-F523-499E-BC3C-D75DD2959E35}"/>
+                <a16:creationId xmlns:a16="http://schemas.microsoft.com/office/drawing/2014/main" id="{B0A27065-FA6E-458D-9FDC-32506D72ED0C}"/>
               </a:ext>
             </a:extLst>
           </p:cNvPr>
@@ -13852,7 +13909,7 @@
           <p:cNvPr id="30" name="">
             <a:extLst xmlns:a="http://schemas.openxmlformats.org/drawingml/2006/main">
               <a:ext uri="{FF2B5EF4-FFF2-40B4-BE49-F238E27FC236}">
-                <a16:creationId xmlns:a16="http://schemas.microsoft.com/office/drawing/2014/main" id="{60F27949-38AA-4EA6-AE4B-DB49071A9E02}"/>
+                <a16:creationId xmlns:a16="http://schemas.microsoft.com/office/drawing/2014/main" id="{B7B553B8-28CB-4178-8F92-0267B832622E}"/>
               </a:ext>
             </a:extLst>
           </p:cNvPr>
@@ -13909,7 +13966,7 @@
           <p:cNvPr id="31" name="">
             <a:extLst xmlns:a="http://schemas.openxmlformats.org/drawingml/2006/main">
               <a:ext uri="{FF2B5EF4-FFF2-40B4-BE49-F238E27FC236}">
-                <a16:creationId xmlns:a16="http://schemas.microsoft.com/office/drawing/2014/main" id="{592FF0F0-E924-4374-AC53-CBD51F305967}"/>
+                <a16:creationId xmlns:a16="http://schemas.microsoft.com/office/drawing/2014/main" id="{C008DE13-FB34-4A0B-B53D-56E152E73EF1}"/>
               </a:ext>
             </a:extLst>
           </p:cNvPr>
@@ -13966,7 +14023,7 @@
           <p:cNvPr id="32" name="">
             <a:extLst xmlns:a="http://schemas.openxmlformats.org/drawingml/2006/main">
               <a:ext uri="{FF2B5EF4-FFF2-40B4-BE49-F238E27FC236}">
-                <a16:creationId xmlns:a16="http://schemas.microsoft.com/office/drawing/2014/main" id="{433831F0-3358-4157-83E3-63F8D5311EAC}"/>
+                <a16:creationId xmlns:a16="http://schemas.microsoft.com/office/drawing/2014/main" id="{4CD94E1B-F730-4122-9B29-C697D23A8B3B}"/>
               </a:ext>
             </a:extLst>
           </p:cNvPr>
@@ -14023,7 +14080,7 @@
           <p:cNvPr id="33" name="">
             <a:extLst xmlns:a="http://schemas.openxmlformats.org/drawingml/2006/main">
               <a:ext uri="{FF2B5EF4-FFF2-40B4-BE49-F238E27FC236}">
-                <a16:creationId xmlns:a16="http://schemas.microsoft.com/office/drawing/2014/main" id="{25D093E0-3D36-453C-9C4E-9CD39E1DE4A3}"/>
+                <a16:creationId xmlns:a16="http://schemas.microsoft.com/office/drawing/2014/main" id="{933DBE73-56E5-4CEE-BDB0-D4D50F9C4260}"/>
               </a:ext>
             </a:extLst>
           </p:cNvPr>
@@ -14058,7 +14115,7 @@
           <p:cNvPr id="34" name="">
             <a:extLst xmlns:a="http://schemas.openxmlformats.org/drawingml/2006/main">
               <a:ext uri="{FF2B5EF4-FFF2-40B4-BE49-F238E27FC236}">
-                <a16:creationId xmlns:a16="http://schemas.microsoft.com/office/drawing/2014/main" id="{2AC30546-D0D0-49E0-969D-AB3892FE11B0}"/>
+                <a16:creationId xmlns:a16="http://schemas.microsoft.com/office/drawing/2014/main" id="{A574B410-C452-4E73-9954-4FEA7CF26804}"/>
               </a:ext>
             </a:extLst>
           </p:cNvPr>
@@ -14093,7 +14150,7 @@
           <p:cNvPr id="35" name="">
             <a:extLst xmlns:a="http://schemas.openxmlformats.org/drawingml/2006/main">
               <a:ext uri="{FF2B5EF4-FFF2-40B4-BE49-F238E27FC236}">
-                <a16:creationId xmlns:a16="http://schemas.microsoft.com/office/drawing/2014/main" id="{D4515DA2-BE93-496B-99B3-436F72DABF3A}"/>
+                <a16:creationId xmlns:a16="http://schemas.microsoft.com/office/drawing/2014/main" id="{7C79090F-1215-4230-AC61-EBCCFA3EA79B}"/>
               </a:ext>
             </a:extLst>
           </p:cNvPr>
@@ -14128,7 +14185,7 @@
           <p:cNvPr id="36" name="">
             <a:extLst xmlns:a="http://schemas.openxmlformats.org/drawingml/2006/main">
               <a:ext uri="{FF2B5EF4-FFF2-40B4-BE49-F238E27FC236}">
-                <a16:creationId xmlns:a16="http://schemas.microsoft.com/office/drawing/2014/main" id="{D8C827D9-528C-4259-9BD1-142152115B5D}"/>
+                <a16:creationId xmlns:a16="http://schemas.microsoft.com/office/drawing/2014/main" id="{34A74B7F-41C1-44B0-BA57-0B65CAB70447}"/>
               </a:ext>
             </a:extLst>
           </p:cNvPr>
@@ -14185,7 +14242,7 @@
           <p:cNvPr id="37" name="">
             <a:extLst xmlns:a="http://schemas.openxmlformats.org/drawingml/2006/main">
               <a:ext uri="{FF2B5EF4-FFF2-40B4-BE49-F238E27FC236}">
-                <a16:creationId xmlns:a16="http://schemas.microsoft.com/office/drawing/2014/main" id="{7F188D08-9209-4DF2-B334-DB4D6028DD97}"/>
+                <a16:creationId xmlns:a16="http://schemas.microsoft.com/office/drawing/2014/main" id="{D5753302-94D0-4F68-B9BE-A3C55098ED47}"/>
               </a:ext>
             </a:extLst>
           </p:cNvPr>
@@ -14242,7 +14299,7 @@
           <p:cNvPr id="38" name="">
             <a:extLst xmlns:a="http://schemas.openxmlformats.org/drawingml/2006/main">
               <a:ext uri="{FF2B5EF4-FFF2-40B4-BE49-F238E27FC236}">
-                <a16:creationId xmlns:a16="http://schemas.microsoft.com/office/drawing/2014/main" id="{09925A43-503E-4152-A3C9-153206D42980}"/>
+                <a16:creationId xmlns:a16="http://schemas.microsoft.com/office/drawing/2014/main" id="{F5C16DC3-F04E-423D-954F-522D5213B8A7}"/>
               </a:ext>
             </a:extLst>
           </p:cNvPr>
@@ -14297,7 +14354,7 @@
     </p:spTree>
     <p:extLst>
       <p:ext uri="{BB962C8B-B14F-4D97-AF65-F5344CB8AC3E}">
-        <p14:creationId xmlns:p14="http://schemas.microsoft.com/office/powerpoint/2010/main" val="583371789"/>
+        <p14:creationId xmlns:p14="http://schemas.microsoft.com/office/powerpoint/2010/main" val="1998164316"/>
       </p:ext>
     </p:extLst>
   </p:cSld>
@@ -14328,7 +14385,7 @@
           <p:cNvPr id="1" name="kicker-marker">
             <a:extLst xmlns:a="http://schemas.openxmlformats.org/drawingml/2006/main">
               <a:ext uri="{FF2B5EF4-FFF2-40B4-BE49-F238E27FC236}">
-                <a16:creationId xmlns:a16="http://schemas.microsoft.com/office/drawing/2014/main" id="{B0D699C8-8E01-4E66-A280-ED6774C2AF9B}"/>
+                <a16:creationId xmlns:a16="http://schemas.microsoft.com/office/drawing/2014/main" id="{A97D208D-FA6D-4F30-9F19-0A6F357E4F21}"/>
               </a:ext>
             </a:extLst>
           </p:cNvPr>
@@ -14363,7 +14420,7 @@
           <p:cNvPr id="2" name="kicker-label">
             <a:extLst xmlns:a="http://schemas.openxmlformats.org/drawingml/2006/main">
               <a:ext uri="{FF2B5EF4-FFF2-40B4-BE49-F238E27FC236}">
-                <a16:creationId xmlns:a16="http://schemas.microsoft.com/office/drawing/2014/main" id="{159CFC16-6D71-4E54-BAC1-3027B33BF7C0}"/>
+                <a16:creationId xmlns:a16="http://schemas.microsoft.com/office/drawing/2014/main" id="{7A8B8868-5AFF-4237-8288-E642D5A978B4}"/>
               </a:ext>
             </a:extLst>
           </p:cNvPr>
@@ -14420,7 +14477,7 @@
           <p:cNvPr id="3" name="">
             <a:extLst xmlns:a="http://schemas.openxmlformats.org/drawingml/2006/main">
               <a:ext uri="{FF2B5EF4-FFF2-40B4-BE49-F238E27FC236}">
-                <a16:creationId xmlns:a16="http://schemas.microsoft.com/office/drawing/2014/main" id="{0C41BD7E-0642-4E6A-B5D5-68A1EE7BA5F9}"/>
+                <a16:creationId xmlns:a16="http://schemas.microsoft.com/office/drawing/2014/main" id="{3476E3E6-2D6F-4151-BB91-85E68AEC95D1}"/>
               </a:ext>
             </a:extLst>
           </p:cNvPr>
@@ -14477,7 +14534,7 @@
           <p:cNvPr id="4" name="">
             <a:extLst xmlns:a="http://schemas.openxmlformats.org/drawingml/2006/main">
               <a:ext uri="{FF2B5EF4-FFF2-40B4-BE49-F238E27FC236}">
-                <a16:creationId xmlns:a16="http://schemas.microsoft.com/office/drawing/2014/main" id="{DF34B60A-74F1-4B67-8ABF-052FB7F62E6E}"/>
+                <a16:creationId xmlns:a16="http://schemas.microsoft.com/office/drawing/2014/main" id="{A691D33C-6B2F-4B5A-8747-D4D0A32424F9}"/>
               </a:ext>
             </a:extLst>
           </p:cNvPr>
@@ -14512,7 +14569,7 @@
           <p:cNvPr id="5" name="">
             <a:extLst xmlns:a="http://schemas.openxmlformats.org/drawingml/2006/main">
               <a:ext uri="{FF2B5EF4-FFF2-40B4-BE49-F238E27FC236}">
-                <a16:creationId xmlns:a16="http://schemas.microsoft.com/office/drawing/2014/main" id="{CDECAB7D-76D4-4B7E-BBDA-E4C8BA4BCAF9}"/>
+                <a16:creationId xmlns:a16="http://schemas.microsoft.com/office/drawing/2014/main" id="{BDDCC4A6-3374-42FF-9130-189DBEF0D8F3}"/>
               </a:ext>
             </a:extLst>
           </p:cNvPr>
@@ -14569,7 +14626,7 @@
           <p:cNvPr id="6" name="">
             <a:extLst xmlns:a="http://schemas.openxmlformats.org/drawingml/2006/main">
               <a:ext uri="{FF2B5EF4-FFF2-40B4-BE49-F238E27FC236}">
-                <a16:creationId xmlns:a16="http://schemas.microsoft.com/office/drawing/2014/main" id="{A622246F-D018-4353-B658-276F3495EEE2}"/>
+                <a16:creationId xmlns:a16="http://schemas.microsoft.com/office/drawing/2014/main" id="{D53299D2-A390-4902-8D18-59D1E0C9F4F3}"/>
               </a:ext>
             </a:extLst>
           </p:cNvPr>
@@ -14626,7 +14683,7 @@
           <p:cNvPr id="7" name="">
             <a:extLst xmlns:a="http://schemas.openxmlformats.org/drawingml/2006/main">
               <a:ext uri="{FF2B5EF4-FFF2-40B4-BE49-F238E27FC236}">
-                <a16:creationId xmlns:a16="http://schemas.microsoft.com/office/drawing/2014/main" id="{55AB10A8-4FAF-4A99-95C7-ADD140736794}"/>
+                <a16:creationId xmlns:a16="http://schemas.microsoft.com/office/drawing/2014/main" id="{373F3C85-1D29-4699-B96B-B1015787037D}"/>
               </a:ext>
             </a:extLst>
           </p:cNvPr>
@@ -14661,7 +14718,7 @@
           <p:cNvPr id="8" name="">
             <a:extLst xmlns:a="http://schemas.openxmlformats.org/drawingml/2006/main">
               <a:ext uri="{FF2B5EF4-FFF2-40B4-BE49-F238E27FC236}">
-                <a16:creationId xmlns:a16="http://schemas.microsoft.com/office/drawing/2014/main" id="{63450057-D802-452D-99EB-B6CA87BC26B7}"/>
+                <a16:creationId xmlns:a16="http://schemas.microsoft.com/office/drawing/2014/main" id="{3B01FF8C-898F-4F06-B888-8B5B4CC25D77}"/>
               </a:ext>
             </a:extLst>
           </p:cNvPr>
@@ -14718,7 +14775,7 @@
           <p:cNvPr id="9" name="">
             <a:extLst xmlns:a="http://schemas.openxmlformats.org/drawingml/2006/main">
               <a:ext uri="{FF2B5EF4-FFF2-40B4-BE49-F238E27FC236}">
-                <a16:creationId xmlns:a16="http://schemas.microsoft.com/office/drawing/2014/main" id="{E680B912-4F60-4CD8-85B6-40BE583AB94C}"/>
+                <a16:creationId xmlns:a16="http://schemas.microsoft.com/office/drawing/2014/main" id="{2ED262A8-FED2-4864-96A6-0C6E9AE99ABD}"/>
               </a:ext>
             </a:extLst>
           </p:cNvPr>
@@ -14775,7 +14832,7 @@
           <p:cNvPr id="10" name="">
             <a:extLst xmlns:a="http://schemas.openxmlformats.org/drawingml/2006/main">
               <a:ext uri="{FF2B5EF4-FFF2-40B4-BE49-F238E27FC236}">
-                <a16:creationId xmlns:a16="http://schemas.microsoft.com/office/drawing/2014/main" id="{2D23F736-4B9A-4FD1-96CB-CBC070615190}"/>
+                <a16:creationId xmlns:a16="http://schemas.microsoft.com/office/drawing/2014/main" id="{DD0227AF-466C-4EF4-99B8-F2707233B8A5}"/>
               </a:ext>
             </a:extLst>
           </p:cNvPr>
@@ -14810,7 +14867,7 @@
           <p:cNvPr id="11" name="">
             <a:extLst xmlns:a="http://schemas.openxmlformats.org/drawingml/2006/main">
               <a:ext uri="{FF2B5EF4-FFF2-40B4-BE49-F238E27FC236}">
-                <a16:creationId xmlns:a16="http://schemas.microsoft.com/office/drawing/2014/main" id="{68AA8BA3-6032-428B-BD5D-8381F8BEF457}"/>
+                <a16:creationId xmlns:a16="http://schemas.microsoft.com/office/drawing/2014/main" id="{5458409C-1D2A-4E34-97D4-2BB583ED07A6}"/>
               </a:ext>
             </a:extLst>
           </p:cNvPr>
@@ -14867,7 +14924,7 @@
           <p:cNvPr id="12" name="">
             <a:extLst xmlns:a="http://schemas.openxmlformats.org/drawingml/2006/main">
               <a:ext uri="{FF2B5EF4-FFF2-40B4-BE49-F238E27FC236}">
-                <a16:creationId xmlns:a16="http://schemas.microsoft.com/office/drawing/2014/main" id="{8496C99B-F03F-4A00-B217-CE9E692E1760}"/>
+                <a16:creationId xmlns:a16="http://schemas.microsoft.com/office/drawing/2014/main" id="{30C6E69B-9806-4146-BA31-E749900C0865}"/>
               </a:ext>
             </a:extLst>
           </p:cNvPr>
@@ -14924,7 +14981,7 @@
           <p:cNvPr id="13" name="">
             <a:extLst xmlns:a="http://schemas.openxmlformats.org/drawingml/2006/main">
               <a:ext uri="{FF2B5EF4-FFF2-40B4-BE49-F238E27FC236}">
-                <a16:creationId xmlns:a16="http://schemas.microsoft.com/office/drawing/2014/main" id="{D1F09F94-FC17-4F4C-B948-442172614CA4}"/>
+                <a16:creationId xmlns:a16="http://schemas.microsoft.com/office/drawing/2014/main" id="{6023D5E9-1D32-4097-A977-DAA1D1551836}"/>
               </a:ext>
             </a:extLst>
           </p:cNvPr>
@@ -14959,7 +15016,7 @@
           <p:cNvPr id="14" name="">
             <a:extLst xmlns:a="http://schemas.openxmlformats.org/drawingml/2006/main">
               <a:ext uri="{FF2B5EF4-FFF2-40B4-BE49-F238E27FC236}">
-                <a16:creationId xmlns:a16="http://schemas.microsoft.com/office/drawing/2014/main" id="{D967CAE0-7523-4482-B86D-809B48079CC5}"/>
+                <a16:creationId xmlns:a16="http://schemas.microsoft.com/office/drawing/2014/main" id="{42A8B9C3-57C2-47B6-B089-C89844B1A02C}"/>
               </a:ext>
             </a:extLst>
           </p:cNvPr>
@@ -15016,7 +15073,7 @@
           <p:cNvPr id="15" name="">
             <a:extLst xmlns:a="http://schemas.openxmlformats.org/drawingml/2006/main">
               <a:ext uri="{FF2B5EF4-FFF2-40B4-BE49-F238E27FC236}">
-                <a16:creationId xmlns:a16="http://schemas.microsoft.com/office/drawing/2014/main" id="{4692D728-27F8-4590-A9CE-95378965E914}"/>
+                <a16:creationId xmlns:a16="http://schemas.microsoft.com/office/drawing/2014/main" id="{2235ABE4-0197-4E0C-89FD-2CEB591C81E8}"/>
               </a:ext>
             </a:extLst>
           </p:cNvPr>
@@ -15073,7 +15130,7 @@
           <p:cNvPr id="16" name="">
             <a:extLst xmlns:a="http://schemas.openxmlformats.org/drawingml/2006/main">
               <a:ext uri="{FF2B5EF4-FFF2-40B4-BE49-F238E27FC236}">
-                <a16:creationId xmlns:a16="http://schemas.microsoft.com/office/drawing/2014/main" id="{1A0983D7-1729-4C38-A029-676137A8AE45}"/>
+                <a16:creationId xmlns:a16="http://schemas.microsoft.com/office/drawing/2014/main" id="{86A4F0C7-37F6-4A00-8A5F-06E5CDF09690}"/>
               </a:ext>
             </a:extLst>
           </p:cNvPr>
@@ -15108,7 +15165,7 @@
           <p:cNvPr id="17" name="">
             <a:extLst xmlns:a="http://schemas.openxmlformats.org/drawingml/2006/main">
               <a:ext uri="{FF2B5EF4-FFF2-40B4-BE49-F238E27FC236}">
-                <a16:creationId xmlns:a16="http://schemas.microsoft.com/office/drawing/2014/main" id="{8A4ADD1E-0FB7-4F8E-979E-95199B9AA339}"/>
+                <a16:creationId xmlns:a16="http://schemas.microsoft.com/office/drawing/2014/main" id="{69792559-9FA2-47C0-977A-EA238B542210}"/>
               </a:ext>
             </a:extLst>
           </p:cNvPr>
@@ -15165,7 +15222,7 @@
           <p:cNvPr id="18" name="">
             <a:extLst xmlns:a="http://schemas.openxmlformats.org/drawingml/2006/main">
               <a:ext uri="{FF2B5EF4-FFF2-40B4-BE49-F238E27FC236}">
-                <a16:creationId xmlns:a16="http://schemas.microsoft.com/office/drawing/2014/main" id="{0A0F33D6-FA7F-4878-B1B1-B6AA80F2A257}"/>
+                <a16:creationId xmlns:a16="http://schemas.microsoft.com/office/drawing/2014/main" id="{2AC1517F-9B03-4CED-9D74-4ECCCDB5CD17}"/>
               </a:ext>
             </a:extLst>
           </p:cNvPr>
@@ -15222,7 +15279,7 @@
           <p:cNvPr id="19" name="">
             <a:extLst xmlns:a="http://schemas.openxmlformats.org/drawingml/2006/main">
               <a:ext uri="{FF2B5EF4-FFF2-40B4-BE49-F238E27FC236}">
-                <a16:creationId xmlns:a16="http://schemas.microsoft.com/office/drawing/2014/main" id="{87A5A148-7AEF-4416-9E38-27F141E82A67}"/>
+                <a16:creationId xmlns:a16="http://schemas.microsoft.com/office/drawing/2014/main" id="{817CC679-C914-41A7-8DC0-30E41F79413A}"/>
               </a:ext>
             </a:extLst>
           </p:cNvPr>
@@ -15257,7 +15314,7 @@
           <p:cNvPr id="20" name="">
             <a:extLst xmlns:a="http://schemas.openxmlformats.org/drawingml/2006/main">
               <a:ext uri="{FF2B5EF4-FFF2-40B4-BE49-F238E27FC236}">
-                <a16:creationId xmlns:a16="http://schemas.microsoft.com/office/drawing/2014/main" id="{B96F1344-12B5-44BE-8B5B-06ACA5672BF0}"/>
+                <a16:creationId xmlns:a16="http://schemas.microsoft.com/office/drawing/2014/main" id="{5A39AD36-5F91-478D-B903-61C4435A1F4D}"/>
               </a:ext>
             </a:extLst>
           </p:cNvPr>
@@ -15341,7 +15398,7 @@
           <p:cNvPr id="21" name="">
             <a:extLst xmlns:a="http://schemas.openxmlformats.org/drawingml/2006/main">
               <a:ext uri="{FF2B5EF4-FFF2-40B4-BE49-F238E27FC236}">
-                <a16:creationId xmlns:a16="http://schemas.microsoft.com/office/drawing/2014/main" id="{EB4FEBB2-A593-4C46-8AE6-93592E7FC31D}"/>
+                <a16:creationId xmlns:a16="http://schemas.microsoft.com/office/drawing/2014/main" id="{8BF8233D-529E-4AD3-B22C-731965CFC92B}"/>
               </a:ext>
             </a:extLst>
           </p:cNvPr>
@@ -15425,7 +15482,7 @@
           <p:cNvPr id="22" name="">
             <a:extLst xmlns:a="http://schemas.openxmlformats.org/drawingml/2006/main">
               <a:ext uri="{FF2B5EF4-FFF2-40B4-BE49-F238E27FC236}">
-                <a16:creationId xmlns:a16="http://schemas.microsoft.com/office/drawing/2014/main" id="{05B2B054-43CF-43D5-8A71-595FDE8E3549}"/>
+                <a16:creationId xmlns:a16="http://schemas.microsoft.com/office/drawing/2014/main" id="{9079F705-8E7E-433F-AA11-7507B8A04485}"/>
               </a:ext>
             </a:extLst>
           </p:cNvPr>
@@ -15482,7 +15539,7 @@
           <p:cNvPr id="23" name="">
             <a:extLst xmlns:a="http://schemas.openxmlformats.org/drawingml/2006/main">
               <a:ext uri="{FF2B5EF4-FFF2-40B4-BE49-F238E27FC236}">
-                <a16:creationId xmlns:a16="http://schemas.microsoft.com/office/drawing/2014/main" id="{2E5CA8B7-D068-48F7-A5BC-FFED90E88C45}"/>
+                <a16:creationId xmlns:a16="http://schemas.microsoft.com/office/drawing/2014/main" id="{D54B08AA-3AEB-4080-9B32-5243E6E8AAFC}"/>
               </a:ext>
             </a:extLst>
           </p:cNvPr>
@@ -15537,7 +15594,7 @@
     </p:spTree>
     <p:extLst>
       <p:ext uri="{BB962C8B-B14F-4D97-AF65-F5344CB8AC3E}">
-        <p14:creationId xmlns:p14="http://schemas.microsoft.com/office/powerpoint/2010/main" val="1905276088"/>
+        <p14:creationId xmlns:p14="http://schemas.microsoft.com/office/powerpoint/2010/main" val="1189601620"/>
       </p:ext>
     </p:extLst>
   </p:cSld>

</xml_diff>